<commit_message>
docs: restore fund-flow audit demo focus
</commit_message>
<xml_diff>
--- a/deliverables/cross-border-audit-agent-class-demo.pptx
+++ b/deliverables/cross-border-audit-agent-class-demo.pptx
@@ -2,24 +2,24 @@
 <file path=ppt/presentation.xml><?xml version="1.0" encoding="utf-8"?>
 <p:presentation xmlns:p="http://schemas.openxmlformats.org/presentationml/2006/main">
   <p:sldMasterIdLst>
-    <p:sldMasterId xmlns:r="http://schemas.openxmlformats.org/officeDocument/2006/relationships" id="2147483648" r:id="Re37a2895ade0425f"/>
+    <p:sldMasterId xmlns:r="http://schemas.openxmlformats.org/officeDocument/2006/relationships" id="2147483648" r:id="R80585c91ed354bb5"/>
   </p:sldMasterIdLst>
   <p:notesMasterIdLst>
-    <p:notesMasterId xmlns:r="http://schemas.openxmlformats.org/officeDocument/2006/relationships" r:id="R1bf62449703f4534"/>
+    <p:notesMasterId xmlns:r="http://schemas.openxmlformats.org/officeDocument/2006/relationships" r:id="Rf3134bec1ab843e8"/>
   </p:notesMasterIdLst>
   <p:sldIdLst>
-    <p:sldId xmlns:r="http://schemas.openxmlformats.org/officeDocument/2006/relationships" id="256" r:id="Rfc0a47162b3f420f"/>
-    <p:sldId xmlns:r="http://schemas.openxmlformats.org/officeDocument/2006/relationships" id="257" r:id="R8786f2811d8b4b7d"/>
-    <p:sldId xmlns:r="http://schemas.openxmlformats.org/officeDocument/2006/relationships" id="258" r:id="Rd6440c9004ca46c1"/>
-    <p:sldId xmlns:r="http://schemas.openxmlformats.org/officeDocument/2006/relationships" id="259" r:id="Rafbdce2cb0674d88"/>
-    <p:sldId xmlns:r="http://schemas.openxmlformats.org/officeDocument/2006/relationships" id="260" r:id="R3f49013ce9644947"/>
-    <p:sldId xmlns:r="http://schemas.openxmlformats.org/officeDocument/2006/relationships" id="261" r:id="R37931e72f9ce4847"/>
-    <p:sldId xmlns:r="http://schemas.openxmlformats.org/officeDocument/2006/relationships" id="262" r:id="Rf39f224dbfc749f6"/>
-    <p:sldId xmlns:r="http://schemas.openxmlformats.org/officeDocument/2006/relationships" id="263" r:id="Rc8495787b50b4b4e"/>
-    <p:sldId xmlns:r="http://schemas.openxmlformats.org/officeDocument/2006/relationships" id="264" r:id="Rdefa6c9cff724b20"/>
-    <p:sldId xmlns:r="http://schemas.openxmlformats.org/officeDocument/2006/relationships" id="265" r:id="R4cc157d0f8dc491d"/>
-    <p:sldId xmlns:r="http://schemas.openxmlformats.org/officeDocument/2006/relationships" id="266" r:id="R6f2d7fb6c3f443ae"/>
-    <p:sldId xmlns:r="http://schemas.openxmlformats.org/officeDocument/2006/relationships" id="267" r:id="Rf9289a469cc744cd"/>
+    <p:sldId xmlns:r="http://schemas.openxmlformats.org/officeDocument/2006/relationships" id="256" r:id="R0bda7c5f0d534ce1"/>
+    <p:sldId xmlns:r="http://schemas.openxmlformats.org/officeDocument/2006/relationships" id="257" r:id="R6295e35440e34d2c"/>
+    <p:sldId xmlns:r="http://schemas.openxmlformats.org/officeDocument/2006/relationships" id="258" r:id="Rc801c53f8edc44fb"/>
+    <p:sldId xmlns:r="http://schemas.openxmlformats.org/officeDocument/2006/relationships" id="259" r:id="R7ca082865813405c"/>
+    <p:sldId xmlns:r="http://schemas.openxmlformats.org/officeDocument/2006/relationships" id="260" r:id="R17082b02e47a47f6"/>
+    <p:sldId xmlns:r="http://schemas.openxmlformats.org/officeDocument/2006/relationships" id="261" r:id="Rf1e4e75a8da84aa1"/>
+    <p:sldId xmlns:r="http://schemas.openxmlformats.org/officeDocument/2006/relationships" id="262" r:id="R4fbd9030d00f49b7"/>
+    <p:sldId xmlns:r="http://schemas.openxmlformats.org/officeDocument/2006/relationships" id="263" r:id="Rc774dcce1b1a4b6a"/>
+    <p:sldId xmlns:r="http://schemas.openxmlformats.org/officeDocument/2006/relationships" id="264" r:id="R4d5a6bb3b4c04e1a"/>
+    <p:sldId xmlns:r="http://schemas.openxmlformats.org/officeDocument/2006/relationships" id="265" r:id="Rc6dc6641c48d4cc3"/>
+    <p:sldId xmlns:r="http://schemas.openxmlformats.org/officeDocument/2006/relationships" id="266" r:id="Ra70868d92fb349ed"/>
+    <p:sldId xmlns:r="http://schemas.openxmlformats.org/officeDocument/2006/relationships" id="267" r:id="R8bee6f4cd2964fe7"/>
   </p:sldIdLst>
   <p:sldSz cx="12192000" cy="6858000"/>
   <p:notesSz cx="6858000" cy="9144000"/>
@@ -1292,7 +1292,7 @@
   </p:cSld>
   <p:clrMap bg1="lt1" tx1="dk1" bg2="lt2" tx2="dk2" accent1="accent1" accent2="accent2" accent3="accent3" accent4="accent4" accent5="accent5" accent6="accent6" hlink="hlink" folHlink="folHlink"/>
   <p:sldLayoutIdLst>
-    <p:sldLayoutId xmlns:r="http://schemas.openxmlformats.org/officeDocument/2006/relationships" id="2147483649" r:id="Ra13dcd485d664590"/>
+    <p:sldLayoutId xmlns:r="http://schemas.openxmlformats.org/officeDocument/2006/relationships" id="2147483649" r:id="Re59ccf0f053c4b66"/>
   </p:sldLayoutIdLst>
   <p:txStyles>
     <p:titleStyle>
@@ -1790,7 +1790,7 @@
           <p:cNvPr id="1" name="">
             <a:extLst xmlns:a="http://schemas.openxmlformats.org/drawingml/2006/main">
               <a:ext uri="{FF2B5EF4-FFF2-40B4-BE49-F238E27FC236}">
-                <a16:creationId xmlns:a16="http://schemas.microsoft.com/office/drawing/2014/main" id="{2D3BD3A7-29C0-40A3-802A-814605CF220C}"/>
+                <a16:creationId xmlns:a16="http://schemas.microsoft.com/office/drawing/2014/main" id="{FFCDC69F-F377-4C4E-B368-EC811B47022E}"/>
               </a:ext>
             </a:extLst>
           </p:cNvPr>
@@ -1829,7 +1829,7 @@
           <p:nvPr/>
         </p:nvPicPr>
         <p:blipFill>
-          <a:blip xmlns:r="http://schemas.openxmlformats.org/officeDocument/2006/relationships" xmlns:a="http://schemas.openxmlformats.org/drawingml/2006/main" r:embed="R4d734ffc43654827"/>
+          <a:blip xmlns:r="http://schemas.openxmlformats.org/officeDocument/2006/relationships" xmlns:a="http://schemas.openxmlformats.org/drawingml/2006/main" r:embed="Ra7029f3193da45d3"/>
           <a:stretch xmlns:a="http://schemas.openxmlformats.org/drawingml/2006/main"/>
         </p:blipFill>
         <p:spPr>
@@ -1847,7 +1847,7 @@
           <p:cNvPr id="3" name="">
             <a:extLst xmlns:a="http://schemas.openxmlformats.org/drawingml/2006/main">
               <a:ext uri="{FF2B5EF4-FFF2-40B4-BE49-F238E27FC236}">
-                <a16:creationId xmlns:a16="http://schemas.microsoft.com/office/drawing/2014/main" id="{CE821CD9-9907-41BA-9F2A-4FA6EF8B312A}"/>
+                <a16:creationId xmlns:a16="http://schemas.microsoft.com/office/drawing/2014/main" id="{92A8737F-A32F-470C-B229-5DD225798E26}"/>
               </a:ext>
             </a:extLst>
           </p:cNvPr>
@@ -1883,7 +1883,7 @@
           <a:lstStyle xmlns:a="http://schemas.openxmlformats.org/drawingml/2006/main"/>
           <a:p xmlns:a="http://schemas.openxmlformats.org/drawingml/2006/main">
             <a:pPr algn="l">
-              <a:defRPr sz="2700" b="1">
+              <a:defRPr sz="2850" b="1">
                 <a:solidFill>
                   <a:srgbClr val="FFFFFF"/>
                 </a:solidFill>
@@ -1893,7 +1893,7 @@
               </a:defRPr>
             </a:pPr>
             <a:r>
-              <a:rPr sz="2700" b="1">
+              <a:rPr sz="2850" b="1">
                 <a:solidFill>
                   <a:srgbClr val="FFFFFF"/>
                 </a:solidFill>
@@ -1901,7 +1901,7 @@
                 <a:ea typeface="Microsoft YaHei"/>
                 <a:cs typeface="Microsoft YaHei"/>
               </a:rPr>
-              <a:t>可信财务 AI：把 Agent 关进确定性流程</a:t>
+              <a:t>跨境电商资金流 AI 审计系统</a:t>
             </a:r>
           </a:p>
         </p:txBody>
@@ -1911,7 +1911,7 @@
           <p:cNvPr id="4" name="">
             <a:extLst xmlns:a="http://schemas.openxmlformats.org/drawingml/2006/main">
               <a:ext uri="{FF2B5EF4-FFF2-40B4-BE49-F238E27FC236}">
-                <a16:creationId xmlns:a16="http://schemas.microsoft.com/office/drawing/2014/main" id="{43B9D64A-0A75-41E8-8440-A00A3D7BD4D7}"/>
+                <a16:creationId xmlns:a16="http://schemas.microsoft.com/office/drawing/2014/main" id="{4E6F5FE4-4494-4F8E-9541-3997791FBC82}"/>
               </a:ext>
             </a:extLst>
           </p:cNvPr>
@@ -1975,7 +1975,7 @@
           <p:cNvPr id="5" name="">
             <a:extLst xmlns:a="http://schemas.openxmlformats.org/drawingml/2006/main">
               <a:ext uri="{FF2B5EF4-FFF2-40B4-BE49-F238E27FC236}">
-                <a16:creationId xmlns:a16="http://schemas.microsoft.com/office/drawing/2014/main" id="{F582FA52-55CB-49C7-9344-9EC3128FE432}"/>
+                <a16:creationId xmlns:a16="http://schemas.microsoft.com/office/drawing/2014/main" id="{517634E2-5531-4768-87C9-BCE6D1ED447B}"/>
               </a:ext>
             </a:extLst>
           </p:cNvPr>
@@ -2008,7 +2008,7 @@
           <p:cNvPr id="6" name="">
             <a:extLst xmlns:a="http://schemas.openxmlformats.org/drawingml/2006/main">
               <a:ext uri="{FF2B5EF4-FFF2-40B4-BE49-F238E27FC236}">
-                <a16:creationId xmlns:a16="http://schemas.microsoft.com/office/drawing/2014/main" id="{6F1472B3-0178-4329-9E51-4F99A694518C}"/>
+                <a16:creationId xmlns:a16="http://schemas.microsoft.com/office/drawing/2014/main" id="{C48EF953-4E38-4020-A056-039B0AED2FE3}"/>
               </a:ext>
             </a:extLst>
           </p:cNvPr>
@@ -2072,7 +2072,7 @@
           <p:cNvPr id="7" name="">
             <a:extLst xmlns:a="http://schemas.openxmlformats.org/drawingml/2006/main">
               <a:ext uri="{FF2B5EF4-FFF2-40B4-BE49-F238E27FC236}">
-                <a16:creationId xmlns:a16="http://schemas.microsoft.com/office/drawing/2014/main" id="{B7892933-BEB0-4FC9-8DD9-12F7851A6F25}"/>
+                <a16:creationId xmlns:a16="http://schemas.microsoft.com/office/drawing/2014/main" id="{D281F253-BE37-4B3D-842B-6AA24D1D00B6}"/>
               </a:ext>
             </a:extLst>
           </p:cNvPr>
@@ -2136,7 +2136,7 @@
           <p:cNvPr id="8" name="">
             <a:extLst xmlns:a="http://schemas.openxmlformats.org/drawingml/2006/main">
               <a:ext uri="{FF2B5EF4-FFF2-40B4-BE49-F238E27FC236}">
-                <a16:creationId xmlns:a16="http://schemas.microsoft.com/office/drawing/2014/main" id="{BA9E9F63-7164-45FE-AFCA-2CBAF6AF3599}"/>
+                <a16:creationId xmlns:a16="http://schemas.microsoft.com/office/drawing/2014/main" id="{C1BEBCD2-19C0-4BC9-A210-7E47544C5FE5}"/>
               </a:ext>
             </a:extLst>
           </p:cNvPr>
@@ -2169,7 +2169,7 @@
           <p:cNvPr id="9" name="">
             <a:extLst xmlns:a="http://schemas.openxmlformats.org/drawingml/2006/main">
               <a:ext uri="{FF2B5EF4-FFF2-40B4-BE49-F238E27FC236}">
-                <a16:creationId xmlns:a16="http://schemas.microsoft.com/office/drawing/2014/main" id="{4FA970FB-1983-4BE1-B7EB-14F8847F0038}"/>
+                <a16:creationId xmlns:a16="http://schemas.microsoft.com/office/drawing/2014/main" id="{F4926A95-E684-4F45-8FC7-213813DF02E6}"/>
               </a:ext>
             </a:extLst>
           </p:cNvPr>
@@ -2233,7 +2233,7 @@
           <p:cNvPr id="10" name="">
             <a:extLst xmlns:a="http://schemas.openxmlformats.org/drawingml/2006/main">
               <a:ext uri="{FF2B5EF4-FFF2-40B4-BE49-F238E27FC236}">
-                <a16:creationId xmlns:a16="http://schemas.microsoft.com/office/drawing/2014/main" id="{042601A2-AB55-48D5-A5B4-F4D687750872}"/>
+                <a16:creationId xmlns:a16="http://schemas.microsoft.com/office/drawing/2014/main" id="{F4DD419E-585E-49C8-BBC9-DC5F3BB9A300}"/>
               </a:ext>
             </a:extLst>
           </p:cNvPr>
@@ -2266,7 +2266,7 @@
           <p:cNvPr id="11" name="">
             <a:extLst xmlns:a="http://schemas.openxmlformats.org/drawingml/2006/main">
               <a:ext uri="{FF2B5EF4-FFF2-40B4-BE49-F238E27FC236}">
-                <a16:creationId xmlns:a16="http://schemas.microsoft.com/office/drawing/2014/main" id="{AE3DC0B2-812A-4230-8677-A4897DCC3932}"/>
+                <a16:creationId xmlns:a16="http://schemas.microsoft.com/office/drawing/2014/main" id="{7076028E-BA13-4E9C-8DCD-AEBAD3BCEC0C}"/>
               </a:ext>
             </a:extLst>
           </p:cNvPr>
@@ -2330,7 +2330,7 @@
           <p:cNvPr id="12" name="">
             <a:extLst xmlns:a="http://schemas.openxmlformats.org/drawingml/2006/main">
               <a:ext uri="{FF2B5EF4-FFF2-40B4-BE49-F238E27FC236}">
-                <a16:creationId xmlns:a16="http://schemas.microsoft.com/office/drawing/2014/main" id="{6FD840C4-FAF0-4D40-BD83-FF5686D6DA48}"/>
+                <a16:creationId xmlns:a16="http://schemas.microsoft.com/office/drawing/2014/main" id="{39120EB3-76DA-449F-9B22-19952CDB4357}"/>
               </a:ext>
             </a:extLst>
           </p:cNvPr>
@@ -2384,7 +2384,7 @@
                 <a:ea typeface="Microsoft YaHei"/>
                 <a:cs typeface="Microsoft YaHei"/>
               </a:rPr>
-              <a:t>开场先演示收敛后的底稿生成，再回到一个更真实的问题：为什么最初那个多 Agent 虽然能跑，但还不能被审计人员信任。</a:t>
+              <a:t>开场先演示资金流审计流水线：自动生成演示数据、执行规则扫描、调用 DeepSeek/离线分析，并输出风险发现和审计报告。</a:t>
             </a:r>
           </a:p>
         </p:txBody>
@@ -2394,7 +2394,7 @@
           <p:cNvPr id="13" name="">
             <a:extLst xmlns:a="http://schemas.openxmlformats.org/drawingml/2006/main">
               <a:ext uri="{FF2B5EF4-FFF2-40B4-BE49-F238E27FC236}">
-                <a16:creationId xmlns:a16="http://schemas.microsoft.com/office/drawing/2014/main" id="{FC654584-4BF9-4A81-B885-E80E1AAF86AA}"/>
+                <a16:creationId xmlns:a16="http://schemas.microsoft.com/office/drawing/2014/main" id="{665FA04E-5489-4E81-9C7B-82BB0FEE410A}"/>
               </a:ext>
             </a:extLst>
           </p:cNvPr>
@@ -2458,7 +2458,7 @@
           <p:cNvPr id="14" name="">
             <a:extLst xmlns:a="http://schemas.openxmlformats.org/drawingml/2006/main">
               <a:ext uri="{FF2B5EF4-FFF2-40B4-BE49-F238E27FC236}">
-                <a16:creationId xmlns:a16="http://schemas.microsoft.com/office/drawing/2014/main" id="{9C3FB038-7C39-412D-BD16-1367E8BF3341}"/>
+                <a16:creationId xmlns:a16="http://schemas.microsoft.com/office/drawing/2014/main" id="{F589C3B4-1A9D-44CB-9B51-E79B5F76EBF9}"/>
               </a:ext>
             </a:extLst>
           </p:cNvPr>
@@ -2520,7 +2520,7 @@
     </p:spTree>
     <p:extLst>
       <p:ext uri="{BB962C8B-B14F-4D97-AF65-F5344CB8AC3E}">
-        <p14:creationId xmlns:p14="http://schemas.microsoft.com/office/powerpoint/2010/main" val="610475536"/>
+        <p14:creationId xmlns:p14="http://schemas.microsoft.com/office/powerpoint/2010/main" val="1854764070"/>
       </p:ext>
     </p:extLst>
   </p:cSld>
@@ -2544,7 +2544,7 @@
           <p:cNvPr id="1" name="">
             <a:extLst xmlns:a="http://schemas.openxmlformats.org/drawingml/2006/main">
               <a:ext uri="{FF2B5EF4-FFF2-40B4-BE49-F238E27FC236}">
-                <a16:creationId xmlns:a16="http://schemas.microsoft.com/office/drawing/2014/main" id="{3C683780-5CF7-45C5-9DA7-802921B5E835}"/>
+                <a16:creationId xmlns:a16="http://schemas.microsoft.com/office/drawing/2014/main" id="{738F4827-C0B4-4FA4-B659-AB09F0CECEAE}"/>
               </a:ext>
             </a:extLst>
           </p:cNvPr>
@@ -2579,7 +2579,7 @@
           <p:cNvPr id="2" name="">
             <a:extLst xmlns:a="http://schemas.openxmlformats.org/drawingml/2006/main">
               <a:ext uri="{FF2B5EF4-FFF2-40B4-BE49-F238E27FC236}">
-                <a16:creationId xmlns:a16="http://schemas.microsoft.com/office/drawing/2014/main" id="{000F6020-0FCC-43F8-B540-8E9D7894281C}"/>
+                <a16:creationId xmlns:a16="http://schemas.microsoft.com/office/drawing/2014/main" id="{89C25592-DB9A-4D0E-9670-6E8C638B6CA2}"/>
               </a:ext>
             </a:extLst>
           </p:cNvPr>
@@ -2643,7 +2643,7 @@
           <p:cNvPr id="3" name="">
             <a:extLst xmlns:a="http://schemas.openxmlformats.org/drawingml/2006/main">
               <a:ext uri="{FF2B5EF4-FFF2-40B4-BE49-F238E27FC236}">
-                <a16:creationId xmlns:a16="http://schemas.microsoft.com/office/drawing/2014/main" id="{9206BE87-C69D-42CE-93D8-D089B239E2E5}"/>
+                <a16:creationId xmlns:a16="http://schemas.microsoft.com/office/drawing/2014/main" id="{DFFDB509-BEC8-48DB-8508-83418DBADE2B}"/>
               </a:ext>
             </a:extLst>
           </p:cNvPr>
@@ -2707,7 +2707,7 @@
           <p:cNvPr id="4" name="">
             <a:extLst xmlns:a="http://schemas.openxmlformats.org/drawingml/2006/main">
               <a:ext uri="{FF2B5EF4-FFF2-40B4-BE49-F238E27FC236}">
-                <a16:creationId xmlns:a16="http://schemas.microsoft.com/office/drawing/2014/main" id="{B1396422-B518-436C-99D0-AC34F7D90A14}"/>
+                <a16:creationId xmlns:a16="http://schemas.microsoft.com/office/drawing/2014/main" id="{2FDFE172-19C1-4C5B-A9B6-629C752EF439}"/>
               </a:ext>
             </a:extLst>
           </p:cNvPr>
@@ -2771,7 +2771,7 @@
           <p:cNvPr id="5" name="">
             <a:extLst xmlns:a="http://schemas.openxmlformats.org/drawingml/2006/main">
               <a:ext uri="{FF2B5EF4-FFF2-40B4-BE49-F238E27FC236}">
-                <a16:creationId xmlns:a16="http://schemas.microsoft.com/office/drawing/2014/main" id="{F407B939-63E7-42BD-8108-F169BFCE2447}"/>
+                <a16:creationId xmlns:a16="http://schemas.microsoft.com/office/drawing/2014/main" id="{7500A202-09ED-4DE2-BE11-69BDCCD99EF1}"/>
               </a:ext>
             </a:extLst>
           </p:cNvPr>
@@ -2806,7 +2806,7 @@
           <p:cNvPr id="6" name="">
             <a:extLst xmlns:a="http://schemas.openxmlformats.org/drawingml/2006/main">
               <a:ext uri="{FF2B5EF4-FFF2-40B4-BE49-F238E27FC236}">
-                <a16:creationId xmlns:a16="http://schemas.microsoft.com/office/drawing/2014/main" id="{059D32FD-D3E9-42AF-9380-928189FC5D41}"/>
+                <a16:creationId xmlns:a16="http://schemas.microsoft.com/office/drawing/2014/main" id="{B7B12B99-1F27-4C7E-AB82-37C13AB4E167}"/>
               </a:ext>
             </a:extLst>
           </p:cNvPr>
@@ -2839,7 +2839,7 @@
           <p:cNvPr id="7" name="">
             <a:extLst xmlns:a="http://schemas.openxmlformats.org/drawingml/2006/main">
               <a:ext uri="{FF2B5EF4-FFF2-40B4-BE49-F238E27FC236}">
-                <a16:creationId xmlns:a16="http://schemas.microsoft.com/office/drawing/2014/main" id="{FEBC0146-5809-4F04-95F0-B7F1DCFBB6ED}"/>
+                <a16:creationId xmlns:a16="http://schemas.microsoft.com/office/drawing/2014/main" id="{E4029096-B00F-423C-BC0C-F4F4DDBA538B}"/>
               </a:ext>
             </a:extLst>
           </p:cNvPr>
@@ -2874,7 +2874,7 @@
           <p:cNvPr id="8" name="">
             <a:extLst xmlns:a="http://schemas.openxmlformats.org/drawingml/2006/main">
               <a:ext uri="{FF2B5EF4-FFF2-40B4-BE49-F238E27FC236}">
-                <a16:creationId xmlns:a16="http://schemas.microsoft.com/office/drawing/2014/main" id="{F9BC47EB-D610-4ABB-A977-B49554226D38}"/>
+                <a16:creationId xmlns:a16="http://schemas.microsoft.com/office/drawing/2014/main" id="{F3DB8AD8-872D-4AF6-81A3-A3E4A1F13F69}"/>
               </a:ext>
             </a:extLst>
           </p:cNvPr>
@@ -2938,7 +2938,7 @@
           <p:cNvPr id="9" name="">
             <a:extLst xmlns:a="http://schemas.openxmlformats.org/drawingml/2006/main">
               <a:ext uri="{FF2B5EF4-FFF2-40B4-BE49-F238E27FC236}">
-                <a16:creationId xmlns:a16="http://schemas.microsoft.com/office/drawing/2014/main" id="{75E61B37-B4ED-4BA5-96B3-6223FBD5D31C}"/>
+                <a16:creationId xmlns:a16="http://schemas.microsoft.com/office/drawing/2014/main" id="{D355B853-CC02-411C-BD74-5C4A0D7D5399}"/>
               </a:ext>
             </a:extLst>
           </p:cNvPr>
@@ -3002,7 +3002,7 @@
           <p:cNvPr id="10" name="">
             <a:extLst xmlns:a="http://schemas.openxmlformats.org/drawingml/2006/main">
               <a:ext uri="{FF2B5EF4-FFF2-40B4-BE49-F238E27FC236}">
-                <a16:creationId xmlns:a16="http://schemas.microsoft.com/office/drawing/2014/main" id="{8D983F62-774B-45FE-83FD-749924158F08}"/>
+                <a16:creationId xmlns:a16="http://schemas.microsoft.com/office/drawing/2014/main" id="{A1AEF42C-B5D0-4CB2-935F-0C2B55237989}"/>
               </a:ext>
             </a:extLst>
           </p:cNvPr>
@@ -3035,7 +3035,7 @@
           <p:cNvPr id="11" name="">
             <a:extLst xmlns:a="http://schemas.openxmlformats.org/drawingml/2006/main">
               <a:ext uri="{FF2B5EF4-FFF2-40B4-BE49-F238E27FC236}">
-                <a16:creationId xmlns:a16="http://schemas.microsoft.com/office/drawing/2014/main" id="{311C4337-A6AB-467E-B772-0963A3DD09A6}"/>
+                <a16:creationId xmlns:a16="http://schemas.microsoft.com/office/drawing/2014/main" id="{A5AC9C6F-321E-4365-B974-D33170D24415}"/>
               </a:ext>
             </a:extLst>
           </p:cNvPr>
@@ -3070,7 +3070,7 @@
           <p:cNvPr id="12" name="">
             <a:extLst xmlns:a="http://schemas.openxmlformats.org/drawingml/2006/main">
               <a:ext uri="{FF2B5EF4-FFF2-40B4-BE49-F238E27FC236}">
-                <a16:creationId xmlns:a16="http://schemas.microsoft.com/office/drawing/2014/main" id="{70DD49A5-13EB-4816-92CF-F610D1C6AFC4}"/>
+                <a16:creationId xmlns:a16="http://schemas.microsoft.com/office/drawing/2014/main" id="{CAA9903B-65B5-4A4A-9D40-50866932EAF1}"/>
               </a:ext>
             </a:extLst>
           </p:cNvPr>
@@ -3134,7 +3134,7 @@
           <p:cNvPr id="13" name="">
             <a:extLst xmlns:a="http://schemas.openxmlformats.org/drawingml/2006/main">
               <a:ext uri="{FF2B5EF4-FFF2-40B4-BE49-F238E27FC236}">
-                <a16:creationId xmlns:a16="http://schemas.microsoft.com/office/drawing/2014/main" id="{E0EBFDE4-2089-467E-81C9-E7DBF7117DF3}"/>
+                <a16:creationId xmlns:a16="http://schemas.microsoft.com/office/drawing/2014/main" id="{A6E90C85-A5B4-4103-B0EA-5CA9AB373C19}"/>
               </a:ext>
             </a:extLst>
           </p:cNvPr>
@@ -3221,7 +3221,7 @@
           <p:cNvPr id="14" name="">
             <a:extLst xmlns:a="http://schemas.openxmlformats.org/drawingml/2006/main">
               <a:ext uri="{FF2B5EF4-FFF2-40B4-BE49-F238E27FC236}">
-                <a16:creationId xmlns:a16="http://schemas.microsoft.com/office/drawing/2014/main" id="{7FF7F028-4D80-49D0-A399-D132BD0C25F9}"/>
+                <a16:creationId xmlns:a16="http://schemas.microsoft.com/office/drawing/2014/main" id="{EB38EF97-F36D-4BAA-BDAF-3585C5672A92}"/>
               </a:ext>
             </a:extLst>
           </p:cNvPr>
@@ -3254,7 +3254,7 @@
           <p:cNvPr id="15" name="">
             <a:extLst xmlns:a="http://schemas.openxmlformats.org/drawingml/2006/main">
               <a:ext uri="{FF2B5EF4-FFF2-40B4-BE49-F238E27FC236}">
-                <a16:creationId xmlns:a16="http://schemas.microsoft.com/office/drawing/2014/main" id="{29371023-7854-4D49-89C6-C70356A22439}"/>
+                <a16:creationId xmlns:a16="http://schemas.microsoft.com/office/drawing/2014/main" id="{A11B1765-D172-4CF9-8FC1-03F6ED43EA37}"/>
               </a:ext>
             </a:extLst>
           </p:cNvPr>
@@ -3289,7 +3289,7 @@
           <p:cNvPr id="16" name="">
             <a:extLst xmlns:a="http://schemas.openxmlformats.org/drawingml/2006/main">
               <a:ext uri="{FF2B5EF4-FFF2-40B4-BE49-F238E27FC236}">
-                <a16:creationId xmlns:a16="http://schemas.microsoft.com/office/drawing/2014/main" id="{D7A821A6-B7DF-415D-BCF0-7D17EC6677D7}"/>
+                <a16:creationId xmlns:a16="http://schemas.microsoft.com/office/drawing/2014/main" id="{389A3360-9D5D-4DE6-AF93-C59892A7603A}"/>
               </a:ext>
             </a:extLst>
           </p:cNvPr>
@@ -3353,7 +3353,7 @@
           <p:cNvPr id="17" name="">
             <a:extLst xmlns:a="http://schemas.openxmlformats.org/drawingml/2006/main">
               <a:ext uri="{FF2B5EF4-FFF2-40B4-BE49-F238E27FC236}">
-                <a16:creationId xmlns:a16="http://schemas.microsoft.com/office/drawing/2014/main" id="{3A550821-ABAB-4FCF-B11E-4570CDEFDDAF}"/>
+                <a16:creationId xmlns:a16="http://schemas.microsoft.com/office/drawing/2014/main" id="{5F866F9B-1613-40BC-B462-3BE05C9EED0A}"/>
               </a:ext>
             </a:extLst>
           </p:cNvPr>
@@ -3417,7 +3417,7 @@
           <p:cNvPr id="18" name="">
             <a:extLst xmlns:a="http://schemas.openxmlformats.org/drawingml/2006/main">
               <a:ext uri="{FF2B5EF4-FFF2-40B4-BE49-F238E27FC236}">
-                <a16:creationId xmlns:a16="http://schemas.microsoft.com/office/drawing/2014/main" id="{8771CE9B-9241-481E-9613-A706CBAA3A05}"/>
+                <a16:creationId xmlns:a16="http://schemas.microsoft.com/office/drawing/2014/main" id="{9E1EAB33-9EA7-430B-83F9-AE1E7C0F0A7A}"/>
               </a:ext>
             </a:extLst>
           </p:cNvPr>
@@ -3450,7 +3450,7 @@
           <p:cNvPr id="19" name="">
             <a:extLst xmlns:a="http://schemas.openxmlformats.org/drawingml/2006/main">
               <a:ext uri="{FF2B5EF4-FFF2-40B4-BE49-F238E27FC236}">
-                <a16:creationId xmlns:a16="http://schemas.microsoft.com/office/drawing/2014/main" id="{E18C3C21-121B-4CAB-A5F4-54ED19D6698A}"/>
+                <a16:creationId xmlns:a16="http://schemas.microsoft.com/office/drawing/2014/main" id="{7424F8FA-8839-450F-B41D-AF79F08FB62B}"/>
               </a:ext>
             </a:extLst>
           </p:cNvPr>
@@ -3485,7 +3485,7 @@
           <p:cNvPr id="20" name="">
             <a:extLst xmlns:a="http://schemas.openxmlformats.org/drawingml/2006/main">
               <a:ext uri="{FF2B5EF4-FFF2-40B4-BE49-F238E27FC236}">
-                <a16:creationId xmlns:a16="http://schemas.microsoft.com/office/drawing/2014/main" id="{716293CD-2BA0-4B68-87FE-22DC9D47107E}"/>
+                <a16:creationId xmlns:a16="http://schemas.microsoft.com/office/drawing/2014/main" id="{65018E95-C22C-48E0-BE57-B8BA4B62DD49}"/>
               </a:ext>
             </a:extLst>
           </p:cNvPr>
@@ -3549,7 +3549,7 @@
           <p:cNvPr id="21" name="">
             <a:extLst xmlns:a="http://schemas.openxmlformats.org/drawingml/2006/main">
               <a:ext uri="{FF2B5EF4-FFF2-40B4-BE49-F238E27FC236}">
-                <a16:creationId xmlns:a16="http://schemas.microsoft.com/office/drawing/2014/main" id="{29271D7F-7082-4A59-B7E1-001DE56D43D7}"/>
+                <a16:creationId xmlns:a16="http://schemas.microsoft.com/office/drawing/2014/main" id="{80F03882-81DB-430F-BED9-28C8C4355E3A}"/>
               </a:ext>
             </a:extLst>
           </p:cNvPr>
@@ -3636,7 +3636,7 @@
           <p:cNvPr id="22" name="">
             <a:extLst xmlns:a="http://schemas.openxmlformats.org/drawingml/2006/main">
               <a:ext uri="{FF2B5EF4-FFF2-40B4-BE49-F238E27FC236}">
-                <a16:creationId xmlns:a16="http://schemas.microsoft.com/office/drawing/2014/main" id="{32462648-E2AA-4AFC-8494-AC1402B0BC9A}"/>
+                <a16:creationId xmlns:a16="http://schemas.microsoft.com/office/drawing/2014/main" id="{A280C8DF-BAB3-4F27-BE03-EB3C91A31854}"/>
               </a:ext>
             </a:extLst>
           </p:cNvPr>
@@ -3669,7 +3669,7 @@
           <p:cNvPr id="23" name="">
             <a:extLst xmlns:a="http://schemas.openxmlformats.org/drawingml/2006/main">
               <a:ext uri="{FF2B5EF4-FFF2-40B4-BE49-F238E27FC236}">
-                <a16:creationId xmlns:a16="http://schemas.microsoft.com/office/drawing/2014/main" id="{BF11DAE9-EB0E-45F4-A11E-13E7D3677963}"/>
+                <a16:creationId xmlns:a16="http://schemas.microsoft.com/office/drawing/2014/main" id="{DC181593-D203-4F04-9A01-F35359AB0C17}"/>
               </a:ext>
             </a:extLst>
           </p:cNvPr>
@@ -3733,7 +3733,7 @@
           <p:cNvPr id="24" name="">
             <a:extLst xmlns:a="http://schemas.openxmlformats.org/drawingml/2006/main">
               <a:ext uri="{FF2B5EF4-FFF2-40B4-BE49-F238E27FC236}">
-                <a16:creationId xmlns:a16="http://schemas.microsoft.com/office/drawing/2014/main" id="{B53AFAE3-194C-4054-A8DA-507E5AAA77B1}"/>
+                <a16:creationId xmlns:a16="http://schemas.microsoft.com/office/drawing/2014/main" id="{4CF24801-E9D3-43B5-A376-D72C729DA7F6}"/>
               </a:ext>
             </a:extLst>
           </p:cNvPr>
@@ -3797,7 +3797,7 @@
           <p:cNvPr id="25" name="">
             <a:extLst xmlns:a="http://schemas.openxmlformats.org/drawingml/2006/main">
               <a:ext uri="{FF2B5EF4-FFF2-40B4-BE49-F238E27FC236}">
-                <a16:creationId xmlns:a16="http://schemas.microsoft.com/office/drawing/2014/main" id="{A1D081F7-3834-48D6-97F5-13831718614F}"/>
+                <a16:creationId xmlns:a16="http://schemas.microsoft.com/office/drawing/2014/main" id="{E785F9E1-CAA3-4B5D-A707-DDCC84F6FC74}"/>
               </a:ext>
             </a:extLst>
           </p:cNvPr>
@@ -3859,7 +3859,7 @@
     </p:spTree>
     <p:extLst>
       <p:ext uri="{BB962C8B-B14F-4D97-AF65-F5344CB8AC3E}">
-        <p14:creationId xmlns:p14="http://schemas.microsoft.com/office/powerpoint/2010/main" val="740187052"/>
+        <p14:creationId xmlns:p14="http://schemas.microsoft.com/office/powerpoint/2010/main" val="1515513655"/>
       </p:ext>
     </p:extLst>
   </p:cSld>
@@ -3883,7 +3883,7 @@
           <p:cNvPr id="1" name="">
             <a:extLst xmlns:a="http://schemas.openxmlformats.org/drawingml/2006/main">
               <a:ext uri="{FF2B5EF4-FFF2-40B4-BE49-F238E27FC236}">
-                <a16:creationId xmlns:a16="http://schemas.microsoft.com/office/drawing/2014/main" id="{20401270-37FF-4195-B0A5-E201371820AF}"/>
+                <a16:creationId xmlns:a16="http://schemas.microsoft.com/office/drawing/2014/main" id="{4D0DF417-BEDC-4EF2-A4D0-EBA114FC4BD7}"/>
               </a:ext>
             </a:extLst>
           </p:cNvPr>
@@ -3918,7 +3918,7 @@
           <p:cNvPr id="2" name="">
             <a:extLst xmlns:a="http://schemas.openxmlformats.org/drawingml/2006/main">
               <a:ext uri="{FF2B5EF4-FFF2-40B4-BE49-F238E27FC236}">
-                <a16:creationId xmlns:a16="http://schemas.microsoft.com/office/drawing/2014/main" id="{9BCECF87-EC81-4F3D-95B1-E4B4D4411F85}"/>
+                <a16:creationId xmlns:a16="http://schemas.microsoft.com/office/drawing/2014/main" id="{A09E84E9-46E0-4AAC-9AD5-5CD194053209}"/>
               </a:ext>
             </a:extLst>
           </p:cNvPr>
@@ -3982,7 +3982,7 @@
           <p:cNvPr id="3" name="">
             <a:extLst xmlns:a="http://schemas.openxmlformats.org/drawingml/2006/main">
               <a:ext uri="{FF2B5EF4-FFF2-40B4-BE49-F238E27FC236}">
-                <a16:creationId xmlns:a16="http://schemas.microsoft.com/office/drawing/2014/main" id="{A5D3F12D-290B-4290-89E1-5C4AC8E7ACD8}"/>
+                <a16:creationId xmlns:a16="http://schemas.microsoft.com/office/drawing/2014/main" id="{A5F33D5C-D65A-44D8-83CD-9F9E40C3A055}"/>
               </a:ext>
             </a:extLst>
           </p:cNvPr>
@@ -4046,7 +4046,7 @@
           <p:cNvPr id="4" name="">
             <a:extLst xmlns:a="http://schemas.openxmlformats.org/drawingml/2006/main">
               <a:ext uri="{FF2B5EF4-FFF2-40B4-BE49-F238E27FC236}">
-                <a16:creationId xmlns:a16="http://schemas.microsoft.com/office/drawing/2014/main" id="{288DB703-4635-4DFB-8F1C-2675ADD9E8E1}"/>
+                <a16:creationId xmlns:a16="http://schemas.microsoft.com/office/drawing/2014/main" id="{61169E5C-E6E6-4E70-986D-A253F9932F59}"/>
               </a:ext>
             </a:extLst>
           </p:cNvPr>
@@ -4110,7 +4110,7 @@
           <p:cNvPr id="5" name="">
             <a:extLst xmlns:a="http://schemas.openxmlformats.org/drawingml/2006/main">
               <a:ext uri="{FF2B5EF4-FFF2-40B4-BE49-F238E27FC236}">
-                <a16:creationId xmlns:a16="http://schemas.microsoft.com/office/drawing/2014/main" id="{D000D6A6-4DF2-4D70-B376-F5E4E6D9B46E}"/>
+                <a16:creationId xmlns:a16="http://schemas.microsoft.com/office/drawing/2014/main" id="{9AF56A66-26EB-43D6-BBC9-72A04CDD2B99}"/>
               </a:ext>
             </a:extLst>
           </p:cNvPr>
@@ -4145,7 +4145,7 @@
           <p:cNvPr id="6" name="">
             <a:extLst xmlns:a="http://schemas.openxmlformats.org/drawingml/2006/main">
               <a:ext uri="{FF2B5EF4-FFF2-40B4-BE49-F238E27FC236}">
-                <a16:creationId xmlns:a16="http://schemas.microsoft.com/office/drawing/2014/main" id="{693E53A5-593D-4358-B0A6-EFE6696A2736}"/>
+                <a16:creationId xmlns:a16="http://schemas.microsoft.com/office/drawing/2014/main" id="{6AE9CD3C-F04C-4093-B48B-69843404F742}"/>
               </a:ext>
             </a:extLst>
           </p:cNvPr>
@@ -4209,7 +4209,7 @@
           <p:cNvPr id="7" name="">
             <a:extLst xmlns:a="http://schemas.openxmlformats.org/drawingml/2006/main">
               <a:ext uri="{FF2B5EF4-FFF2-40B4-BE49-F238E27FC236}">
-                <a16:creationId xmlns:a16="http://schemas.microsoft.com/office/drawing/2014/main" id="{7294430E-1EF4-4FB7-9321-59BF848BBD6D}"/>
+                <a16:creationId xmlns:a16="http://schemas.microsoft.com/office/drawing/2014/main" id="{EFA48C2A-EED4-494A-A3DF-C461CDB72610}"/>
               </a:ext>
             </a:extLst>
           </p:cNvPr>
@@ -4273,7 +4273,7 @@
           <p:cNvPr id="8" name="">
             <a:extLst xmlns:a="http://schemas.openxmlformats.org/drawingml/2006/main">
               <a:ext uri="{FF2B5EF4-FFF2-40B4-BE49-F238E27FC236}">
-                <a16:creationId xmlns:a16="http://schemas.microsoft.com/office/drawing/2014/main" id="{C7207389-0052-41E5-9AC7-E53B7B4CE957}"/>
+                <a16:creationId xmlns:a16="http://schemas.microsoft.com/office/drawing/2014/main" id="{3543E0D5-36A7-4376-9CDB-3828AA7CBA04}"/>
               </a:ext>
             </a:extLst>
           </p:cNvPr>
@@ -4306,7 +4306,7 @@
           <p:cNvPr id="9" name="">
             <a:extLst xmlns:a="http://schemas.openxmlformats.org/drawingml/2006/main">
               <a:ext uri="{FF2B5EF4-FFF2-40B4-BE49-F238E27FC236}">
-                <a16:creationId xmlns:a16="http://schemas.microsoft.com/office/drawing/2014/main" id="{89B18EB2-A05B-4838-AA1C-7BA702D6A6E3}"/>
+                <a16:creationId xmlns:a16="http://schemas.microsoft.com/office/drawing/2014/main" id="{7D2E2EEA-C249-41C4-A6E6-B916610B79EF}"/>
               </a:ext>
             </a:extLst>
           </p:cNvPr>
@@ -4370,7 +4370,7 @@
           <p:cNvPr id="10" name="">
             <a:extLst xmlns:a="http://schemas.openxmlformats.org/drawingml/2006/main">
               <a:ext uri="{FF2B5EF4-FFF2-40B4-BE49-F238E27FC236}">
-                <a16:creationId xmlns:a16="http://schemas.microsoft.com/office/drawing/2014/main" id="{4ABAAFFB-484B-469B-BCFF-07BE50E9F823}"/>
+                <a16:creationId xmlns:a16="http://schemas.microsoft.com/office/drawing/2014/main" id="{AA925FAA-919C-4A48-8DFE-C1594914548D}"/>
               </a:ext>
             </a:extLst>
           </p:cNvPr>
@@ -4424,7 +4424,7 @@
                 <a:ea typeface="Microsoft YaHei"/>
                 <a:cs typeface="Microsoft YaHei"/>
               </a:rPr>
-              <a:t>CSV / PDF / 示例材料</a:t>
+              <a:t>演示交易流水</a:t>
             </a:r>
           </a:p>
           <a:p xmlns:a="http://schemas.openxmlformats.org/drawingml/2006/main">
@@ -4447,7 +4447,7 @@
                 <a:ea typeface="Microsoft YaHei"/>
                 <a:cs typeface="Microsoft YaHei"/>
               </a:rPr>
-              <a:t>审计知识片段</a:t>
+              <a:t>或上传 CSV</a:t>
             </a:r>
           </a:p>
         </p:txBody>
@@ -4457,7 +4457,7 @@
           <p:cNvPr id="11" name="">
             <a:extLst xmlns:a="http://schemas.openxmlformats.org/drawingml/2006/main">
               <a:ext uri="{FF2B5EF4-FFF2-40B4-BE49-F238E27FC236}">
-                <a16:creationId xmlns:a16="http://schemas.microsoft.com/office/drawing/2014/main" id="{47AB62C9-8EEC-4B26-AC66-F03A00B6B5ED}"/>
+                <a16:creationId xmlns:a16="http://schemas.microsoft.com/office/drawing/2014/main" id="{62AB96C8-E7A2-485A-BD95-37BEAC4F2F9D}"/>
               </a:ext>
             </a:extLst>
           </p:cNvPr>
@@ -4521,7 +4521,7 @@
           <p:cNvPr id="12" name="">
             <a:extLst xmlns:a="http://schemas.openxmlformats.org/drawingml/2006/main">
               <a:ext uri="{FF2B5EF4-FFF2-40B4-BE49-F238E27FC236}">
-                <a16:creationId xmlns:a16="http://schemas.microsoft.com/office/drawing/2014/main" id="{CF206825-2F06-489B-8EE8-85DF78E8A8FC}"/>
+                <a16:creationId xmlns:a16="http://schemas.microsoft.com/office/drawing/2014/main" id="{DB727A78-0206-46B6-8A99-98483072B414}"/>
               </a:ext>
             </a:extLst>
           </p:cNvPr>
@@ -4554,7 +4554,7 @@
           <p:cNvPr id="13" name="">
             <a:extLst xmlns:a="http://schemas.openxmlformats.org/drawingml/2006/main">
               <a:ext uri="{FF2B5EF4-FFF2-40B4-BE49-F238E27FC236}">
-                <a16:creationId xmlns:a16="http://schemas.microsoft.com/office/drawing/2014/main" id="{44047237-A7FE-467D-A411-1FCA9EFFD622}"/>
+                <a16:creationId xmlns:a16="http://schemas.microsoft.com/office/drawing/2014/main" id="{C6A0EEBE-CBCD-4B41-B41F-FCEB2BD099C1}"/>
               </a:ext>
             </a:extLst>
           </p:cNvPr>
@@ -4618,7 +4618,7 @@
           <p:cNvPr id="14" name="">
             <a:extLst xmlns:a="http://schemas.openxmlformats.org/drawingml/2006/main">
               <a:ext uri="{FF2B5EF4-FFF2-40B4-BE49-F238E27FC236}">
-                <a16:creationId xmlns:a16="http://schemas.microsoft.com/office/drawing/2014/main" id="{83368FDE-F1CC-49AC-B1A8-39D4B0AE2961}"/>
+                <a16:creationId xmlns:a16="http://schemas.microsoft.com/office/drawing/2014/main" id="{CF0ACED9-DAC7-47FB-9D2F-D6CE019778D1}"/>
               </a:ext>
             </a:extLst>
           </p:cNvPr>
@@ -4672,7 +4672,7 @@
                 <a:ea typeface="Microsoft YaHei"/>
                 <a:cs typeface="Microsoft YaHei"/>
               </a:rPr>
-              <a:t>data_tools 结构化</a:t>
+              <a:t>数据清洗评分</a:t>
             </a:r>
           </a:p>
           <a:p xmlns:a="http://schemas.openxmlformats.org/drawingml/2006/main">
@@ -4695,7 +4695,7 @@
                 <a:ea typeface="Microsoft YaHei"/>
                 <a:cs typeface="Microsoft YaHei"/>
               </a:rPr>
-              <a:t>RAG 检索与 fallback</a:t>
+              <a:t>规则异常扫描</a:t>
             </a:r>
           </a:p>
         </p:txBody>
@@ -4705,7 +4705,7 @@
           <p:cNvPr id="15" name="">
             <a:extLst xmlns:a="http://schemas.openxmlformats.org/drawingml/2006/main">
               <a:ext uri="{FF2B5EF4-FFF2-40B4-BE49-F238E27FC236}">
-                <a16:creationId xmlns:a16="http://schemas.microsoft.com/office/drawing/2014/main" id="{2B79B740-8AF7-4F0A-9C4C-827D40563A2A}"/>
+                <a16:creationId xmlns:a16="http://schemas.microsoft.com/office/drawing/2014/main" id="{624987A3-DE38-41C8-8F64-2DD16BDF4333}"/>
               </a:ext>
             </a:extLst>
           </p:cNvPr>
@@ -4769,7 +4769,7 @@
           <p:cNvPr id="16" name="">
             <a:extLst xmlns:a="http://schemas.openxmlformats.org/drawingml/2006/main">
               <a:ext uri="{FF2B5EF4-FFF2-40B4-BE49-F238E27FC236}">
-                <a16:creationId xmlns:a16="http://schemas.microsoft.com/office/drawing/2014/main" id="{74D5D770-181D-445F-B387-F680A5401B81}"/>
+                <a16:creationId xmlns:a16="http://schemas.microsoft.com/office/drawing/2014/main" id="{BC3F841D-2F62-4956-81B0-265008B06C7C}"/>
               </a:ext>
             </a:extLst>
           </p:cNvPr>
@@ -4802,7 +4802,7 @@
           <p:cNvPr id="17" name="">
             <a:extLst xmlns:a="http://schemas.openxmlformats.org/drawingml/2006/main">
               <a:ext uri="{FF2B5EF4-FFF2-40B4-BE49-F238E27FC236}">
-                <a16:creationId xmlns:a16="http://schemas.microsoft.com/office/drawing/2014/main" id="{B068D293-7A6F-48F8-9156-2A4650BBC7D0}"/>
+                <a16:creationId xmlns:a16="http://schemas.microsoft.com/office/drawing/2014/main" id="{1374C6A7-9AFB-4651-A9CE-6D95BC9773AA}"/>
               </a:ext>
             </a:extLst>
           </p:cNvPr>
@@ -4856,7 +4856,7 @@
                 <a:ea typeface="Microsoft YaHei"/>
                 <a:cs typeface="Microsoft YaHei"/>
               </a:rPr>
-              <a:t>Agent 讨论</a:t>
+              <a:t>AI 分析</a:t>
             </a:r>
           </a:p>
         </p:txBody>
@@ -4866,7 +4866,7 @@
           <p:cNvPr id="18" name="">
             <a:extLst xmlns:a="http://schemas.openxmlformats.org/drawingml/2006/main">
               <a:ext uri="{FF2B5EF4-FFF2-40B4-BE49-F238E27FC236}">
-                <a16:creationId xmlns:a16="http://schemas.microsoft.com/office/drawing/2014/main" id="{8ED72825-F02E-4B16-9FB1-643776F69995}"/>
+                <a16:creationId xmlns:a16="http://schemas.microsoft.com/office/drawing/2014/main" id="{F1198DCD-C54D-4E3B-832E-858B3C08F2E7}"/>
               </a:ext>
             </a:extLst>
           </p:cNvPr>
@@ -4920,7 +4920,7 @@
                 <a:ea typeface="Microsoft YaHei"/>
                 <a:cs typeface="Microsoft YaHei"/>
               </a:rPr>
-              <a:t>Data Extractor</a:t>
+              <a:t>DeepSeek 叙述</a:t>
             </a:r>
           </a:p>
           <a:p xmlns:a="http://schemas.openxmlformats.org/drawingml/2006/main">
@@ -4943,9 +4943,211 @@
                 <a:ea typeface="Microsoft YaHei"/>
                 <a:cs typeface="Microsoft YaHei"/>
               </a:rPr>
-              <a:t>Compliance Checker</a:t>
-            </a:r>
-          </a:p>
+              <a:t>资金核对</a:t>
+            </a:r>
+          </a:p>
+        </p:txBody>
+      </p:sp>
+      <p:sp>
+        <p:nvSpPr>
+          <p:cNvPr id="19" name="">
+            <a:extLst xmlns:a="http://schemas.openxmlformats.org/drawingml/2006/main">
+              <a:ext uri="{FF2B5EF4-FFF2-40B4-BE49-F238E27FC236}">
+                <a16:creationId xmlns:a16="http://schemas.microsoft.com/office/drawing/2014/main" id="{4AE544D9-3D3E-4C9F-89FF-A124D9A4A2CC}"/>
+              </a:ext>
+            </a:extLst>
+          </p:cNvPr>
+          <p:cNvSpPr>
+            <a:spLocks xmlns:a="http://schemas.openxmlformats.org/drawingml/2006/main" noGrp="1"/>
+          </p:cNvSpPr>
+          <p:nvPr/>
+        </p:nvSpPr>
+        <p:spPr>
+          <a:xfrm xmlns:a="http://schemas.openxmlformats.org/drawingml/2006/main">
+            <a:off x="2895600" y="4591050"/>
+            <a:ext cx="266700" cy="228600"/>
+          </a:xfrm>
+          <a:prstGeom xmlns:a="http://schemas.openxmlformats.org/drawingml/2006/main" prst="rect">
+            <a:avLst/>
+          </a:prstGeom>
+          <a:solidFill xmlns:a="http://schemas.openxmlformats.org/drawingml/2006/main">
+            <a:srgbClr val="000000">
+              <a:alpha val="0"/>
+            </a:srgbClr>
+          </a:solidFill>
+          <a:ln xmlns:a="http://schemas.openxmlformats.org/drawingml/2006/main" w="0">
+            <a:solidFill>
+              <a:srgbClr val="000000">
+                <a:alpha val="0"/>
+              </a:srgbClr>
+            </a:solidFill>
+            <a:prstDash val="solid"/>
+          </a:ln>
+        </p:spPr>
+        <p:txBody>
+          <a:bodyPr xmlns:a="http://schemas.openxmlformats.org/drawingml/2006/main" lIns="0" tIns="0" rIns="0" bIns="0" anchor="t"/>
+          <a:lstStyle xmlns:a="http://schemas.openxmlformats.org/drawingml/2006/main"/>
+          <a:p xmlns:a="http://schemas.openxmlformats.org/drawingml/2006/main">
+            <a:pPr algn="ctr">
+              <a:defRPr sz="1350" b="1">
+                <a:solidFill>
+                  <a:srgbClr val="94A3B8"/>
+                </a:solidFill>
+                <a:latin typeface="Microsoft YaHei"/>
+                <a:ea typeface="Microsoft YaHei"/>
+                <a:cs typeface="Microsoft YaHei"/>
+              </a:defRPr>
+            </a:pPr>
+            <a:r>
+              <a:rPr sz="1350" b="1">
+                <a:solidFill>
+                  <a:srgbClr val="94A3B8"/>
+                </a:solidFill>
+                <a:latin typeface="Microsoft YaHei"/>
+                <a:ea typeface="Microsoft YaHei"/>
+                <a:cs typeface="Microsoft YaHei"/>
+              </a:rPr>
+              <a:t>↓</a:t>
+            </a:r>
+          </a:p>
+        </p:txBody>
+      </p:sp>
+      <p:sp>
+        <p:nvSpPr>
+          <p:cNvPr id="20" name="">
+            <a:extLst xmlns:a="http://schemas.openxmlformats.org/drawingml/2006/main">
+              <a:ext uri="{FF2B5EF4-FFF2-40B4-BE49-F238E27FC236}">
+                <a16:creationId xmlns:a16="http://schemas.microsoft.com/office/drawing/2014/main" id="{14893CE7-C2F5-4F98-9D08-07B48E875686}"/>
+              </a:ext>
+            </a:extLst>
+          </p:cNvPr>
+          <p:cNvSpPr>
+            <a:spLocks xmlns:a="http://schemas.openxmlformats.org/drawingml/2006/main" noGrp="1"/>
+          </p:cNvSpPr>
+          <p:nvPr/>
+        </p:nvSpPr>
+        <p:spPr>
+          <a:xfrm xmlns:a="http://schemas.openxmlformats.org/drawingml/2006/main">
+            <a:off x="723900" y="4819650"/>
+            <a:ext cx="4476750" cy="685800"/>
+          </a:xfrm>
+          <a:prstGeom xmlns:a="http://schemas.openxmlformats.org/drawingml/2006/main" prst="rect">
+            <a:avLst/>
+          </a:prstGeom>
+          <a:solidFill xmlns:a="http://schemas.openxmlformats.org/drawingml/2006/main">
+            <a:srgbClr val="F1F5F9"/>
+          </a:solidFill>
+          <a:ln xmlns:a="http://schemas.openxmlformats.org/drawingml/2006/main" w="9525">
+            <a:solidFill>
+              <a:srgbClr val="DBE3EF"/>
+            </a:solidFill>
+            <a:prstDash val="solid"/>
+          </a:ln>
+        </p:spPr>
+      </p:sp>
+      <p:sp>
+        <p:nvSpPr>
+          <p:cNvPr id="21" name="">
+            <a:extLst xmlns:a="http://schemas.openxmlformats.org/drawingml/2006/main">
+              <a:ext uri="{FF2B5EF4-FFF2-40B4-BE49-F238E27FC236}">
+                <a16:creationId xmlns:a16="http://schemas.microsoft.com/office/drawing/2014/main" id="{E073EC15-2AC5-46FE-B31F-16D9A42406E2}"/>
+              </a:ext>
+            </a:extLst>
+          </p:cNvPr>
+          <p:cNvSpPr>
+            <a:spLocks xmlns:a="http://schemas.openxmlformats.org/drawingml/2006/main" noGrp="1"/>
+          </p:cNvSpPr>
+          <p:nvPr/>
+        </p:nvSpPr>
+        <p:spPr>
+          <a:xfrm xmlns:a="http://schemas.openxmlformats.org/drawingml/2006/main">
+            <a:off x="971550" y="4953000"/>
+            <a:ext cx="1143000" cy="209550"/>
+          </a:xfrm>
+          <a:prstGeom xmlns:a="http://schemas.openxmlformats.org/drawingml/2006/main" prst="rect">
+            <a:avLst/>
+          </a:prstGeom>
+          <a:solidFill xmlns:a="http://schemas.openxmlformats.org/drawingml/2006/main">
+            <a:srgbClr val="000000">
+              <a:alpha val="0"/>
+            </a:srgbClr>
+          </a:solidFill>
+          <a:ln xmlns:a="http://schemas.openxmlformats.org/drawingml/2006/main" w="0">
+            <a:solidFill>
+              <a:srgbClr val="000000">
+                <a:alpha val="0"/>
+              </a:srgbClr>
+            </a:solidFill>
+            <a:prstDash val="solid"/>
+          </a:ln>
+        </p:spPr>
+        <p:txBody>
+          <a:bodyPr xmlns:a="http://schemas.openxmlformats.org/drawingml/2006/main" lIns="0" tIns="0" rIns="0" bIns="0" anchor="t"/>
+          <a:lstStyle xmlns:a="http://schemas.openxmlformats.org/drawingml/2006/main"/>
+          <a:p xmlns:a="http://schemas.openxmlformats.org/drawingml/2006/main">
+            <a:pPr algn="l">
+              <a:defRPr sz="1125" b="1">
+                <a:solidFill>
+                  <a:srgbClr val="B45309"/>
+                </a:solidFill>
+                <a:latin typeface="Microsoft YaHei"/>
+                <a:ea typeface="Microsoft YaHei"/>
+                <a:cs typeface="Microsoft YaHei"/>
+              </a:defRPr>
+            </a:pPr>
+            <a:r>
+              <a:rPr sz="1125" b="1">
+                <a:solidFill>
+                  <a:srgbClr val="B45309"/>
+                </a:solidFill>
+                <a:latin typeface="Microsoft YaHei"/>
+                <a:ea typeface="Microsoft YaHei"/>
+                <a:cs typeface="Microsoft YaHei"/>
+              </a:rPr>
+              <a:t>输出层</a:t>
+            </a:r>
+          </a:p>
+        </p:txBody>
+      </p:sp>
+      <p:sp>
+        <p:nvSpPr>
+          <p:cNvPr id="22" name="">
+            <a:extLst xmlns:a="http://schemas.openxmlformats.org/drawingml/2006/main">
+              <a:ext uri="{FF2B5EF4-FFF2-40B4-BE49-F238E27FC236}">
+                <a16:creationId xmlns:a16="http://schemas.microsoft.com/office/drawing/2014/main" id="{68C0CFC2-1DDD-46B2-91B6-2F1013FC0368}"/>
+              </a:ext>
+            </a:extLst>
+          </p:cNvPr>
+          <p:cNvSpPr>
+            <a:spLocks xmlns:a="http://schemas.openxmlformats.org/drawingml/2006/main" noGrp="1"/>
+          </p:cNvSpPr>
+          <p:nvPr/>
+        </p:nvSpPr>
+        <p:spPr>
+          <a:xfrm xmlns:a="http://schemas.openxmlformats.org/drawingml/2006/main">
+            <a:off x="2343150" y="4943475"/>
+            <a:ext cx="2476500" cy="400050"/>
+          </a:xfrm>
+          <a:prstGeom xmlns:a="http://schemas.openxmlformats.org/drawingml/2006/main" prst="rect">
+            <a:avLst/>
+          </a:prstGeom>
+          <a:solidFill xmlns:a="http://schemas.openxmlformats.org/drawingml/2006/main">
+            <a:srgbClr val="000000">
+              <a:alpha val="0"/>
+            </a:srgbClr>
+          </a:solidFill>
+          <a:ln xmlns:a="http://schemas.openxmlformats.org/drawingml/2006/main" w="0">
+            <a:solidFill>
+              <a:srgbClr val="000000">
+                <a:alpha val="0"/>
+              </a:srgbClr>
+            </a:solidFill>
+            <a:prstDash val="solid"/>
+          </a:ln>
+        </p:spPr>
+        <p:txBody>
+          <a:bodyPr xmlns:a="http://schemas.openxmlformats.org/drawingml/2006/main" lIns="0" tIns="0" rIns="0" bIns="0" anchor="t"/>
+          <a:lstStyle xmlns:a="http://schemas.openxmlformats.org/drawingml/2006/main"/>
           <a:p xmlns:a="http://schemas.openxmlformats.org/drawingml/2006/main">
             <a:pPr algn="l">
               <a:defRPr sz="975" b="0">
@@ -4966,211 +5168,9 @@
                 <a:ea typeface="Microsoft YaHei"/>
                 <a:cs typeface="Microsoft YaHei"/>
               </a:rPr>
-              <a:t>Audit Partner</a:t>
-            </a:r>
-          </a:p>
-        </p:txBody>
-      </p:sp>
-      <p:sp>
-        <p:nvSpPr>
-          <p:cNvPr id="19" name="">
-            <a:extLst xmlns:a="http://schemas.openxmlformats.org/drawingml/2006/main">
-              <a:ext uri="{FF2B5EF4-FFF2-40B4-BE49-F238E27FC236}">
-                <a16:creationId xmlns:a16="http://schemas.microsoft.com/office/drawing/2014/main" id="{DCC3B512-EABF-4AC1-9C59-82A89FDC27B9}"/>
-              </a:ext>
-            </a:extLst>
-          </p:cNvPr>
-          <p:cNvSpPr>
-            <a:spLocks xmlns:a="http://schemas.openxmlformats.org/drawingml/2006/main" noGrp="1"/>
-          </p:cNvSpPr>
-          <p:nvPr/>
-        </p:nvSpPr>
-        <p:spPr>
-          <a:xfrm xmlns:a="http://schemas.openxmlformats.org/drawingml/2006/main">
-            <a:off x="2895600" y="4591050"/>
-            <a:ext cx="266700" cy="228600"/>
-          </a:xfrm>
-          <a:prstGeom xmlns:a="http://schemas.openxmlformats.org/drawingml/2006/main" prst="rect">
-            <a:avLst/>
-          </a:prstGeom>
-          <a:solidFill xmlns:a="http://schemas.openxmlformats.org/drawingml/2006/main">
-            <a:srgbClr val="000000">
-              <a:alpha val="0"/>
-            </a:srgbClr>
-          </a:solidFill>
-          <a:ln xmlns:a="http://schemas.openxmlformats.org/drawingml/2006/main" w="0">
-            <a:solidFill>
-              <a:srgbClr val="000000">
-                <a:alpha val="0"/>
-              </a:srgbClr>
-            </a:solidFill>
-            <a:prstDash val="solid"/>
-          </a:ln>
-        </p:spPr>
-        <p:txBody>
-          <a:bodyPr xmlns:a="http://schemas.openxmlformats.org/drawingml/2006/main" lIns="0" tIns="0" rIns="0" bIns="0" anchor="t"/>
-          <a:lstStyle xmlns:a="http://schemas.openxmlformats.org/drawingml/2006/main"/>
-          <a:p xmlns:a="http://schemas.openxmlformats.org/drawingml/2006/main">
-            <a:pPr algn="ctr">
-              <a:defRPr sz="1350" b="1">
-                <a:solidFill>
-                  <a:srgbClr val="94A3B8"/>
-                </a:solidFill>
-                <a:latin typeface="Microsoft YaHei"/>
-                <a:ea typeface="Microsoft YaHei"/>
-                <a:cs typeface="Microsoft YaHei"/>
-              </a:defRPr>
-            </a:pPr>
-            <a:r>
-              <a:rPr sz="1350" b="1">
-                <a:solidFill>
-                  <a:srgbClr val="94A3B8"/>
-                </a:solidFill>
-                <a:latin typeface="Microsoft YaHei"/>
-                <a:ea typeface="Microsoft YaHei"/>
-                <a:cs typeface="Microsoft YaHei"/>
-              </a:rPr>
-              <a:t>↓</a:t>
-            </a:r>
-          </a:p>
-        </p:txBody>
-      </p:sp>
-      <p:sp>
-        <p:nvSpPr>
-          <p:cNvPr id="20" name="">
-            <a:extLst xmlns:a="http://schemas.openxmlformats.org/drawingml/2006/main">
-              <a:ext uri="{FF2B5EF4-FFF2-40B4-BE49-F238E27FC236}">
-                <a16:creationId xmlns:a16="http://schemas.microsoft.com/office/drawing/2014/main" id="{398AE5F1-1DAF-4CA9-87DB-DD315E70B55A}"/>
-              </a:ext>
-            </a:extLst>
-          </p:cNvPr>
-          <p:cNvSpPr>
-            <a:spLocks xmlns:a="http://schemas.openxmlformats.org/drawingml/2006/main" noGrp="1"/>
-          </p:cNvSpPr>
-          <p:nvPr/>
-        </p:nvSpPr>
-        <p:spPr>
-          <a:xfrm xmlns:a="http://schemas.openxmlformats.org/drawingml/2006/main">
-            <a:off x="723900" y="4819650"/>
-            <a:ext cx="4476750" cy="685800"/>
-          </a:xfrm>
-          <a:prstGeom xmlns:a="http://schemas.openxmlformats.org/drawingml/2006/main" prst="rect">
-            <a:avLst/>
-          </a:prstGeom>
-          <a:solidFill xmlns:a="http://schemas.openxmlformats.org/drawingml/2006/main">
-            <a:srgbClr val="F1F5F9"/>
-          </a:solidFill>
-          <a:ln xmlns:a="http://schemas.openxmlformats.org/drawingml/2006/main" w="9525">
-            <a:solidFill>
-              <a:srgbClr val="DBE3EF"/>
-            </a:solidFill>
-            <a:prstDash val="solid"/>
-          </a:ln>
-        </p:spPr>
-      </p:sp>
-      <p:sp>
-        <p:nvSpPr>
-          <p:cNvPr id="21" name="">
-            <a:extLst xmlns:a="http://schemas.openxmlformats.org/drawingml/2006/main">
-              <a:ext uri="{FF2B5EF4-FFF2-40B4-BE49-F238E27FC236}">
-                <a16:creationId xmlns:a16="http://schemas.microsoft.com/office/drawing/2014/main" id="{CAC48E58-72FD-4EBF-A868-069AE46678B4}"/>
-              </a:ext>
-            </a:extLst>
-          </p:cNvPr>
-          <p:cNvSpPr>
-            <a:spLocks xmlns:a="http://schemas.openxmlformats.org/drawingml/2006/main" noGrp="1"/>
-          </p:cNvSpPr>
-          <p:nvPr/>
-        </p:nvSpPr>
-        <p:spPr>
-          <a:xfrm xmlns:a="http://schemas.openxmlformats.org/drawingml/2006/main">
-            <a:off x="971550" y="4953000"/>
-            <a:ext cx="1143000" cy="209550"/>
-          </a:xfrm>
-          <a:prstGeom xmlns:a="http://schemas.openxmlformats.org/drawingml/2006/main" prst="rect">
-            <a:avLst/>
-          </a:prstGeom>
-          <a:solidFill xmlns:a="http://schemas.openxmlformats.org/drawingml/2006/main">
-            <a:srgbClr val="000000">
-              <a:alpha val="0"/>
-            </a:srgbClr>
-          </a:solidFill>
-          <a:ln xmlns:a="http://schemas.openxmlformats.org/drawingml/2006/main" w="0">
-            <a:solidFill>
-              <a:srgbClr val="000000">
-                <a:alpha val="0"/>
-              </a:srgbClr>
-            </a:solidFill>
-            <a:prstDash val="solid"/>
-          </a:ln>
-        </p:spPr>
-        <p:txBody>
-          <a:bodyPr xmlns:a="http://schemas.openxmlformats.org/drawingml/2006/main" lIns="0" tIns="0" rIns="0" bIns="0" anchor="t"/>
-          <a:lstStyle xmlns:a="http://schemas.openxmlformats.org/drawingml/2006/main"/>
-          <a:p xmlns:a="http://schemas.openxmlformats.org/drawingml/2006/main">
-            <a:pPr algn="l">
-              <a:defRPr sz="1125" b="1">
-                <a:solidFill>
-                  <a:srgbClr val="B45309"/>
-                </a:solidFill>
-                <a:latin typeface="Microsoft YaHei"/>
-                <a:ea typeface="Microsoft YaHei"/>
-                <a:cs typeface="Microsoft YaHei"/>
-              </a:defRPr>
-            </a:pPr>
-            <a:r>
-              <a:rPr sz="1125" b="1">
-                <a:solidFill>
-                  <a:srgbClr val="B45309"/>
-                </a:solidFill>
-                <a:latin typeface="Microsoft YaHei"/>
-                <a:ea typeface="Microsoft YaHei"/>
-                <a:cs typeface="Microsoft YaHei"/>
-              </a:rPr>
-              <a:t>输出层</a:t>
-            </a:r>
-          </a:p>
-        </p:txBody>
-      </p:sp>
-      <p:sp>
-        <p:nvSpPr>
-          <p:cNvPr id="22" name="">
-            <a:extLst xmlns:a="http://schemas.openxmlformats.org/drawingml/2006/main">
-              <a:ext uri="{FF2B5EF4-FFF2-40B4-BE49-F238E27FC236}">
-                <a16:creationId xmlns:a16="http://schemas.microsoft.com/office/drawing/2014/main" id="{C9E84B0E-E279-45BC-AB39-E3E7B8E46C7A}"/>
-              </a:ext>
-            </a:extLst>
-          </p:cNvPr>
-          <p:cNvSpPr>
-            <a:spLocks xmlns:a="http://schemas.openxmlformats.org/drawingml/2006/main" noGrp="1"/>
-          </p:cNvSpPr>
-          <p:nvPr/>
-        </p:nvSpPr>
-        <p:spPr>
-          <a:xfrm xmlns:a="http://schemas.openxmlformats.org/drawingml/2006/main">
-            <a:off x="2343150" y="4943475"/>
-            <a:ext cx="2476500" cy="400050"/>
-          </a:xfrm>
-          <a:prstGeom xmlns:a="http://schemas.openxmlformats.org/drawingml/2006/main" prst="rect">
-            <a:avLst/>
-          </a:prstGeom>
-          <a:solidFill xmlns:a="http://schemas.openxmlformats.org/drawingml/2006/main">
-            <a:srgbClr val="000000">
-              <a:alpha val="0"/>
-            </a:srgbClr>
-          </a:solidFill>
-          <a:ln xmlns:a="http://schemas.openxmlformats.org/drawingml/2006/main" w="0">
-            <a:solidFill>
-              <a:srgbClr val="000000">
-                <a:alpha val="0"/>
-              </a:srgbClr>
-            </a:solidFill>
-            <a:prstDash val="solid"/>
-          </a:ln>
-        </p:spPr>
-        <p:txBody>
-          <a:bodyPr xmlns:a="http://schemas.openxmlformats.org/drawingml/2006/main" lIns="0" tIns="0" rIns="0" bIns="0" anchor="t"/>
-          <a:lstStyle xmlns:a="http://schemas.openxmlformats.org/drawingml/2006/main"/>
+              <a:t>Markdown 报告</a:t>
+            </a:r>
+          </a:p>
           <a:p xmlns:a="http://schemas.openxmlformats.org/drawingml/2006/main">
             <a:pPr algn="l">
               <a:defRPr sz="975" b="0">
@@ -5191,7 +5191,7 @@
                 <a:ea typeface="Microsoft YaHei"/>
                 <a:cs typeface="Microsoft YaHei"/>
               </a:rPr>
-              <a:t>Markdown 报告</a:t>
+              <a:t>清洗后 CSV</a:t>
             </a:r>
           </a:p>
           <a:p xmlns:a="http://schemas.openxmlformats.org/drawingml/2006/main">
@@ -5214,30 +5214,7 @@
                 <a:ea typeface="Microsoft YaHei"/>
                 <a:cs typeface="Microsoft YaHei"/>
               </a:rPr>
-              <a:t>Excel 标准底稿</a:t>
-            </a:r>
-          </a:p>
-          <a:p xmlns:a="http://schemas.openxmlformats.org/drawingml/2006/main">
-            <a:pPr algn="l">
-              <a:defRPr sz="975" b="0">
-                <a:solidFill>
-                  <a:srgbClr val="0F172A"/>
-                </a:solidFill>
-                <a:latin typeface="Microsoft YaHei"/>
-                <a:ea typeface="Microsoft YaHei"/>
-                <a:cs typeface="Microsoft YaHei"/>
-              </a:defRPr>
-            </a:pPr>
-            <a:r>
-              <a:rPr sz="975" b="0">
-                <a:solidFill>
-                  <a:srgbClr val="0F172A"/>
-                </a:solidFill>
-                <a:latin typeface="Microsoft YaHei"/>
-                <a:ea typeface="Microsoft YaHei"/>
-                <a:cs typeface="Microsoft YaHei"/>
-              </a:rPr>
-              <a:t>人工复核点</a:t>
+              <a:t>AI 分析 JSON</a:t>
             </a:r>
           </a:p>
         </p:txBody>
@@ -5247,7 +5224,7 @@
           <p:cNvPr id="23" name="">
             <a:extLst xmlns:a="http://schemas.openxmlformats.org/drawingml/2006/main">
               <a:ext uri="{FF2B5EF4-FFF2-40B4-BE49-F238E27FC236}">
-                <a16:creationId xmlns:a16="http://schemas.microsoft.com/office/drawing/2014/main" id="{3DE4CB48-1360-43D6-BB37-4E2B5F5D786E}"/>
+                <a16:creationId xmlns:a16="http://schemas.microsoft.com/office/drawing/2014/main" id="{864DA4C1-5BE5-4917-B6A2-88F494241E01}"/>
               </a:ext>
             </a:extLst>
           </p:cNvPr>
@@ -5280,7 +5257,7 @@
           <p:cNvPr id="24" name="">
             <a:extLst xmlns:a="http://schemas.openxmlformats.org/drawingml/2006/main">
               <a:ext uri="{FF2B5EF4-FFF2-40B4-BE49-F238E27FC236}">
-                <a16:creationId xmlns:a16="http://schemas.microsoft.com/office/drawing/2014/main" id="{76030ED2-344C-47A3-98C7-44D5CC45B4DF}"/>
+                <a16:creationId xmlns:a16="http://schemas.microsoft.com/office/drawing/2014/main" id="{5C94C4ED-5909-4E12-9486-E16CF78CBE7E}"/>
               </a:ext>
             </a:extLst>
           </p:cNvPr>
@@ -5334,7 +5311,7 @@
                 <a:ea typeface="Consolas"/>
                 <a:cs typeface="Consolas"/>
               </a:rPr>
-              <a:t>audit_rag/</a:t>
+              <a:t>streamlit_app.py</a:t>
             </a:r>
           </a:p>
         </p:txBody>
@@ -5344,7 +5321,7 @@
           <p:cNvPr id="25" name="">
             <a:extLst xmlns:a="http://schemas.openxmlformats.org/drawingml/2006/main">
               <a:ext uri="{FF2B5EF4-FFF2-40B4-BE49-F238E27FC236}">
-                <a16:creationId xmlns:a16="http://schemas.microsoft.com/office/drawing/2014/main" id="{015E61C8-C9AA-4FB3-90CC-2254D9EE87E8}"/>
+                <a16:creationId xmlns:a16="http://schemas.microsoft.com/office/drawing/2014/main" id="{C7D89562-956A-43A4-97BA-EE21EA2724A0}"/>
               </a:ext>
             </a:extLst>
           </p:cNvPr>
@@ -5398,7 +5375,7 @@
                 <a:ea typeface="Microsoft YaHei"/>
                 <a:cs typeface="Microsoft YaHei"/>
               </a:rPr>
-              <a:t>核心能力包</a:t>
+              <a:t>课堂前端：配置、运行、结果展示</a:t>
             </a:r>
           </a:p>
         </p:txBody>
@@ -5408,7 +5385,7 @@
           <p:cNvPr id="26" name="">
             <a:extLst xmlns:a="http://schemas.openxmlformats.org/drawingml/2006/main">
               <a:ext uri="{FF2B5EF4-FFF2-40B4-BE49-F238E27FC236}">
-                <a16:creationId xmlns:a16="http://schemas.microsoft.com/office/drawing/2014/main" id="{6BCBA04E-152A-4750-AA02-A7BD78DFAC98}"/>
+                <a16:creationId xmlns:a16="http://schemas.microsoft.com/office/drawing/2014/main" id="{EFEE919A-2604-49EF-83D7-062F354A84B6}"/>
               </a:ext>
             </a:extLst>
           </p:cNvPr>
@@ -5444,9 +5421,9 @@
           <a:lstStyle xmlns:a="http://schemas.openxmlformats.org/drawingml/2006/main"/>
           <a:p xmlns:a="http://schemas.openxmlformats.org/drawingml/2006/main">
             <a:pPr algn="l">
-              <a:defRPr sz="938" b="0">
-                <a:solidFill>
-                  <a:srgbClr val="7C3AED"/>
+              <a:defRPr sz="938" b="1">
+                <a:solidFill>
+                  <a:srgbClr val="16A34A"/>
                 </a:solidFill>
                 <a:latin typeface="Consolas"/>
                 <a:ea typeface="Consolas"/>
@@ -5454,15 +5431,15 @@
               </a:defRPr>
             </a:pPr>
             <a:r>
-              <a:rPr sz="938" b="0">
-                <a:solidFill>
-                  <a:srgbClr val="7C3AED"/>
+              <a:rPr sz="938" b="1">
+                <a:solidFill>
+                  <a:srgbClr val="16A34A"/>
                 </a:solidFill>
                 <a:latin typeface="Consolas"/>
                 <a:ea typeface="Consolas"/>
                 <a:cs typeface="Consolas"/>
               </a:rPr>
-              <a:t>  agents.py</a:t>
+              <a:t>src/data_ingestion/</a:t>
             </a:r>
           </a:p>
         </p:txBody>
@@ -5472,7 +5449,7 @@
           <p:cNvPr id="27" name="">
             <a:extLst xmlns:a="http://schemas.openxmlformats.org/drawingml/2006/main">
               <a:ext uri="{FF2B5EF4-FFF2-40B4-BE49-F238E27FC236}">
-                <a16:creationId xmlns:a16="http://schemas.microsoft.com/office/drawing/2014/main" id="{BB600DC4-F287-4B46-951A-52C772082AD7}"/>
+                <a16:creationId xmlns:a16="http://schemas.microsoft.com/office/drawing/2014/main" id="{2A2E9289-3150-448A-BFBB-2FEB3D602385}"/>
               </a:ext>
             </a:extLst>
           </p:cNvPr>
@@ -5526,7 +5503,7 @@
                 <a:ea typeface="Microsoft YaHei"/>
                 <a:cs typeface="Microsoft YaHei"/>
               </a:rPr>
-              <a:t>三 Agent 提示词 / mock 响应</a:t>
+              <a:t>合成交易流水与结算计划</a:t>
             </a:r>
           </a:p>
         </p:txBody>
@@ -5536,7 +5513,7 @@
           <p:cNvPr id="28" name="">
             <a:extLst xmlns:a="http://schemas.openxmlformats.org/drawingml/2006/main">
               <a:ext uri="{FF2B5EF4-FFF2-40B4-BE49-F238E27FC236}">
-                <a16:creationId xmlns:a16="http://schemas.microsoft.com/office/drawing/2014/main" id="{EB32B0EA-914F-4AF9-ABCE-F684332CB3A6}"/>
+                <a16:creationId xmlns:a16="http://schemas.microsoft.com/office/drawing/2014/main" id="{B728A835-2D2B-491C-A98D-7DFA3B66AA37}"/>
               </a:ext>
             </a:extLst>
           </p:cNvPr>
@@ -5572,7 +5549,7 @@
           <a:lstStyle xmlns:a="http://schemas.openxmlformats.org/drawingml/2006/main"/>
           <a:p xmlns:a="http://schemas.openxmlformats.org/drawingml/2006/main">
             <a:pPr algn="l">
-              <a:defRPr sz="938" b="0">
+              <a:defRPr sz="938" b="1">
                 <a:solidFill>
                   <a:srgbClr val="16A34A"/>
                 </a:solidFill>
@@ -5582,7 +5559,7 @@
               </a:defRPr>
             </a:pPr>
             <a:r>
-              <a:rPr sz="938" b="0">
+              <a:rPr sz="938" b="1">
                 <a:solidFill>
                   <a:srgbClr val="16A34A"/>
                 </a:solidFill>
@@ -5590,7 +5567,7 @@
                 <a:ea typeface="Consolas"/>
                 <a:cs typeface="Consolas"/>
               </a:rPr>
-              <a:t>  pipeline.py</a:t>
+              <a:t>src/cleaning/</a:t>
             </a:r>
           </a:p>
         </p:txBody>
@@ -5600,7 +5577,7 @@
           <p:cNvPr id="29" name="">
             <a:extLst xmlns:a="http://schemas.openxmlformats.org/drawingml/2006/main">
               <a:ext uri="{FF2B5EF4-FFF2-40B4-BE49-F238E27FC236}">
-                <a16:creationId xmlns:a16="http://schemas.microsoft.com/office/drawing/2014/main" id="{4478CDF7-2D81-4EAD-9C17-799B4369CE9C}"/>
+                <a16:creationId xmlns:a16="http://schemas.microsoft.com/office/drawing/2014/main" id="{A387AF7D-4B16-4506-B09C-98F1286D93F1}"/>
               </a:ext>
             </a:extLst>
           </p:cNvPr>
@@ -5654,7 +5631,7 @@
                 <a:ea typeface="Microsoft YaHei"/>
                 <a:cs typeface="Microsoft YaHei"/>
               </a:rPr>
-              <a:t>流程编排：材料 → RAG → Agent</a:t>
+              <a:t>数据清洗、质量评分、异常字段</a:t>
             </a:r>
           </a:p>
         </p:txBody>
@@ -5664,7 +5641,7 @@
           <p:cNvPr id="30" name="">
             <a:extLst xmlns:a="http://schemas.openxmlformats.org/drawingml/2006/main">
               <a:ext uri="{FF2B5EF4-FFF2-40B4-BE49-F238E27FC236}">
-                <a16:creationId xmlns:a16="http://schemas.microsoft.com/office/drawing/2014/main" id="{DBCAEE74-0695-48C6-9B75-3DACF460B406}"/>
+                <a16:creationId xmlns:a16="http://schemas.microsoft.com/office/drawing/2014/main" id="{A4F6E1F4-F957-495F-B90B-77501B2E6277}"/>
               </a:ext>
             </a:extLst>
           </p:cNvPr>
@@ -5700,9 +5677,9 @@
           <a:lstStyle xmlns:a="http://schemas.openxmlformats.org/drawingml/2006/main"/>
           <a:p xmlns:a="http://schemas.openxmlformats.org/drawingml/2006/main">
             <a:pPr algn="l">
-              <a:defRPr sz="938" b="0">
-                <a:solidFill>
-                  <a:srgbClr val="16A34A"/>
+              <a:defRPr sz="938" b="1">
+                <a:solidFill>
+                  <a:srgbClr val="B45309"/>
                 </a:solidFill>
                 <a:latin typeface="Consolas"/>
                 <a:ea typeface="Consolas"/>
@@ -5710,15 +5687,15 @@
               </a:defRPr>
             </a:pPr>
             <a:r>
-              <a:rPr sz="938" b="0">
-                <a:solidFill>
-                  <a:srgbClr val="16A34A"/>
+              <a:rPr sz="938" b="1">
+                <a:solidFill>
+                  <a:srgbClr val="B45309"/>
                 </a:solidFill>
                 <a:latin typeface="Consolas"/>
                 <a:ea typeface="Consolas"/>
                 <a:cs typeface="Consolas"/>
               </a:rPr>
-              <a:t>  rag.py</a:t>
+              <a:t>src/audit/</a:t>
             </a:r>
           </a:p>
         </p:txBody>
@@ -5728,7 +5705,7 @@
           <p:cNvPr id="31" name="">
             <a:extLst xmlns:a="http://schemas.openxmlformats.org/drawingml/2006/main">
               <a:ext uri="{FF2B5EF4-FFF2-40B4-BE49-F238E27FC236}">
-                <a16:creationId xmlns:a16="http://schemas.microsoft.com/office/drawing/2014/main" id="{53D10702-36C4-463E-A651-598BBE1FBAA9}"/>
+                <a16:creationId xmlns:a16="http://schemas.microsoft.com/office/drawing/2014/main" id="{1EFB6B50-1A7A-4E98-BE3C-2C50D95A1587}"/>
               </a:ext>
             </a:extLst>
           </p:cNvPr>
@@ -5782,7 +5759,7 @@
                 <a:ea typeface="Microsoft YaHei"/>
                 <a:cs typeface="Microsoft YaHei"/>
               </a:rPr>
-              <a:t>ChromaDB 检索 + 关键词 fallback</a:t>
+              <a:t>ISA 240/520 规则扫描</a:t>
             </a:r>
           </a:p>
         </p:txBody>
@@ -5792,7 +5769,7 @@
           <p:cNvPr id="32" name="">
             <a:extLst xmlns:a="http://schemas.openxmlformats.org/drawingml/2006/main">
               <a:ext uri="{FF2B5EF4-FFF2-40B4-BE49-F238E27FC236}">
-                <a16:creationId xmlns:a16="http://schemas.microsoft.com/office/drawing/2014/main" id="{B2F0D03C-5144-42A9-9DF6-97369916F119}"/>
+                <a16:creationId xmlns:a16="http://schemas.microsoft.com/office/drawing/2014/main" id="{1A9937E8-59A4-4325-BF1A-28CD727C8FC2}"/>
               </a:ext>
             </a:extLst>
           </p:cNvPr>
@@ -5828,9 +5805,9 @@
           <a:lstStyle xmlns:a="http://schemas.openxmlformats.org/drawingml/2006/main"/>
           <a:p xmlns:a="http://schemas.openxmlformats.org/drawingml/2006/main">
             <a:pPr algn="l">
-              <a:defRPr sz="938" b="0">
-                <a:solidFill>
-                  <a:srgbClr val="B45309"/>
+              <a:defRPr sz="938" b="1">
+                <a:solidFill>
+                  <a:srgbClr val="7C3AED"/>
                 </a:solidFill>
                 <a:latin typeface="Consolas"/>
                 <a:ea typeface="Consolas"/>
@@ -5838,15 +5815,15 @@
               </a:defRPr>
             </a:pPr>
             <a:r>
-              <a:rPr sz="938" b="0">
-                <a:solidFill>
-                  <a:srgbClr val="B45309"/>
+              <a:rPr sz="938" b="1">
+                <a:solidFill>
+                  <a:srgbClr val="7C3AED"/>
                 </a:solidFill>
                 <a:latin typeface="Consolas"/>
                 <a:ea typeface="Consolas"/>
                 <a:cs typeface="Consolas"/>
               </a:rPr>
-              <a:t>  data_tools.py</a:t>
+              <a:t>src/llm/</a:t>
             </a:r>
           </a:p>
         </p:txBody>
@@ -5856,7 +5833,7 @@
           <p:cNvPr id="33" name="">
             <a:extLst xmlns:a="http://schemas.openxmlformats.org/drawingml/2006/main">
               <a:ext uri="{FF2B5EF4-FFF2-40B4-BE49-F238E27FC236}">
-                <a16:creationId xmlns:a16="http://schemas.microsoft.com/office/drawing/2014/main" id="{FB157516-5368-476A-8C4F-64F252CEB1A1}"/>
+                <a16:creationId xmlns:a16="http://schemas.microsoft.com/office/drawing/2014/main" id="{1946F957-BDF1-48BB-B3C3-31DF5EC17B8B}"/>
               </a:ext>
             </a:extLst>
           </p:cNvPr>
@@ -5910,7 +5887,7 @@
                 <a:ea typeface="Microsoft YaHei"/>
                 <a:cs typeface="Microsoft YaHei"/>
               </a:rPr>
-              <a:t>凭证加载与风险规则扫描</a:t>
+              <a:t>DeepSeek 分类、叙述、资金核对</a:t>
             </a:r>
           </a:p>
         </p:txBody>
@@ -5920,7 +5897,7 @@
           <p:cNvPr id="34" name="">
             <a:extLst xmlns:a="http://schemas.openxmlformats.org/drawingml/2006/main">
               <a:ext uri="{FF2B5EF4-FFF2-40B4-BE49-F238E27FC236}">
-                <a16:creationId xmlns:a16="http://schemas.microsoft.com/office/drawing/2014/main" id="{EC940456-FA5E-47FA-99DB-D574411A13DD}"/>
+                <a16:creationId xmlns:a16="http://schemas.microsoft.com/office/drawing/2014/main" id="{415597DA-4829-49E6-867F-70A86417ADA2}"/>
               </a:ext>
             </a:extLst>
           </p:cNvPr>
@@ -5956,7 +5933,7 @@
           <a:lstStyle xmlns:a="http://schemas.openxmlformats.org/drawingml/2006/main"/>
           <a:p xmlns:a="http://schemas.openxmlformats.org/drawingml/2006/main">
             <a:pPr algn="l">
-              <a:defRPr sz="938" b="0">
+              <a:defRPr sz="938" b="1">
                 <a:solidFill>
                   <a:srgbClr val="2563EB"/>
                 </a:solidFill>
@@ -5966,7 +5943,7 @@
               </a:defRPr>
             </a:pPr>
             <a:r>
-              <a:rPr sz="938" b="0">
+              <a:rPr sz="938" b="1">
                 <a:solidFill>
                   <a:srgbClr val="2563EB"/>
                 </a:solidFill>
@@ -5974,7 +5951,7 @@
                 <a:ea typeface="Consolas"/>
                 <a:cs typeface="Consolas"/>
               </a:rPr>
-              <a:t>  reporting.py</a:t>
+              <a:t>src/reporting/</a:t>
             </a:r>
           </a:p>
         </p:txBody>
@@ -5984,7 +5961,7 @@
           <p:cNvPr id="35" name="">
             <a:extLst xmlns:a="http://schemas.openxmlformats.org/drawingml/2006/main">
               <a:ext uri="{FF2B5EF4-FFF2-40B4-BE49-F238E27FC236}">
-                <a16:creationId xmlns:a16="http://schemas.microsoft.com/office/drawing/2014/main" id="{D3B27034-6088-4644-B5FE-3082FC061F26}"/>
+                <a16:creationId xmlns:a16="http://schemas.microsoft.com/office/drawing/2014/main" id="{2BE19E37-5088-4376-BEB5-D32BD6ABABD7}"/>
               </a:ext>
             </a:extLst>
           </p:cNvPr>
@@ -6038,7 +6015,7 @@
                 <a:ea typeface="Microsoft YaHei"/>
                 <a:cs typeface="Microsoft YaHei"/>
               </a:rPr>
-              <a:t>Markdown 工作底稿草稿</a:t>
+              <a:t>Markdown 报告与图表</a:t>
             </a:r>
           </a:p>
         </p:txBody>
@@ -6048,7 +6025,7 @@
           <p:cNvPr id="36" name="">
             <a:extLst xmlns:a="http://schemas.openxmlformats.org/drawingml/2006/main">
               <a:ext uri="{FF2B5EF4-FFF2-40B4-BE49-F238E27FC236}">
-                <a16:creationId xmlns:a16="http://schemas.microsoft.com/office/drawing/2014/main" id="{9CE19602-4166-48E8-A76E-2E8CEB3076D2}"/>
+                <a16:creationId xmlns:a16="http://schemas.microsoft.com/office/drawing/2014/main" id="{CFBD88B8-0E70-4948-BAE8-7EC5C8C28E19}"/>
               </a:ext>
             </a:extLst>
           </p:cNvPr>
@@ -6086,7 +6063,7 @@
             <a:pPr algn="l">
               <a:defRPr sz="938" b="1">
                 <a:solidFill>
-                  <a:srgbClr val="2563EB"/>
+                  <a:srgbClr val="7C3AED"/>
                 </a:solidFill>
                 <a:latin typeface="Consolas"/>
                 <a:ea typeface="Consolas"/>
@@ -6096,13 +6073,13 @@
             <a:r>
               <a:rPr sz="938" b="1">
                 <a:solidFill>
-                  <a:srgbClr val="2563EB"/>
+                  <a:srgbClr val="7C3AED"/>
                 </a:solidFill>
                 <a:latin typeface="Consolas"/>
                 <a:ea typeface="Consolas"/>
                 <a:cs typeface="Consolas"/>
               </a:rPr>
-              <a:t>cli.py / streamlit_app.py</a:t>
+              <a:t>audit_rag/</a:t>
             </a:r>
           </a:p>
         </p:txBody>
@@ -6112,7 +6089,7 @@
           <p:cNvPr id="37" name="">
             <a:extLst xmlns:a="http://schemas.openxmlformats.org/drawingml/2006/main">
               <a:ext uri="{FF2B5EF4-FFF2-40B4-BE49-F238E27FC236}">
-                <a16:creationId xmlns:a16="http://schemas.microsoft.com/office/drawing/2014/main" id="{A1AD2FD2-0FDF-4A3E-A793-45A68E5FA402}"/>
+                <a16:creationId xmlns:a16="http://schemas.microsoft.com/office/drawing/2014/main" id="{1322FD45-DED4-4C51-8283-E4AAB0D6BA8F}"/>
               </a:ext>
             </a:extLst>
           </p:cNvPr>
@@ -6166,7 +6143,7 @@
                 <a:ea typeface="Microsoft YaHei"/>
                 <a:cs typeface="Microsoft YaHei"/>
               </a:rPr>
-              <a:t>命令行入口 / 课堂前端</a:t>
+              <a:t>多 Agent + RAG 原型层</a:t>
             </a:r>
           </a:p>
         </p:txBody>
@@ -6176,7 +6153,7 @@
           <p:cNvPr id="38" name="">
             <a:extLst xmlns:a="http://schemas.openxmlformats.org/drawingml/2006/main">
               <a:ext uri="{FF2B5EF4-FFF2-40B4-BE49-F238E27FC236}">
-                <a16:creationId xmlns:a16="http://schemas.microsoft.com/office/drawing/2014/main" id="{9C7D23ED-FD93-4EEA-966A-37E2FE93E9A4}"/>
+                <a16:creationId xmlns:a16="http://schemas.microsoft.com/office/drawing/2014/main" id="{65C35CF9-770C-4729-9CAA-12DDFB30DF43}"/>
               </a:ext>
             </a:extLst>
           </p:cNvPr>
@@ -6214,7 +6191,7 @@
             <a:pPr algn="l">
               <a:defRPr sz="938" b="1">
                 <a:solidFill>
-                  <a:srgbClr val="DC2626"/>
+                  <a:srgbClr val="2563EB"/>
                 </a:solidFill>
                 <a:latin typeface="Consolas"/>
                 <a:ea typeface="Consolas"/>
@@ -6224,13 +6201,13 @@
             <a:r>
               <a:rPr sz="938" b="1">
                 <a:solidFill>
-                  <a:srgbClr val="DC2626"/>
+                  <a:srgbClr val="2563EB"/>
                 </a:solidFill>
                 <a:latin typeface="Consolas"/>
                 <a:ea typeface="Consolas"/>
                 <a:cs typeface="Consolas"/>
               </a:rPr>
-              <a:t>benchmarks/</a:t>
+              <a:t>cli.py</a:t>
             </a:r>
           </a:p>
         </p:txBody>
@@ -6240,7 +6217,7 @@
           <p:cNvPr id="39" name="">
             <a:extLst xmlns:a="http://schemas.openxmlformats.org/drawingml/2006/main">
               <a:ext uri="{FF2B5EF4-FFF2-40B4-BE49-F238E27FC236}">
-                <a16:creationId xmlns:a16="http://schemas.microsoft.com/office/drawing/2014/main" id="{8B471205-8FC0-4A7E-917D-31AC42129521}"/>
+                <a16:creationId xmlns:a16="http://schemas.microsoft.com/office/drawing/2014/main" id="{4CA8EFCC-1311-460D-8A62-7A19E6ECCF31}"/>
               </a:ext>
             </a:extLst>
           </p:cNvPr>
@@ -6294,7 +6271,7 @@
                 <a:ea typeface="Microsoft YaHei"/>
                 <a:cs typeface="Microsoft YaHei"/>
               </a:rPr>
-              <a:t>合成材料与隔离评测设计</a:t>
+              <a:t>doctor / where / run / search</a:t>
             </a:r>
           </a:p>
         </p:txBody>
@@ -6304,7 +6281,7 @@
           <p:cNvPr id="40" name="">
             <a:extLst xmlns:a="http://schemas.openxmlformats.org/drawingml/2006/main">
               <a:ext uri="{FF2B5EF4-FFF2-40B4-BE49-F238E27FC236}">
-                <a16:creationId xmlns:a16="http://schemas.microsoft.com/office/drawing/2014/main" id="{4FC5E105-6A2D-46F0-A113-B8F5B696F620}"/>
+                <a16:creationId xmlns:a16="http://schemas.microsoft.com/office/drawing/2014/main" id="{9E5AED87-156E-4D3B-8D8B-CDCEC70C10EF}"/>
               </a:ext>
             </a:extLst>
           </p:cNvPr>
@@ -6358,7 +6335,7 @@
                 <a:ea typeface="Consolas"/>
                 <a:cs typeface="Consolas"/>
               </a:rPr>
-              <a:t>outputs/</a:t>
+              <a:t>output/</a:t>
             </a:r>
           </a:p>
         </p:txBody>
@@ -6368,7 +6345,7 @@
           <p:cNvPr id="41" name="">
             <a:extLst xmlns:a="http://schemas.openxmlformats.org/drawingml/2006/main">
               <a:ext uri="{FF2B5EF4-FFF2-40B4-BE49-F238E27FC236}">
-                <a16:creationId xmlns:a16="http://schemas.microsoft.com/office/drawing/2014/main" id="{8BB01DED-0722-44D8-8FD6-76325D553EEC}"/>
+                <a16:creationId xmlns:a16="http://schemas.microsoft.com/office/drawing/2014/main" id="{957CEEBE-614A-41EA-977D-112294A0CFC4}"/>
               </a:ext>
             </a:extLst>
           </p:cNvPr>
@@ -6422,7 +6399,7 @@
                 <a:ea typeface="Microsoft YaHei"/>
                 <a:cs typeface="Microsoft YaHei"/>
               </a:rPr>
-              <a:t>生成报告与 Excel 底稿</a:t>
+              <a:t>报告、图表、清洗后数据</a:t>
             </a:r>
           </a:p>
         </p:txBody>
@@ -6432,7 +6409,7 @@
           <p:cNvPr id="42" name="">
             <a:extLst xmlns:a="http://schemas.openxmlformats.org/drawingml/2006/main">
               <a:ext uri="{FF2B5EF4-FFF2-40B4-BE49-F238E27FC236}">
-                <a16:creationId xmlns:a16="http://schemas.microsoft.com/office/drawing/2014/main" id="{028336D2-262C-4FDB-9BE8-6145E68F517A}"/>
+                <a16:creationId xmlns:a16="http://schemas.microsoft.com/office/drawing/2014/main" id="{5EF40863-0F98-4E63-9B45-C08344095682}"/>
               </a:ext>
             </a:extLst>
           </p:cNvPr>
@@ -6496,7 +6473,7 @@
           <p:cNvPr id="43" name="">
             <a:extLst xmlns:a="http://schemas.openxmlformats.org/drawingml/2006/main">
               <a:ext uri="{FF2B5EF4-FFF2-40B4-BE49-F238E27FC236}">
-                <a16:creationId xmlns:a16="http://schemas.microsoft.com/office/drawing/2014/main" id="{5D7135D9-5C21-469D-AEBD-5ADF902163D3}"/>
+                <a16:creationId xmlns:a16="http://schemas.microsoft.com/office/drawing/2014/main" id="{EF031767-B099-47AF-A9AC-72E67E0907AC}"/>
               </a:ext>
             </a:extLst>
           </p:cNvPr>
@@ -6560,7 +6537,7 @@
           <p:cNvPr id="44" name="">
             <a:extLst xmlns:a="http://schemas.openxmlformats.org/drawingml/2006/main">
               <a:ext uri="{FF2B5EF4-FFF2-40B4-BE49-F238E27FC236}">
-                <a16:creationId xmlns:a16="http://schemas.microsoft.com/office/drawing/2014/main" id="{83EC45CD-1876-471F-A6E4-AC4259CECF92}"/>
+                <a16:creationId xmlns:a16="http://schemas.microsoft.com/office/drawing/2014/main" id="{9F5D7735-937D-4AED-8FD6-8DC896B29207}"/>
               </a:ext>
             </a:extLst>
           </p:cNvPr>
@@ -6593,7 +6570,7 @@
           <p:cNvPr id="45" name="">
             <a:extLst xmlns:a="http://schemas.openxmlformats.org/drawingml/2006/main">
               <a:ext uri="{FF2B5EF4-FFF2-40B4-BE49-F238E27FC236}">
-                <a16:creationId xmlns:a16="http://schemas.microsoft.com/office/drawing/2014/main" id="{30CE3280-5ABC-479D-BB94-D5F35D85D991}"/>
+                <a16:creationId xmlns:a16="http://schemas.microsoft.com/office/drawing/2014/main" id="{E854F7EE-6C6E-4977-9B06-13EF16C5505F}"/>
               </a:ext>
             </a:extLst>
           </p:cNvPr>
@@ -6657,7 +6634,7 @@
           <p:cNvPr id="46" name="">
             <a:extLst xmlns:a="http://schemas.openxmlformats.org/drawingml/2006/main">
               <a:ext uri="{FF2B5EF4-FFF2-40B4-BE49-F238E27FC236}">
-                <a16:creationId xmlns:a16="http://schemas.microsoft.com/office/drawing/2014/main" id="{16CD16B3-C5C5-4E93-A0EA-CA406BEFE80A}"/>
+                <a16:creationId xmlns:a16="http://schemas.microsoft.com/office/drawing/2014/main" id="{E0902DBB-6B85-4592-8C28-C19AEBB484FF}"/>
               </a:ext>
             </a:extLst>
           </p:cNvPr>
@@ -6721,7 +6698,7 @@
           <p:cNvPr id="47" name="">
             <a:extLst xmlns:a="http://schemas.openxmlformats.org/drawingml/2006/main">
               <a:ext uri="{FF2B5EF4-FFF2-40B4-BE49-F238E27FC236}">
-                <a16:creationId xmlns:a16="http://schemas.microsoft.com/office/drawing/2014/main" id="{26B58FCF-E4A2-4A84-83CE-AD3D5DAAF22C}"/>
+                <a16:creationId xmlns:a16="http://schemas.microsoft.com/office/drawing/2014/main" id="{0A83CEF7-B2C2-4CB0-8D6D-B4069AF27DA6}"/>
               </a:ext>
             </a:extLst>
           </p:cNvPr>
@@ -6783,7 +6760,7 @@
     </p:spTree>
     <p:extLst>
       <p:ext uri="{BB962C8B-B14F-4D97-AF65-F5344CB8AC3E}">
-        <p14:creationId xmlns:p14="http://schemas.microsoft.com/office/powerpoint/2010/main" val="1448375119"/>
+        <p14:creationId xmlns:p14="http://schemas.microsoft.com/office/powerpoint/2010/main" val="2030247783"/>
       </p:ext>
     </p:extLst>
   </p:cSld>
@@ -6807,7 +6784,7 @@
           <p:cNvPr id="1" name="">
             <a:extLst xmlns:a="http://schemas.openxmlformats.org/drawingml/2006/main">
               <a:ext uri="{FF2B5EF4-FFF2-40B4-BE49-F238E27FC236}">
-                <a16:creationId xmlns:a16="http://schemas.microsoft.com/office/drawing/2014/main" id="{069EEC93-7E55-4370-BC05-5C48D36351CA}"/>
+                <a16:creationId xmlns:a16="http://schemas.microsoft.com/office/drawing/2014/main" id="{31261CBC-A9AA-49CC-A263-308DE3306869}"/>
               </a:ext>
             </a:extLst>
           </p:cNvPr>
@@ -6846,7 +6823,7 @@
           <p:nvPr/>
         </p:nvPicPr>
         <p:blipFill>
-          <a:blip xmlns:r="http://schemas.openxmlformats.org/officeDocument/2006/relationships" xmlns:a="http://schemas.openxmlformats.org/drawingml/2006/main" r:embed="Ra3a0a80016154ced"/>
+          <a:blip xmlns:r="http://schemas.openxmlformats.org/officeDocument/2006/relationships" xmlns:a="http://schemas.openxmlformats.org/drawingml/2006/main" r:embed="Rd12edb0fc08b4d0a"/>
           <a:stretch xmlns:a="http://schemas.openxmlformats.org/drawingml/2006/main"/>
         </p:blipFill>
         <p:spPr>
@@ -6864,7 +6841,7 @@
           <p:cNvPr id="3" name="">
             <a:extLst xmlns:a="http://schemas.openxmlformats.org/drawingml/2006/main">
               <a:ext uri="{FF2B5EF4-FFF2-40B4-BE49-F238E27FC236}">
-                <a16:creationId xmlns:a16="http://schemas.microsoft.com/office/drawing/2014/main" id="{CFB9B1A6-0C5F-40AA-AA61-3C4814F1B3B3}"/>
+                <a16:creationId xmlns:a16="http://schemas.microsoft.com/office/drawing/2014/main" id="{A0327A14-845C-4737-8B52-6A708FCCFC68}"/>
               </a:ext>
             </a:extLst>
           </p:cNvPr>
@@ -6928,7 +6905,7 @@
           <p:cNvPr id="4" name="">
             <a:extLst xmlns:a="http://schemas.openxmlformats.org/drawingml/2006/main">
               <a:ext uri="{FF2B5EF4-FFF2-40B4-BE49-F238E27FC236}">
-                <a16:creationId xmlns:a16="http://schemas.microsoft.com/office/drawing/2014/main" id="{DE15308D-117B-41F8-80E1-62E91FE69F7A}"/>
+                <a16:creationId xmlns:a16="http://schemas.microsoft.com/office/drawing/2014/main" id="{A87ECF43-B978-4B18-A742-1A6712CE7096}"/>
               </a:ext>
             </a:extLst>
           </p:cNvPr>
@@ -6982,7 +6959,7 @@
                 <a:ea typeface="Microsoft YaHei"/>
                 <a:cs typeface="Microsoft YaHei"/>
               </a:rPr>
-              <a:t>这个项目的价值不是证明 Agent 可以全自动审计，而是证明它能在确定流程里承担可复核的高频工作。</a:t>
+              <a:t>这个项目的价值不是证明 Agent 可以全自动审计，而是证明它能在资金流场景里先做可复核的异常扫描和风险叙述。</a:t>
             </a:r>
           </a:p>
         </p:txBody>
@@ -6992,7 +6969,7 @@
           <p:cNvPr id="5" name="">
             <a:extLst xmlns:a="http://schemas.openxmlformats.org/drawingml/2006/main">
               <a:ext uri="{FF2B5EF4-FFF2-40B4-BE49-F238E27FC236}">
-                <a16:creationId xmlns:a16="http://schemas.microsoft.com/office/drawing/2014/main" id="{B7D4BDAF-2052-423C-8323-BEFE877DEC59}"/>
+                <a16:creationId xmlns:a16="http://schemas.microsoft.com/office/drawing/2014/main" id="{205EECD2-230E-4149-B4D8-81A62DE33398}"/>
               </a:ext>
             </a:extLst>
           </p:cNvPr>
@@ -7025,7 +7002,7 @@
           <p:cNvPr id="6" name="">
             <a:extLst xmlns:a="http://schemas.openxmlformats.org/drawingml/2006/main">
               <a:ext uri="{FF2B5EF4-FFF2-40B4-BE49-F238E27FC236}">
-                <a16:creationId xmlns:a16="http://schemas.microsoft.com/office/drawing/2014/main" id="{546C637A-47AF-4385-BFF6-08D850F62D67}"/>
+                <a16:creationId xmlns:a16="http://schemas.microsoft.com/office/drawing/2014/main" id="{54D7DEDB-D459-42F6-AEFF-E9FD4B54C7E1}"/>
               </a:ext>
             </a:extLst>
           </p:cNvPr>
@@ -7060,7 +7037,7 @@
           <p:cNvPr id="7" name="">
             <a:extLst xmlns:a="http://schemas.openxmlformats.org/drawingml/2006/main">
               <a:ext uri="{FF2B5EF4-FFF2-40B4-BE49-F238E27FC236}">
-                <a16:creationId xmlns:a16="http://schemas.microsoft.com/office/drawing/2014/main" id="{363B02EB-7E75-48EA-9ED3-BABF09324FD8}"/>
+                <a16:creationId xmlns:a16="http://schemas.microsoft.com/office/drawing/2014/main" id="{2C775C4D-CF55-48D6-B99A-C029415722C4}"/>
               </a:ext>
             </a:extLst>
           </p:cNvPr>
@@ -7124,7 +7101,7 @@
           <p:cNvPr id="8" name="">
             <a:extLst xmlns:a="http://schemas.openxmlformats.org/drawingml/2006/main">
               <a:ext uri="{FF2B5EF4-FFF2-40B4-BE49-F238E27FC236}">
-                <a16:creationId xmlns:a16="http://schemas.microsoft.com/office/drawing/2014/main" id="{F4441C1E-1341-4F04-8B2E-D8FE3068C5AB}"/>
+                <a16:creationId xmlns:a16="http://schemas.microsoft.com/office/drawing/2014/main" id="{B67BDDA8-F137-46E0-968C-F7FE9B22F23C}"/>
               </a:ext>
             </a:extLst>
           </p:cNvPr>
@@ -7188,7 +7165,7 @@
           <p:cNvPr id="9" name="">
             <a:extLst xmlns:a="http://schemas.openxmlformats.org/drawingml/2006/main">
               <a:ext uri="{FF2B5EF4-FFF2-40B4-BE49-F238E27FC236}">
-                <a16:creationId xmlns:a16="http://schemas.microsoft.com/office/drawing/2014/main" id="{C7BA7BF0-3627-4BE3-966A-0EDF1CEB1EB4}"/>
+                <a16:creationId xmlns:a16="http://schemas.microsoft.com/office/drawing/2014/main" id="{F739E90F-AFD0-48EA-BF09-AD402D7AB278}"/>
               </a:ext>
             </a:extLst>
           </p:cNvPr>
@@ -7221,7 +7198,7 @@
           <p:cNvPr id="10" name="">
             <a:extLst xmlns:a="http://schemas.openxmlformats.org/drawingml/2006/main">
               <a:ext uri="{FF2B5EF4-FFF2-40B4-BE49-F238E27FC236}">
-                <a16:creationId xmlns:a16="http://schemas.microsoft.com/office/drawing/2014/main" id="{9A7D493A-9544-4327-9185-24F61DD0D94A}"/>
+                <a16:creationId xmlns:a16="http://schemas.microsoft.com/office/drawing/2014/main" id="{B8FDF8B9-4FA7-4F11-94F5-B95BD83BD877}"/>
               </a:ext>
             </a:extLst>
           </p:cNvPr>
@@ -7256,7 +7233,7 @@
           <p:cNvPr id="11" name="">
             <a:extLst xmlns:a="http://schemas.openxmlformats.org/drawingml/2006/main">
               <a:ext uri="{FF2B5EF4-FFF2-40B4-BE49-F238E27FC236}">
-                <a16:creationId xmlns:a16="http://schemas.microsoft.com/office/drawing/2014/main" id="{287C0670-F7E3-4E14-8913-AE3E7A5DC73B}"/>
+                <a16:creationId xmlns:a16="http://schemas.microsoft.com/office/drawing/2014/main" id="{ABCF7930-2785-4B9F-8981-F92C2D62E908}"/>
               </a:ext>
             </a:extLst>
           </p:cNvPr>
@@ -7320,7 +7297,7 @@
           <p:cNvPr id="12" name="">
             <a:extLst xmlns:a="http://schemas.openxmlformats.org/drawingml/2006/main">
               <a:ext uri="{FF2B5EF4-FFF2-40B4-BE49-F238E27FC236}">
-                <a16:creationId xmlns:a16="http://schemas.microsoft.com/office/drawing/2014/main" id="{4F8AECDF-DC53-4F6F-9978-240B3DAB4C5D}"/>
+                <a16:creationId xmlns:a16="http://schemas.microsoft.com/office/drawing/2014/main" id="{7EBDE3DD-EE58-4FD5-9BB7-2CACB17291EC}"/>
               </a:ext>
             </a:extLst>
           </p:cNvPr>
@@ -7374,7 +7351,7 @@
                 <a:ea typeface="Microsoft YaHei"/>
                 <a:cs typeface="Microsoft YaHei"/>
               </a:rPr>
-              <a:t>和真实审计师底稿做差异分析</a:t>
+              <a:t>和审计人员风险判断做差异分析</a:t>
             </a:r>
           </a:p>
         </p:txBody>
@@ -7384,7 +7361,7 @@
           <p:cNvPr id="13" name="">
             <a:extLst xmlns:a="http://schemas.openxmlformats.org/drawingml/2006/main">
               <a:ext uri="{FF2B5EF4-FFF2-40B4-BE49-F238E27FC236}">
-                <a16:creationId xmlns:a16="http://schemas.microsoft.com/office/drawing/2014/main" id="{1461E2D5-2E35-47BD-8030-7ABC856DB3F4}"/>
+                <a16:creationId xmlns:a16="http://schemas.microsoft.com/office/drawing/2014/main" id="{4059FF7A-35F1-42E9-843F-0D4E287FA18B}"/>
               </a:ext>
             </a:extLst>
           </p:cNvPr>
@@ -7417,7 +7394,7 @@
           <p:cNvPr id="14" name="">
             <a:extLst xmlns:a="http://schemas.openxmlformats.org/drawingml/2006/main">
               <a:ext uri="{FF2B5EF4-FFF2-40B4-BE49-F238E27FC236}">
-                <a16:creationId xmlns:a16="http://schemas.microsoft.com/office/drawing/2014/main" id="{AD13B0AB-9670-4F41-A0AC-DDA551FC8CEB}"/>
+                <a16:creationId xmlns:a16="http://schemas.microsoft.com/office/drawing/2014/main" id="{B8B8046A-F2B9-44C3-9357-EA5809E85683}"/>
               </a:ext>
             </a:extLst>
           </p:cNvPr>
@@ -7452,7 +7429,7 @@
           <p:cNvPr id="15" name="">
             <a:extLst xmlns:a="http://schemas.openxmlformats.org/drawingml/2006/main">
               <a:ext uri="{FF2B5EF4-FFF2-40B4-BE49-F238E27FC236}">
-                <a16:creationId xmlns:a16="http://schemas.microsoft.com/office/drawing/2014/main" id="{23B654F4-7987-49DD-8D2F-3AFA19482232}"/>
+                <a16:creationId xmlns:a16="http://schemas.microsoft.com/office/drawing/2014/main" id="{DE0D15E9-A3AA-4B69-B4C9-6A4ED8FD0004}"/>
               </a:ext>
             </a:extLst>
           </p:cNvPr>
@@ -7506,7 +7483,7 @@
                 <a:ea typeface="Microsoft YaHei"/>
                 <a:cs typeface="Microsoft YaHei"/>
               </a:rPr>
-              <a:t>底稿扩展</a:t>
+              <a:t>场景扩展</a:t>
             </a:r>
           </a:p>
         </p:txBody>
@@ -7516,7 +7493,7 @@
           <p:cNvPr id="16" name="">
             <a:extLst xmlns:a="http://schemas.openxmlformats.org/drawingml/2006/main">
               <a:ext uri="{FF2B5EF4-FFF2-40B4-BE49-F238E27FC236}">
-                <a16:creationId xmlns:a16="http://schemas.microsoft.com/office/drawing/2014/main" id="{86B9CDC6-8629-4E06-99FC-506D4385978C}"/>
+                <a16:creationId xmlns:a16="http://schemas.microsoft.com/office/drawing/2014/main" id="{7AA3C4BC-6DC7-4B1C-90D7-3F4459A9FB42}"/>
               </a:ext>
             </a:extLst>
           </p:cNvPr>
@@ -7570,7 +7547,7 @@
                 <a:ea typeface="Microsoft YaHei"/>
                 <a:cs typeface="Microsoft YaHei"/>
               </a:rPr>
-              <a:t>应收、存货、收入截止</a:t>
+              <a:t>更多平台、币种、物流和税务数据</a:t>
             </a:r>
           </a:p>
         </p:txBody>
@@ -7580,7 +7557,7 @@
           <p:cNvPr id="17" name="">
             <a:extLst xmlns:a="http://schemas.openxmlformats.org/drawingml/2006/main">
               <a:ext uri="{FF2B5EF4-FFF2-40B4-BE49-F238E27FC236}">
-                <a16:creationId xmlns:a16="http://schemas.microsoft.com/office/drawing/2014/main" id="{96EE72B0-148F-437C-AED7-1EE63A8568BD}"/>
+                <a16:creationId xmlns:a16="http://schemas.microsoft.com/office/drawing/2014/main" id="{F7705662-B2DC-4855-89A6-1D893869D82C}"/>
               </a:ext>
             </a:extLst>
           </p:cNvPr>
@@ -7613,7 +7590,7 @@
           <p:cNvPr id="18" name="">
             <a:extLst xmlns:a="http://schemas.openxmlformats.org/drawingml/2006/main">
               <a:ext uri="{FF2B5EF4-FFF2-40B4-BE49-F238E27FC236}">
-                <a16:creationId xmlns:a16="http://schemas.microsoft.com/office/drawing/2014/main" id="{522861ED-2417-4F35-86E5-9EEF260B5ACD}"/>
+                <a16:creationId xmlns:a16="http://schemas.microsoft.com/office/drawing/2014/main" id="{0AA7D711-5DCD-4E04-BE91-A92B8C89620A}"/>
               </a:ext>
             </a:extLst>
           </p:cNvPr>
@@ -7648,7 +7625,7 @@
           <p:cNvPr id="19" name="">
             <a:extLst xmlns:a="http://schemas.openxmlformats.org/drawingml/2006/main">
               <a:ext uri="{FF2B5EF4-FFF2-40B4-BE49-F238E27FC236}">
-                <a16:creationId xmlns:a16="http://schemas.microsoft.com/office/drawing/2014/main" id="{F02EF13F-E64E-43FB-B4B9-55A6B2C98A11}"/>
+                <a16:creationId xmlns:a16="http://schemas.microsoft.com/office/drawing/2014/main" id="{DFBC67A4-FD17-416D-925D-54D5E93DC380}"/>
               </a:ext>
             </a:extLst>
           </p:cNvPr>
@@ -7712,7 +7689,7 @@
           <p:cNvPr id="20" name="">
             <a:extLst xmlns:a="http://schemas.openxmlformats.org/drawingml/2006/main">
               <a:ext uri="{FF2B5EF4-FFF2-40B4-BE49-F238E27FC236}">
-                <a16:creationId xmlns:a16="http://schemas.microsoft.com/office/drawing/2014/main" id="{54DB80B5-5EE0-4BF9-90DE-82965061C57B}"/>
+                <a16:creationId xmlns:a16="http://schemas.microsoft.com/office/drawing/2014/main" id="{461DAFE7-7D5A-4DD0-B24C-F95F62F06772}"/>
               </a:ext>
             </a:extLst>
           </p:cNvPr>
@@ -7776,7 +7753,7 @@
           <p:cNvPr id="21" name="">
             <a:extLst xmlns:a="http://schemas.openxmlformats.org/drawingml/2006/main">
               <a:ext uri="{FF2B5EF4-FFF2-40B4-BE49-F238E27FC236}">
-                <a16:creationId xmlns:a16="http://schemas.microsoft.com/office/drawing/2014/main" id="{E6AC3513-7A3E-4D1F-A709-3865D5515A23}"/>
+                <a16:creationId xmlns:a16="http://schemas.microsoft.com/office/drawing/2014/main" id="{B9F0CE83-7C46-4452-AB2C-3E5486290F8A}"/>
               </a:ext>
             </a:extLst>
           </p:cNvPr>
@@ -7809,7 +7786,7 @@
           <p:cNvPr id="22" name="">
             <a:extLst xmlns:a="http://schemas.openxmlformats.org/drawingml/2006/main">
               <a:ext uri="{FF2B5EF4-FFF2-40B4-BE49-F238E27FC236}">
-                <a16:creationId xmlns:a16="http://schemas.microsoft.com/office/drawing/2014/main" id="{8D92F70F-489C-4C89-AB84-0F08B536069D}"/>
+                <a16:creationId xmlns:a16="http://schemas.microsoft.com/office/drawing/2014/main" id="{09792FBC-CB3A-418D-A843-C0346E43B144}"/>
               </a:ext>
             </a:extLst>
           </p:cNvPr>
@@ -7873,7 +7850,7 @@
           <p:cNvPr id="23" name="">
             <a:extLst xmlns:a="http://schemas.openxmlformats.org/drawingml/2006/main">
               <a:ext uri="{FF2B5EF4-FFF2-40B4-BE49-F238E27FC236}">
-                <a16:creationId xmlns:a16="http://schemas.microsoft.com/office/drawing/2014/main" id="{A8DC2A2B-E687-4BC5-9057-91940924DD62}"/>
+                <a16:creationId xmlns:a16="http://schemas.microsoft.com/office/drawing/2014/main" id="{092FB4D0-A935-481D-9FA1-F4A3F50C4C5C}"/>
               </a:ext>
             </a:extLst>
           </p:cNvPr>
@@ -7937,7 +7914,7 @@
           <p:cNvPr id="24" name="">
             <a:extLst xmlns:a="http://schemas.openxmlformats.org/drawingml/2006/main">
               <a:ext uri="{FF2B5EF4-FFF2-40B4-BE49-F238E27FC236}">
-                <a16:creationId xmlns:a16="http://schemas.microsoft.com/office/drawing/2014/main" id="{C3560D38-B3F4-40A6-9A2D-F4ECC3577C0E}"/>
+                <a16:creationId xmlns:a16="http://schemas.microsoft.com/office/drawing/2014/main" id="{10107C5B-A775-4993-BD02-3330F8A82BA9}"/>
               </a:ext>
             </a:extLst>
           </p:cNvPr>
@@ -7999,7 +7976,7 @@
     </p:spTree>
     <p:extLst>
       <p:ext uri="{BB962C8B-B14F-4D97-AF65-F5344CB8AC3E}">
-        <p14:creationId xmlns:p14="http://schemas.microsoft.com/office/powerpoint/2010/main" val="1873263146"/>
+        <p14:creationId xmlns:p14="http://schemas.microsoft.com/office/powerpoint/2010/main" val="1618355589"/>
       </p:ext>
     </p:extLst>
   </p:cSld>
@@ -8023,7 +8000,7 @@
           <p:cNvPr id="1" name="">
             <a:extLst xmlns:a="http://schemas.openxmlformats.org/drawingml/2006/main">
               <a:ext uri="{FF2B5EF4-FFF2-40B4-BE49-F238E27FC236}">
-                <a16:creationId xmlns:a16="http://schemas.microsoft.com/office/drawing/2014/main" id="{4C6A4112-32CA-449E-8406-A753A42AEB5D}"/>
+                <a16:creationId xmlns:a16="http://schemas.microsoft.com/office/drawing/2014/main" id="{D54E84B8-E79E-4059-A367-712C725FECED}"/>
               </a:ext>
             </a:extLst>
           </p:cNvPr>
@@ -8058,7 +8035,7 @@
           <p:cNvPr id="2" name="">
             <a:extLst xmlns:a="http://schemas.openxmlformats.org/drawingml/2006/main">
               <a:ext uri="{FF2B5EF4-FFF2-40B4-BE49-F238E27FC236}">
-                <a16:creationId xmlns:a16="http://schemas.microsoft.com/office/drawing/2014/main" id="{15D562EC-06CC-48F3-B8F8-1B706544D3BE}"/>
+                <a16:creationId xmlns:a16="http://schemas.microsoft.com/office/drawing/2014/main" id="{7C6E97BE-2DF1-40D9-B1D2-C0B59F82DABC}"/>
               </a:ext>
             </a:extLst>
           </p:cNvPr>
@@ -8122,7 +8099,7 @@
           <p:cNvPr id="3" name="">
             <a:extLst xmlns:a="http://schemas.openxmlformats.org/drawingml/2006/main">
               <a:ext uri="{FF2B5EF4-FFF2-40B4-BE49-F238E27FC236}">
-                <a16:creationId xmlns:a16="http://schemas.microsoft.com/office/drawing/2014/main" id="{6FEE77D0-CBF9-45DA-822B-84F8AB141DDA}"/>
+                <a16:creationId xmlns:a16="http://schemas.microsoft.com/office/drawing/2014/main" id="{4ADAD03A-28FA-425B-80AD-FA67246558AD}"/>
               </a:ext>
             </a:extLst>
           </p:cNvPr>
@@ -8176,7 +8153,7 @@
                 <a:ea typeface="Microsoft YaHei"/>
                 <a:cs typeface="Microsoft YaHei"/>
               </a:rPr>
-              <a:t>先演示收敛后的底稿 Workflow，再讲为什么我不再相信自由 Agent。</a:t>
+              <a:t>先打开跨境电商资金流审计系统，让同学看到真实流水线。</a:t>
             </a:r>
           </a:p>
         </p:txBody>
@@ -8186,7 +8163,7 @@
           <p:cNvPr id="4" name="">
             <a:extLst xmlns:a="http://schemas.openxmlformats.org/drawingml/2006/main">
               <a:ext uri="{FF2B5EF4-FFF2-40B4-BE49-F238E27FC236}">
-                <a16:creationId xmlns:a16="http://schemas.microsoft.com/office/drawing/2014/main" id="{B53F0177-32DD-4A3C-99F4-659FA2FB0AF9}"/>
+                <a16:creationId xmlns:a16="http://schemas.microsoft.com/office/drawing/2014/main" id="{08A74D4B-A439-47F2-BAC3-892A239F2CF0}"/>
               </a:ext>
             </a:extLst>
           </p:cNvPr>
@@ -8250,7 +8227,7 @@
           <p:cNvPr id="5" name="">
             <a:extLst xmlns:a="http://schemas.openxmlformats.org/drawingml/2006/main">
               <a:ext uri="{FF2B5EF4-FFF2-40B4-BE49-F238E27FC236}">
-                <a16:creationId xmlns:a16="http://schemas.microsoft.com/office/drawing/2014/main" id="{D9CC0F96-9911-44BB-958B-FB7E01576483}"/>
+                <a16:creationId xmlns:a16="http://schemas.microsoft.com/office/drawing/2014/main" id="{834C617E-9B4A-478C-BB48-6BFAF9860902}"/>
               </a:ext>
             </a:extLst>
           </p:cNvPr>
@@ -8289,13 +8266,13 @@
           <p:nvPr/>
         </p:nvPicPr>
         <p:blipFill>
-          <a:blip xmlns:r="http://schemas.openxmlformats.org/officeDocument/2006/relationships" xmlns:a="http://schemas.openxmlformats.org/drawingml/2006/main" r:embed="Rad53117afd4b4286"/>
+          <a:blip xmlns:r="http://schemas.openxmlformats.org/officeDocument/2006/relationships" xmlns:a="http://schemas.openxmlformats.org/drawingml/2006/main" r:embed="R229799aa954044f3"/>
           <a:stretch xmlns:a="http://schemas.openxmlformats.org/drawingml/2006/main"/>
         </p:blipFill>
         <p:spPr>
           <a:xfrm xmlns:a="http://schemas.openxmlformats.org/drawingml/2006/main">
-            <a:off x="1860550" y="1524000"/>
-            <a:ext cx="4622800" cy="4333875"/>
+            <a:off x="704850" y="1524000"/>
+            <a:ext cx="6934200" cy="4333875"/>
           </a:xfrm>
           <a:prstGeom xmlns:a="http://schemas.openxmlformats.org/drawingml/2006/main" prst="rect">
             <a:avLst/>
@@ -8307,7 +8284,7 @@
           <p:cNvPr id="7" name="">
             <a:extLst xmlns:a="http://schemas.openxmlformats.org/drawingml/2006/main">
               <a:ext uri="{FF2B5EF4-FFF2-40B4-BE49-F238E27FC236}">
-                <a16:creationId xmlns:a16="http://schemas.microsoft.com/office/drawing/2014/main" id="{F1D9201D-F3C9-4B29-81A6-2F6313A2EC57}"/>
+                <a16:creationId xmlns:a16="http://schemas.microsoft.com/office/drawing/2014/main" id="{DCD4606D-E09E-450E-901A-10AAB2DF40AC}"/>
               </a:ext>
             </a:extLst>
           </p:cNvPr>
@@ -8340,7 +8317,7 @@
           <p:cNvPr id="8" name="">
             <a:extLst xmlns:a="http://schemas.openxmlformats.org/drawingml/2006/main">
               <a:ext uri="{FF2B5EF4-FFF2-40B4-BE49-F238E27FC236}">
-                <a16:creationId xmlns:a16="http://schemas.microsoft.com/office/drawing/2014/main" id="{BD6C6023-FAD2-488A-B959-88FA819E4504}"/>
+                <a16:creationId xmlns:a16="http://schemas.microsoft.com/office/drawing/2014/main" id="{311C7D6E-7557-4FAE-B7FF-803479CEA03F}"/>
               </a:ext>
             </a:extLst>
           </p:cNvPr>
@@ -8375,7 +8352,7 @@
           <p:cNvPr id="9" name="">
             <a:extLst xmlns:a="http://schemas.openxmlformats.org/drawingml/2006/main">
               <a:ext uri="{FF2B5EF4-FFF2-40B4-BE49-F238E27FC236}">
-                <a16:creationId xmlns:a16="http://schemas.microsoft.com/office/drawing/2014/main" id="{FA6502EB-C498-4B5E-B550-C9A771A4FB50}"/>
+                <a16:creationId xmlns:a16="http://schemas.microsoft.com/office/drawing/2014/main" id="{E37CE74A-E30C-4B34-B0D7-EA5007BA0590}"/>
               </a:ext>
             </a:extLst>
           </p:cNvPr>
@@ -8439,7 +8416,7 @@
           <p:cNvPr id="10" name="">
             <a:extLst xmlns:a="http://schemas.openxmlformats.org/drawingml/2006/main">
               <a:ext uri="{FF2B5EF4-FFF2-40B4-BE49-F238E27FC236}">
-                <a16:creationId xmlns:a16="http://schemas.microsoft.com/office/drawing/2014/main" id="{AEB4A894-CFDF-4646-A7D3-0720AD2CC482}"/>
+                <a16:creationId xmlns:a16="http://schemas.microsoft.com/office/drawing/2014/main" id="{7C63324A-D7B9-4A05-969C-8B0A4F2DF6DC}"/>
               </a:ext>
             </a:extLst>
           </p:cNvPr>
@@ -8516,7 +8493,7 @@
                 <a:ea typeface="Microsoft YaHei"/>
                 <a:cs typeface="Microsoft YaHei"/>
               </a:rPr>
-              <a:t>2. 点击“使用内置示例生成底稿”</a:t>
+              <a:t>2. 左侧选择演示数据</a:t>
             </a:r>
           </a:p>
           <a:p xmlns:a="http://schemas.openxmlformats.org/drawingml/2006/main">
@@ -8539,7 +8516,7 @@
                 <a:ea typeface="Microsoft YaHei"/>
                 <a:cs typeface="Microsoft YaHei"/>
               </a:rPr>
-              <a:t>3. 下载 Excel 工作底稿</a:t>
+              <a:t>3. 点击“开始审计”</a:t>
             </a:r>
           </a:p>
           <a:p xmlns:a="http://schemas.openxmlformats.org/drawingml/2006/main">
@@ -8562,7 +8539,7 @@
                 <a:ea typeface="Microsoft YaHei"/>
                 <a:cs typeface="Microsoft YaHei"/>
               </a:rPr>
-              <a:t>4. 回到 PPT 解释为什么这样设计</a:t>
+              <a:t>4. 展示风险发现、AI 叙述和下载区</a:t>
             </a:r>
           </a:p>
         </p:txBody>
@@ -8572,7 +8549,7 @@
           <p:cNvPr id="11" name="">
             <a:extLst xmlns:a="http://schemas.openxmlformats.org/drawingml/2006/main">
               <a:ext uri="{FF2B5EF4-FFF2-40B4-BE49-F238E27FC236}">
-                <a16:creationId xmlns:a16="http://schemas.microsoft.com/office/drawing/2014/main" id="{64B8DBE0-43B3-4F8B-86E2-E744EFCEA4BD}"/>
+                <a16:creationId xmlns:a16="http://schemas.microsoft.com/office/drawing/2014/main" id="{E56B9C0D-312B-4593-988F-C24522898B12}"/>
               </a:ext>
             </a:extLst>
           </p:cNvPr>
@@ -8605,7 +8582,7 @@
           <p:cNvPr id="12" name="">
             <a:extLst xmlns:a="http://schemas.openxmlformats.org/drawingml/2006/main">
               <a:ext uri="{FF2B5EF4-FFF2-40B4-BE49-F238E27FC236}">
-                <a16:creationId xmlns:a16="http://schemas.microsoft.com/office/drawing/2014/main" id="{498165D1-0F6E-429B-89DD-D0ACCB1AE660}"/>
+                <a16:creationId xmlns:a16="http://schemas.microsoft.com/office/drawing/2014/main" id="{C0B6FF2F-71B9-4416-879C-D4E9188B0DBD}"/>
               </a:ext>
             </a:extLst>
           </p:cNvPr>
@@ -8640,7 +8617,7 @@
           <p:cNvPr id="13" name="">
             <a:extLst xmlns:a="http://schemas.openxmlformats.org/drawingml/2006/main">
               <a:ext uri="{FF2B5EF4-FFF2-40B4-BE49-F238E27FC236}">
-                <a16:creationId xmlns:a16="http://schemas.microsoft.com/office/drawing/2014/main" id="{36FC5F0B-2CC4-4FCD-BAC3-7C1BFC6A635C}"/>
+                <a16:creationId xmlns:a16="http://schemas.microsoft.com/office/drawing/2014/main" id="{BC714B9D-CB1B-4A33-A792-E0D5B3990C67}"/>
               </a:ext>
             </a:extLst>
           </p:cNvPr>
@@ -8704,7 +8681,7 @@
           <p:cNvPr id="14" name="">
             <a:extLst xmlns:a="http://schemas.openxmlformats.org/drawingml/2006/main">
               <a:ext uri="{FF2B5EF4-FFF2-40B4-BE49-F238E27FC236}">
-                <a16:creationId xmlns:a16="http://schemas.microsoft.com/office/drawing/2014/main" id="{5C76FCB5-DDDD-4910-9F16-9409C0D4CDF6}"/>
+                <a16:creationId xmlns:a16="http://schemas.microsoft.com/office/drawing/2014/main" id="{94FA3357-D9E7-4A07-BA4E-9621C3182234}"/>
               </a:ext>
             </a:extLst>
           </p:cNvPr>
@@ -8758,7 +8735,7 @@
                 <a:ea typeface="Microsoft YaHei"/>
                 <a:cs typeface="Microsoft YaHei"/>
               </a:rPr>
-              <a:t>内置合成材料 + mock 模式 + Excel 底稿。重点展示可运行路径，不展示真实客户敏感数据。</a:t>
+              <a:t>跨境电商资金流审计 Agent：模拟 Anker 风格交易流水，覆盖平台收入、广告、退款、FX、ERP 缺口等异常。</a:t>
             </a:r>
           </a:p>
         </p:txBody>
@@ -8768,7 +8745,7 @@
           <p:cNvPr id="15" name="">
             <a:extLst xmlns:a="http://schemas.openxmlformats.org/drawingml/2006/main">
               <a:ext uri="{FF2B5EF4-FFF2-40B4-BE49-F238E27FC236}">
-                <a16:creationId xmlns:a16="http://schemas.microsoft.com/office/drawing/2014/main" id="{26E1145C-4503-49B1-BC25-CA8DC7DCA9EA}"/>
+                <a16:creationId xmlns:a16="http://schemas.microsoft.com/office/drawing/2014/main" id="{683EF966-0D9E-4153-AB7C-DC25715278E1}"/>
               </a:ext>
             </a:extLst>
           </p:cNvPr>
@@ -8801,7 +8778,7 @@
           <p:cNvPr id="16" name="">
             <a:extLst xmlns:a="http://schemas.openxmlformats.org/drawingml/2006/main">
               <a:ext uri="{FF2B5EF4-FFF2-40B4-BE49-F238E27FC236}">
-                <a16:creationId xmlns:a16="http://schemas.microsoft.com/office/drawing/2014/main" id="{C8FCC74E-8D68-430F-868C-256DB82727AF}"/>
+                <a16:creationId xmlns:a16="http://schemas.microsoft.com/office/drawing/2014/main" id="{33CB30AD-C16F-47C2-B213-B2C794F6209E}"/>
               </a:ext>
             </a:extLst>
           </p:cNvPr>
@@ -8836,7 +8813,7 @@
           <p:cNvPr id="17" name="">
             <a:extLst xmlns:a="http://schemas.openxmlformats.org/drawingml/2006/main">
               <a:ext uri="{FF2B5EF4-FFF2-40B4-BE49-F238E27FC236}">
-                <a16:creationId xmlns:a16="http://schemas.microsoft.com/office/drawing/2014/main" id="{E0CF00EC-55D1-45DD-AB48-A263FB18ACE4}"/>
+                <a16:creationId xmlns:a16="http://schemas.microsoft.com/office/drawing/2014/main" id="{222DC596-8751-42FE-9ADD-E31E0745F7F5}"/>
               </a:ext>
             </a:extLst>
           </p:cNvPr>
@@ -8890,7 +8867,7 @@
                 <a:ea typeface="Microsoft YaHei"/>
                 <a:cs typeface="Microsoft YaHei"/>
               </a:rPr>
-              <a:t>它不是什么</a:t>
+              <a:t>演示边界</a:t>
             </a:r>
           </a:p>
         </p:txBody>
@@ -8900,7 +8877,7 @@
           <p:cNvPr id="18" name="">
             <a:extLst xmlns:a="http://schemas.openxmlformats.org/drawingml/2006/main">
               <a:ext uri="{FF2B5EF4-FFF2-40B4-BE49-F238E27FC236}">
-                <a16:creationId xmlns:a16="http://schemas.microsoft.com/office/drawing/2014/main" id="{D52E73DF-3B3A-428A-8AFF-5D50FB9B94A9}"/>
+                <a16:creationId xmlns:a16="http://schemas.microsoft.com/office/drawing/2014/main" id="{91EB7321-4894-48C0-83B8-05F79EE2483F}"/>
               </a:ext>
             </a:extLst>
           </p:cNvPr>
@@ -8954,7 +8931,7 @@
                 <a:ea typeface="Microsoft YaHei"/>
                 <a:cs typeface="Microsoft YaHei"/>
               </a:rPr>
-              <a:t>不是让模型自由查账、自由下结论；而是把材料、规则、证据和复核点串起来。</a:t>
+              <a:t>课堂使用合成交易数据；真实客户资料需要先脱敏，或放在私有化模型和权限环境里处理。</a:t>
             </a:r>
           </a:p>
         </p:txBody>
@@ -8964,7 +8941,7 @@
           <p:cNvPr id="19" name="">
             <a:extLst xmlns:a="http://schemas.openxmlformats.org/drawingml/2006/main">
               <a:ext uri="{FF2B5EF4-FFF2-40B4-BE49-F238E27FC236}">
-                <a16:creationId xmlns:a16="http://schemas.microsoft.com/office/drawing/2014/main" id="{875EF565-D0F3-42E9-A52E-FCEC3E3D78D9}"/>
+                <a16:creationId xmlns:a16="http://schemas.microsoft.com/office/drawing/2014/main" id="{DAFCAE33-9863-4E28-B467-299674F0F6AC}"/>
               </a:ext>
             </a:extLst>
           </p:cNvPr>
@@ -9028,7 +9005,7 @@
           <p:cNvPr id="20" name="">
             <a:extLst xmlns:a="http://schemas.openxmlformats.org/drawingml/2006/main">
               <a:ext uri="{FF2B5EF4-FFF2-40B4-BE49-F238E27FC236}">
-                <a16:creationId xmlns:a16="http://schemas.microsoft.com/office/drawing/2014/main" id="{0AF59E16-912B-410F-9C9E-6119AB816603}"/>
+                <a16:creationId xmlns:a16="http://schemas.microsoft.com/office/drawing/2014/main" id="{6EF4B31B-BD49-469C-9C2B-C690A49E6035}"/>
               </a:ext>
             </a:extLst>
           </p:cNvPr>
@@ -9090,7 +9067,7 @@
     </p:spTree>
     <p:extLst>
       <p:ext uri="{BB962C8B-B14F-4D97-AF65-F5344CB8AC3E}">
-        <p14:creationId xmlns:p14="http://schemas.microsoft.com/office/powerpoint/2010/main" val="994544707"/>
+        <p14:creationId xmlns:p14="http://schemas.microsoft.com/office/powerpoint/2010/main" val="1421304551"/>
       </p:ext>
     </p:extLst>
   </p:cSld>
@@ -9114,7 +9091,7 @@
           <p:cNvPr id="1" name="">
             <a:extLst xmlns:a="http://schemas.openxmlformats.org/drawingml/2006/main">
               <a:ext uri="{FF2B5EF4-FFF2-40B4-BE49-F238E27FC236}">
-                <a16:creationId xmlns:a16="http://schemas.microsoft.com/office/drawing/2014/main" id="{7E5A4538-9940-487B-9CF3-F58D107EDD5A}"/>
+                <a16:creationId xmlns:a16="http://schemas.microsoft.com/office/drawing/2014/main" id="{DE5AB994-149A-4C68-A312-F77BE66798FB}"/>
               </a:ext>
             </a:extLst>
           </p:cNvPr>
@@ -9149,7 +9126,7 @@
           <p:cNvPr id="2" name="">
             <a:extLst xmlns:a="http://schemas.openxmlformats.org/drawingml/2006/main">
               <a:ext uri="{FF2B5EF4-FFF2-40B4-BE49-F238E27FC236}">
-                <a16:creationId xmlns:a16="http://schemas.microsoft.com/office/drawing/2014/main" id="{242BF768-E91A-43F2-A5C1-42205B2B3837}"/>
+                <a16:creationId xmlns:a16="http://schemas.microsoft.com/office/drawing/2014/main" id="{0A1E3527-C2E6-4954-978A-F56CE93A4500}"/>
               </a:ext>
             </a:extLst>
           </p:cNvPr>
@@ -9213,7 +9190,7 @@
           <p:cNvPr id="3" name="">
             <a:extLst xmlns:a="http://schemas.openxmlformats.org/drawingml/2006/main">
               <a:ext uri="{FF2B5EF4-FFF2-40B4-BE49-F238E27FC236}">
-                <a16:creationId xmlns:a16="http://schemas.microsoft.com/office/drawing/2014/main" id="{9816D0E6-EF6A-4304-9BBF-6B2A00A05AEE}"/>
+                <a16:creationId xmlns:a16="http://schemas.microsoft.com/office/drawing/2014/main" id="{5244B517-EA7E-4CB6-B365-5013923FCFC1}"/>
               </a:ext>
             </a:extLst>
           </p:cNvPr>
@@ -9267,7 +9244,7 @@
                 <a:ea typeface="Microsoft YaHei"/>
                 <a:cs typeface="Microsoft YaHei"/>
               </a:rPr>
-              <a:t>最初的跨境资金多 Agent 能跑，但问题不是运行，而是不可信。</a:t>
+              <a:t>最初做的就是跨境电商资金审计 Agent：能跑，但可信度还不够。</a:t>
             </a:r>
           </a:p>
         </p:txBody>
@@ -9277,7 +9254,7 @@
           <p:cNvPr id="4" name="">
             <a:extLst xmlns:a="http://schemas.openxmlformats.org/drawingml/2006/main">
               <a:ext uri="{FF2B5EF4-FFF2-40B4-BE49-F238E27FC236}">
-                <a16:creationId xmlns:a16="http://schemas.microsoft.com/office/drawing/2014/main" id="{D3829E30-9ED3-4D07-AECA-96045CD3EC9A}"/>
+                <a16:creationId xmlns:a16="http://schemas.microsoft.com/office/drawing/2014/main" id="{55B4D09B-7FF1-4679-A36D-A900D0B19BEE}"/>
               </a:ext>
             </a:extLst>
           </p:cNvPr>
@@ -9341,7 +9318,7 @@
           <p:cNvPr id="5" name="">
             <a:extLst xmlns:a="http://schemas.openxmlformats.org/drawingml/2006/main">
               <a:ext uri="{FF2B5EF4-FFF2-40B4-BE49-F238E27FC236}">
-                <a16:creationId xmlns:a16="http://schemas.microsoft.com/office/drawing/2014/main" id="{24B91959-5D8D-4871-BA9F-3C1167A8EA84}"/>
+                <a16:creationId xmlns:a16="http://schemas.microsoft.com/office/drawing/2014/main" id="{D40E2E0F-1738-4A67-8118-94CDB1E6823A}"/>
               </a:ext>
             </a:extLst>
           </p:cNvPr>
@@ -9376,7 +9353,7 @@
           <p:cNvPr id="6" name="">
             <a:extLst xmlns:a="http://schemas.openxmlformats.org/drawingml/2006/main">
               <a:ext uri="{FF2B5EF4-FFF2-40B4-BE49-F238E27FC236}">
-                <a16:creationId xmlns:a16="http://schemas.microsoft.com/office/drawing/2014/main" id="{4EBBB371-2476-4F21-93B5-971A8D34BE9B}"/>
+                <a16:creationId xmlns:a16="http://schemas.microsoft.com/office/drawing/2014/main" id="{422C45D1-9C09-458C-9810-D09F3C04F5CE}"/>
               </a:ext>
             </a:extLst>
           </p:cNvPr>
@@ -9409,7 +9386,7 @@
           <p:cNvPr id="7" name="">
             <a:extLst xmlns:a="http://schemas.openxmlformats.org/drawingml/2006/main">
               <a:ext uri="{FF2B5EF4-FFF2-40B4-BE49-F238E27FC236}">
-                <a16:creationId xmlns:a16="http://schemas.microsoft.com/office/drawing/2014/main" id="{A1B64941-D3BD-40F1-AEDF-52725EBB4794}"/>
+                <a16:creationId xmlns:a16="http://schemas.microsoft.com/office/drawing/2014/main" id="{765926BA-CA52-4436-B37F-8F3830D8C84B}"/>
               </a:ext>
             </a:extLst>
           </p:cNvPr>
@@ -9473,7 +9450,7 @@
           <p:cNvPr id="8" name="">
             <a:extLst xmlns:a="http://schemas.openxmlformats.org/drawingml/2006/main">
               <a:ext uri="{FF2B5EF4-FFF2-40B4-BE49-F238E27FC236}">
-                <a16:creationId xmlns:a16="http://schemas.microsoft.com/office/drawing/2014/main" id="{941AA7CE-7BFE-44CC-814D-CEF76AD9AC1E}"/>
+                <a16:creationId xmlns:a16="http://schemas.microsoft.com/office/drawing/2014/main" id="{1E504D96-96F1-4778-A671-15504070BB53}"/>
               </a:ext>
             </a:extLst>
           </p:cNvPr>
@@ -9537,7 +9514,7 @@
           <p:cNvPr id="9" name="">
             <a:extLst xmlns:a="http://schemas.openxmlformats.org/drawingml/2006/main">
               <a:ext uri="{FF2B5EF4-FFF2-40B4-BE49-F238E27FC236}">
-                <a16:creationId xmlns:a16="http://schemas.microsoft.com/office/drawing/2014/main" id="{B1D330CF-D700-47BB-A343-9422BB71788E}"/>
+                <a16:creationId xmlns:a16="http://schemas.microsoft.com/office/drawing/2014/main" id="{6EAB9720-D627-489A-B5A6-5CDC1B042BBA}"/>
               </a:ext>
             </a:extLst>
           </p:cNvPr>
@@ -9591,7 +9568,7 @@
                 <a:ea typeface="Microsoft YaHei"/>
                 <a:cs typeface="Microsoft YaHei"/>
               </a:rPr>
-              <a:t>让不同 Agent 分别做数据提取、合规分析和审计合伙人复核，前端可以上传材料并输出风险判断。</a:t>
+              <a:t>前端选择演示数据或上传 CSV，后端生成交易流水、跑规则、再给出 AI 审计叙述。</a:t>
             </a:r>
           </a:p>
         </p:txBody>
@@ -9601,7 +9578,7 @@
           <p:cNvPr id="10" name="">
             <a:extLst xmlns:a="http://schemas.openxmlformats.org/drawingml/2006/main">
               <a:ext uri="{FF2B5EF4-FFF2-40B4-BE49-F238E27FC236}">
-                <a16:creationId xmlns:a16="http://schemas.microsoft.com/office/drawing/2014/main" id="{F6839B41-3F94-4DC6-975A-4EAAC78A9EAF}"/>
+                <a16:creationId xmlns:a16="http://schemas.microsoft.com/office/drawing/2014/main" id="{74C8AB7D-1C93-4934-8970-78CDB46240BD}"/>
               </a:ext>
             </a:extLst>
           </p:cNvPr>
@@ -9665,7 +9642,7 @@
           <p:cNvPr id="11" name="">
             <a:extLst xmlns:a="http://schemas.openxmlformats.org/drawingml/2006/main">
               <a:ext uri="{FF2B5EF4-FFF2-40B4-BE49-F238E27FC236}">
-                <a16:creationId xmlns:a16="http://schemas.microsoft.com/office/drawing/2014/main" id="{A179FC4D-316B-44FB-86AF-EC057ACFDEC9}"/>
+                <a16:creationId xmlns:a16="http://schemas.microsoft.com/office/drawing/2014/main" id="{FF6DF7C8-8453-4173-91AE-4D686090F7E5}"/>
               </a:ext>
             </a:extLst>
           </p:cNvPr>
@@ -9698,7 +9675,7 @@
           <p:cNvPr id="12" name="">
             <a:extLst xmlns:a="http://schemas.openxmlformats.org/drawingml/2006/main">
               <a:ext uri="{FF2B5EF4-FFF2-40B4-BE49-F238E27FC236}">
-                <a16:creationId xmlns:a16="http://schemas.microsoft.com/office/drawing/2014/main" id="{813C730C-5745-49C8-9427-E2F45DD96891}"/>
+                <a16:creationId xmlns:a16="http://schemas.microsoft.com/office/drawing/2014/main" id="{E8AB9E50-ECCA-4740-959B-197D8CCADBA1}"/>
               </a:ext>
             </a:extLst>
           </p:cNvPr>
@@ -9762,7 +9739,7 @@
           <p:cNvPr id="13" name="">
             <a:extLst xmlns:a="http://schemas.openxmlformats.org/drawingml/2006/main">
               <a:ext uri="{FF2B5EF4-FFF2-40B4-BE49-F238E27FC236}">
-                <a16:creationId xmlns:a16="http://schemas.microsoft.com/office/drawing/2014/main" id="{2BC2B64D-86B3-40F8-AA69-E972FFF4A599}"/>
+                <a16:creationId xmlns:a16="http://schemas.microsoft.com/office/drawing/2014/main" id="{7388EFBE-512B-44CB-B9A0-0CF391DE80BD}"/>
               </a:ext>
             </a:extLst>
           </p:cNvPr>
@@ -9826,7 +9803,7 @@
           <p:cNvPr id="14" name="">
             <a:extLst xmlns:a="http://schemas.openxmlformats.org/drawingml/2006/main">
               <a:ext uri="{FF2B5EF4-FFF2-40B4-BE49-F238E27FC236}">
-                <a16:creationId xmlns:a16="http://schemas.microsoft.com/office/drawing/2014/main" id="{B1E35EBE-02D5-446C-BDC6-74E3E47CCC0A}"/>
+                <a16:creationId xmlns:a16="http://schemas.microsoft.com/office/drawing/2014/main" id="{FC78A223-1D1D-45CF-B643-3833E078DD85}"/>
               </a:ext>
             </a:extLst>
           </p:cNvPr>
@@ -9890,7 +9867,7 @@
           <p:cNvPr id="15" name="">
             <a:extLst xmlns:a="http://schemas.openxmlformats.org/drawingml/2006/main">
               <a:ext uri="{FF2B5EF4-FFF2-40B4-BE49-F238E27FC236}">
-                <a16:creationId xmlns:a16="http://schemas.microsoft.com/office/drawing/2014/main" id="{C3C22913-ED64-40BB-8FC6-A637DDA92B6B}"/>
+                <a16:creationId xmlns:a16="http://schemas.microsoft.com/office/drawing/2014/main" id="{19594F60-CCB6-45DC-8456-E6EC068CE436}"/>
               </a:ext>
             </a:extLst>
           </p:cNvPr>
@@ -9954,7 +9931,7 @@
           <p:cNvPr id="16" name="">
             <a:extLst xmlns:a="http://schemas.openxmlformats.org/drawingml/2006/main">
               <a:ext uri="{FF2B5EF4-FFF2-40B4-BE49-F238E27FC236}">
-                <a16:creationId xmlns:a16="http://schemas.microsoft.com/office/drawing/2014/main" id="{813BC87A-EAE9-4540-ACB2-FB4A7797B571}"/>
+                <a16:creationId xmlns:a16="http://schemas.microsoft.com/office/drawing/2014/main" id="{3F54C70F-D7FB-4152-B56A-AF02256B9321}"/>
               </a:ext>
             </a:extLst>
           </p:cNvPr>
@@ -9987,7 +9964,7 @@
           <p:cNvPr id="17" name="">
             <a:extLst xmlns:a="http://schemas.openxmlformats.org/drawingml/2006/main">
               <a:ext uri="{FF2B5EF4-FFF2-40B4-BE49-F238E27FC236}">
-                <a16:creationId xmlns:a16="http://schemas.microsoft.com/office/drawing/2014/main" id="{6B92416E-C876-45EA-8528-99FB9751217A}"/>
+                <a16:creationId xmlns:a16="http://schemas.microsoft.com/office/drawing/2014/main" id="{2975B58C-E4C9-4A27-9F52-AF68A2B13DC6}"/>
               </a:ext>
             </a:extLst>
           </p:cNvPr>
@@ -10051,7 +10028,7 @@
           <p:cNvPr id="18" name="">
             <a:extLst xmlns:a="http://schemas.openxmlformats.org/drawingml/2006/main">
               <a:ext uri="{FF2B5EF4-FFF2-40B4-BE49-F238E27FC236}">
-                <a16:creationId xmlns:a16="http://schemas.microsoft.com/office/drawing/2014/main" id="{49843599-E689-412C-935D-26A330D1E39D}"/>
+                <a16:creationId xmlns:a16="http://schemas.microsoft.com/office/drawing/2014/main" id="{778A742A-0507-47BA-A13D-A9A3E4730375}"/>
               </a:ext>
             </a:extLst>
           </p:cNvPr>
@@ -10105,7 +10082,7 @@
                 <a:ea typeface="Microsoft YaHei"/>
                 <a:cs typeface="Microsoft YaHei"/>
               </a:rPr>
-              <a:t>需求收敛：先刷底稿</a:t>
+              <a:t>课堂展示：资金流主线</a:t>
             </a:r>
           </a:p>
         </p:txBody>
@@ -10115,7 +10092,7 @@
           <p:cNvPr id="19" name="">
             <a:extLst xmlns:a="http://schemas.openxmlformats.org/drawingml/2006/main">
               <a:ext uri="{FF2B5EF4-FFF2-40B4-BE49-F238E27FC236}">
-                <a16:creationId xmlns:a16="http://schemas.microsoft.com/office/drawing/2014/main" id="{BEC7D683-A5C3-4156-ABA9-A77FC1CE6095}"/>
+                <a16:creationId xmlns:a16="http://schemas.microsoft.com/office/drawing/2014/main" id="{2553B8DE-D784-4FD9-94D8-85C2EAADB150}"/>
               </a:ext>
             </a:extLst>
           </p:cNvPr>
@@ -10169,7 +10146,7 @@
                 <a:ea typeface="Microsoft YaHei"/>
                 <a:cs typeface="Microsoft YaHei"/>
               </a:rPr>
-              <a:t>把目标从“自由审计 Agent”收敛到自动填写底稿、报销单审核这类更稳定的流程节点。</a:t>
+              <a:t>这次展示聚焦跨境电商平台流水、规则异常、AI 审计叙述和人工复核。</a:t>
             </a:r>
           </a:p>
         </p:txBody>
@@ -10179,7 +10156,7 @@
           <p:cNvPr id="20" name="">
             <a:extLst xmlns:a="http://schemas.openxmlformats.org/drawingml/2006/main">
               <a:ext uri="{FF2B5EF4-FFF2-40B4-BE49-F238E27FC236}">
-                <a16:creationId xmlns:a16="http://schemas.microsoft.com/office/drawing/2014/main" id="{88471BE6-DDA2-47E8-B489-11F570F1752D}"/>
+                <a16:creationId xmlns:a16="http://schemas.microsoft.com/office/drawing/2014/main" id="{1CA27898-585C-4C5C-9DDE-32647A7128C2}"/>
               </a:ext>
             </a:extLst>
           </p:cNvPr>
@@ -10212,7 +10189,7 @@
           <p:cNvPr id="21" name="">
             <a:extLst xmlns:a="http://schemas.openxmlformats.org/drawingml/2006/main">
               <a:ext uri="{FF2B5EF4-FFF2-40B4-BE49-F238E27FC236}">
-                <a16:creationId xmlns:a16="http://schemas.microsoft.com/office/drawing/2014/main" id="{3DCE4974-8A3E-44F0-B0B9-5021B78CE494}"/>
+                <a16:creationId xmlns:a16="http://schemas.microsoft.com/office/drawing/2014/main" id="{DF1BC75D-1B4B-404A-B328-1689608E6614}"/>
               </a:ext>
             </a:extLst>
           </p:cNvPr>
@@ -10276,7 +10253,7 @@
           <p:cNvPr id="22" name="">
             <a:extLst xmlns:a="http://schemas.openxmlformats.org/drawingml/2006/main">
               <a:ext uri="{FF2B5EF4-FFF2-40B4-BE49-F238E27FC236}">
-                <a16:creationId xmlns:a16="http://schemas.microsoft.com/office/drawing/2014/main" id="{B2F4656E-D29C-45CF-86AA-60DD9F083EF4}"/>
+                <a16:creationId xmlns:a16="http://schemas.microsoft.com/office/drawing/2014/main" id="{75C957BE-42D0-454C-8A84-FE8B2AD1F3AE}"/>
               </a:ext>
             </a:extLst>
           </p:cNvPr>
@@ -10340,7 +10317,7 @@
           <p:cNvPr id="23" name="">
             <a:extLst xmlns:a="http://schemas.openxmlformats.org/drawingml/2006/main">
               <a:ext uri="{FF2B5EF4-FFF2-40B4-BE49-F238E27FC236}">
-                <a16:creationId xmlns:a16="http://schemas.microsoft.com/office/drawing/2014/main" id="{628FB2D1-49CE-4902-B4A9-19FB8B796CFE}"/>
+                <a16:creationId xmlns:a16="http://schemas.microsoft.com/office/drawing/2014/main" id="{C97FA3C4-EA1B-4785-AA25-817680ECC2C5}"/>
               </a:ext>
             </a:extLst>
           </p:cNvPr>
@@ -10402,7 +10379,7 @@
     </p:spTree>
     <p:extLst>
       <p:ext uri="{BB962C8B-B14F-4D97-AF65-F5344CB8AC3E}">
-        <p14:creationId xmlns:p14="http://schemas.microsoft.com/office/powerpoint/2010/main" val="1839372260"/>
+        <p14:creationId xmlns:p14="http://schemas.microsoft.com/office/powerpoint/2010/main" val="90738046"/>
       </p:ext>
     </p:extLst>
   </p:cSld>
@@ -10426,7 +10403,7 @@
           <p:cNvPr id="1" name="">
             <a:extLst xmlns:a="http://schemas.openxmlformats.org/drawingml/2006/main">
               <a:ext uri="{FF2B5EF4-FFF2-40B4-BE49-F238E27FC236}">
-                <a16:creationId xmlns:a16="http://schemas.microsoft.com/office/drawing/2014/main" id="{F197FE5C-1EDE-456D-8439-E48502B29B9F}"/>
+                <a16:creationId xmlns:a16="http://schemas.microsoft.com/office/drawing/2014/main" id="{C64E61C2-822F-4579-90C1-4AE9E5428C72}"/>
               </a:ext>
             </a:extLst>
           </p:cNvPr>
@@ -10461,7 +10438,7 @@
           <p:cNvPr id="2" name="">
             <a:extLst xmlns:a="http://schemas.openxmlformats.org/drawingml/2006/main">
               <a:ext uri="{FF2B5EF4-FFF2-40B4-BE49-F238E27FC236}">
-                <a16:creationId xmlns:a16="http://schemas.microsoft.com/office/drawing/2014/main" id="{E8A61E83-ECEA-4E47-BCB4-7D812EADE2EC}"/>
+                <a16:creationId xmlns:a16="http://schemas.microsoft.com/office/drawing/2014/main" id="{0780CA1C-0870-4BC9-A8FC-C7614D22A414}"/>
               </a:ext>
             </a:extLst>
           </p:cNvPr>
@@ -10525,7 +10502,7 @@
           <p:cNvPr id="3" name="">
             <a:extLst xmlns:a="http://schemas.openxmlformats.org/drawingml/2006/main">
               <a:ext uri="{FF2B5EF4-FFF2-40B4-BE49-F238E27FC236}">
-                <a16:creationId xmlns:a16="http://schemas.microsoft.com/office/drawing/2014/main" id="{C6943A70-013B-49C9-BEAD-D3ED4BF92371}"/>
+                <a16:creationId xmlns:a16="http://schemas.microsoft.com/office/drawing/2014/main" id="{074C0A04-B670-46B9-BB85-F494D4C1665F}"/>
               </a:ext>
             </a:extLst>
           </p:cNvPr>
@@ -10589,7 +10566,7 @@
           <p:cNvPr id="4" name="">
             <a:extLst xmlns:a="http://schemas.openxmlformats.org/drawingml/2006/main">
               <a:ext uri="{FF2B5EF4-FFF2-40B4-BE49-F238E27FC236}">
-                <a16:creationId xmlns:a16="http://schemas.microsoft.com/office/drawing/2014/main" id="{6CA2E102-21D9-4538-AA87-AF1752177AF0}"/>
+                <a16:creationId xmlns:a16="http://schemas.microsoft.com/office/drawing/2014/main" id="{7AB05129-5416-47F7-8E90-FEFDC5AA1AD5}"/>
               </a:ext>
             </a:extLst>
           </p:cNvPr>
@@ -10653,7 +10630,7 @@
           <p:cNvPr id="5" name="">
             <a:extLst xmlns:a="http://schemas.openxmlformats.org/drawingml/2006/main">
               <a:ext uri="{FF2B5EF4-FFF2-40B4-BE49-F238E27FC236}">
-                <a16:creationId xmlns:a16="http://schemas.microsoft.com/office/drawing/2014/main" id="{9A69ECB7-AB77-43E9-B8AE-601830E5F189}"/>
+                <a16:creationId xmlns:a16="http://schemas.microsoft.com/office/drawing/2014/main" id="{02C877A9-201D-4CD0-AE81-2AE0E3D6B4FF}"/>
               </a:ext>
             </a:extLst>
           </p:cNvPr>
@@ -10688,7 +10665,7 @@
           <p:cNvPr id="6" name="">
             <a:extLst xmlns:a="http://schemas.openxmlformats.org/drawingml/2006/main">
               <a:ext uri="{FF2B5EF4-FFF2-40B4-BE49-F238E27FC236}">
-                <a16:creationId xmlns:a16="http://schemas.microsoft.com/office/drawing/2014/main" id="{BC0AC672-CD2C-4454-8CEE-840B59B05D07}"/>
+                <a16:creationId xmlns:a16="http://schemas.microsoft.com/office/drawing/2014/main" id="{61DE61CF-9808-4C33-85FE-6BEF4916DCDB}"/>
               </a:ext>
             </a:extLst>
           </p:cNvPr>
@@ -10721,7 +10698,7 @@
           <p:cNvPr id="7" name="">
             <a:extLst xmlns:a="http://schemas.openxmlformats.org/drawingml/2006/main">
               <a:ext uri="{FF2B5EF4-FFF2-40B4-BE49-F238E27FC236}">
-                <a16:creationId xmlns:a16="http://schemas.microsoft.com/office/drawing/2014/main" id="{0926B1FF-EC49-4CCD-82C9-E015FA69B1EF}"/>
+                <a16:creationId xmlns:a16="http://schemas.microsoft.com/office/drawing/2014/main" id="{357DC210-B4C5-4AF1-9778-09E4AE33C283}"/>
               </a:ext>
             </a:extLst>
           </p:cNvPr>
@@ -10756,7 +10733,7 @@
           <p:cNvPr id="8" name="">
             <a:extLst xmlns:a="http://schemas.openxmlformats.org/drawingml/2006/main">
               <a:ext uri="{FF2B5EF4-FFF2-40B4-BE49-F238E27FC236}">
-                <a16:creationId xmlns:a16="http://schemas.microsoft.com/office/drawing/2014/main" id="{EEC9A13D-1B65-4629-AF76-D26D0B92E7F2}"/>
+                <a16:creationId xmlns:a16="http://schemas.microsoft.com/office/drawing/2014/main" id="{38FE5E84-31A9-4706-B9B0-F5B85C15571F}"/>
               </a:ext>
             </a:extLst>
           </p:cNvPr>
@@ -10820,7 +10797,7 @@
           <p:cNvPr id="9" name="">
             <a:extLst xmlns:a="http://schemas.openxmlformats.org/drawingml/2006/main">
               <a:ext uri="{FF2B5EF4-FFF2-40B4-BE49-F238E27FC236}">
-                <a16:creationId xmlns:a16="http://schemas.microsoft.com/office/drawing/2014/main" id="{025AB1BD-23F3-42F0-9793-DA6AA3A36512}"/>
+                <a16:creationId xmlns:a16="http://schemas.microsoft.com/office/drawing/2014/main" id="{92010762-D61E-4A30-A2EE-3FC0CBA41B38}"/>
               </a:ext>
             </a:extLst>
           </p:cNvPr>
@@ -10884,7 +10861,7 @@
           <p:cNvPr id="10" name="">
             <a:extLst xmlns:a="http://schemas.openxmlformats.org/drawingml/2006/main">
               <a:ext uri="{FF2B5EF4-FFF2-40B4-BE49-F238E27FC236}">
-                <a16:creationId xmlns:a16="http://schemas.microsoft.com/office/drawing/2014/main" id="{C20A0D4A-59E8-4C2D-B317-671690297A09}"/>
+                <a16:creationId xmlns:a16="http://schemas.microsoft.com/office/drawing/2014/main" id="{37F9471D-6B88-4525-A6A8-439E10915A9C}"/>
               </a:ext>
             </a:extLst>
           </p:cNvPr>
@@ -10917,7 +10894,7 @@
           <p:cNvPr id="11" name="">
             <a:extLst xmlns:a="http://schemas.openxmlformats.org/drawingml/2006/main">
               <a:ext uri="{FF2B5EF4-FFF2-40B4-BE49-F238E27FC236}">
-                <a16:creationId xmlns:a16="http://schemas.microsoft.com/office/drawing/2014/main" id="{1BA1ACF9-3259-409A-87F7-F8CC02A82690}"/>
+                <a16:creationId xmlns:a16="http://schemas.microsoft.com/office/drawing/2014/main" id="{31A57B73-7A9E-4334-992B-7706A540A77E}"/>
               </a:ext>
             </a:extLst>
           </p:cNvPr>
@@ -10952,7 +10929,7 @@
           <p:cNvPr id="12" name="">
             <a:extLst xmlns:a="http://schemas.openxmlformats.org/drawingml/2006/main">
               <a:ext uri="{FF2B5EF4-FFF2-40B4-BE49-F238E27FC236}">
-                <a16:creationId xmlns:a16="http://schemas.microsoft.com/office/drawing/2014/main" id="{3D8107B2-8683-4DA9-B961-7E1E80E4E3AB}"/>
+                <a16:creationId xmlns:a16="http://schemas.microsoft.com/office/drawing/2014/main" id="{72FCBD58-AF07-4B2A-9932-6D2053BB1CBF}"/>
               </a:ext>
             </a:extLst>
           </p:cNvPr>
@@ -11016,7 +10993,7 @@
           <p:cNvPr id="13" name="">
             <a:extLst xmlns:a="http://schemas.openxmlformats.org/drawingml/2006/main">
               <a:ext uri="{FF2B5EF4-FFF2-40B4-BE49-F238E27FC236}">
-                <a16:creationId xmlns:a16="http://schemas.microsoft.com/office/drawing/2014/main" id="{B8F08363-47D8-4BDF-80BD-153536DCCA90}"/>
+                <a16:creationId xmlns:a16="http://schemas.microsoft.com/office/drawing/2014/main" id="{60B50803-4E6C-424D-89F2-99A74B7AF2F1}"/>
               </a:ext>
             </a:extLst>
           </p:cNvPr>
@@ -11080,7 +11057,7 @@
           <p:cNvPr id="14" name="">
             <a:extLst xmlns:a="http://schemas.openxmlformats.org/drawingml/2006/main">
               <a:ext uri="{FF2B5EF4-FFF2-40B4-BE49-F238E27FC236}">
-                <a16:creationId xmlns:a16="http://schemas.microsoft.com/office/drawing/2014/main" id="{0358BBAE-9D50-4709-B36C-9B6BFED253D5}"/>
+                <a16:creationId xmlns:a16="http://schemas.microsoft.com/office/drawing/2014/main" id="{EB83C3DD-B5FD-427E-8CE1-50F28688B7DB}"/>
               </a:ext>
             </a:extLst>
           </p:cNvPr>
@@ -11113,7 +11090,7 @@
           <p:cNvPr id="15" name="">
             <a:extLst xmlns:a="http://schemas.openxmlformats.org/drawingml/2006/main">
               <a:ext uri="{FF2B5EF4-FFF2-40B4-BE49-F238E27FC236}">
-                <a16:creationId xmlns:a16="http://schemas.microsoft.com/office/drawing/2014/main" id="{6CF121DA-F8EF-4085-8827-FA929A8B57BA}"/>
+                <a16:creationId xmlns:a16="http://schemas.microsoft.com/office/drawing/2014/main" id="{EAC15ED5-BD65-47FC-AE2D-F31CF7983DD0}"/>
               </a:ext>
             </a:extLst>
           </p:cNvPr>
@@ -11148,7 +11125,7 @@
           <p:cNvPr id="16" name="">
             <a:extLst xmlns:a="http://schemas.openxmlformats.org/drawingml/2006/main">
               <a:ext uri="{FF2B5EF4-FFF2-40B4-BE49-F238E27FC236}">
-                <a16:creationId xmlns:a16="http://schemas.microsoft.com/office/drawing/2014/main" id="{37CA1B14-D2D3-41FD-8B4B-E52470FEA848}"/>
+                <a16:creationId xmlns:a16="http://schemas.microsoft.com/office/drawing/2014/main" id="{170E0E2F-C7CA-4DFB-B247-1A5947E0D5F9}"/>
               </a:ext>
             </a:extLst>
           </p:cNvPr>
@@ -11212,7 +11189,7 @@
           <p:cNvPr id="17" name="">
             <a:extLst xmlns:a="http://schemas.openxmlformats.org/drawingml/2006/main">
               <a:ext uri="{FF2B5EF4-FFF2-40B4-BE49-F238E27FC236}">
-                <a16:creationId xmlns:a16="http://schemas.microsoft.com/office/drawing/2014/main" id="{278DAEE2-E14B-4185-BDE3-1F3A5913E8C4}"/>
+                <a16:creationId xmlns:a16="http://schemas.microsoft.com/office/drawing/2014/main" id="{F233ADBD-A9D8-4954-A272-EB579222FF13}"/>
               </a:ext>
             </a:extLst>
           </p:cNvPr>
@@ -11276,7 +11253,7 @@
           <p:cNvPr id="18" name="">
             <a:extLst xmlns:a="http://schemas.openxmlformats.org/drawingml/2006/main">
               <a:ext uri="{FF2B5EF4-FFF2-40B4-BE49-F238E27FC236}">
-                <a16:creationId xmlns:a16="http://schemas.microsoft.com/office/drawing/2014/main" id="{F828D39F-7552-4BFC-B906-A59103548CD9}"/>
+                <a16:creationId xmlns:a16="http://schemas.microsoft.com/office/drawing/2014/main" id="{0F0AB616-E03A-428D-8D19-D6936F6BB42F}"/>
               </a:ext>
             </a:extLst>
           </p:cNvPr>
@@ -11309,7 +11286,7 @@
           <p:cNvPr id="19" name="">
             <a:extLst xmlns:a="http://schemas.openxmlformats.org/drawingml/2006/main">
               <a:ext uri="{FF2B5EF4-FFF2-40B4-BE49-F238E27FC236}">
-                <a16:creationId xmlns:a16="http://schemas.microsoft.com/office/drawing/2014/main" id="{0BCA1ECF-6A6D-4798-AFB4-35E51D88134A}"/>
+                <a16:creationId xmlns:a16="http://schemas.microsoft.com/office/drawing/2014/main" id="{1CBCF3BD-8B61-414C-849C-5D89F54FD635}"/>
               </a:ext>
             </a:extLst>
           </p:cNvPr>
@@ -11344,7 +11321,7 @@
           <p:cNvPr id="20" name="">
             <a:extLst xmlns:a="http://schemas.openxmlformats.org/drawingml/2006/main">
               <a:ext uri="{FF2B5EF4-FFF2-40B4-BE49-F238E27FC236}">
-                <a16:creationId xmlns:a16="http://schemas.microsoft.com/office/drawing/2014/main" id="{AC4FAFC1-8854-492C-9FD8-E12D82F6682D}"/>
+                <a16:creationId xmlns:a16="http://schemas.microsoft.com/office/drawing/2014/main" id="{0BB54780-4299-4690-BC51-CB137AF3C119}"/>
               </a:ext>
             </a:extLst>
           </p:cNvPr>
@@ -11408,7 +11385,7 @@
           <p:cNvPr id="21" name="">
             <a:extLst xmlns:a="http://schemas.openxmlformats.org/drawingml/2006/main">
               <a:ext uri="{FF2B5EF4-FFF2-40B4-BE49-F238E27FC236}">
-                <a16:creationId xmlns:a16="http://schemas.microsoft.com/office/drawing/2014/main" id="{EA383B86-71AA-424D-A61D-DFBE05A1722B}"/>
+                <a16:creationId xmlns:a16="http://schemas.microsoft.com/office/drawing/2014/main" id="{2F8E0259-6B9E-48AD-8CAF-65EB034888FC}"/>
               </a:ext>
             </a:extLst>
           </p:cNvPr>
@@ -11472,7 +11449,7 @@
           <p:cNvPr id="22" name="">
             <a:extLst xmlns:a="http://schemas.openxmlformats.org/drawingml/2006/main">
               <a:ext uri="{FF2B5EF4-FFF2-40B4-BE49-F238E27FC236}">
-                <a16:creationId xmlns:a16="http://schemas.microsoft.com/office/drawing/2014/main" id="{C56F6180-9270-4CD2-B953-76BA61BB2555}"/>
+                <a16:creationId xmlns:a16="http://schemas.microsoft.com/office/drawing/2014/main" id="{99516BF6-50ED-4094-87AD-7D53336622FF}"/>
               </a:ext>
             </a:extLst>
           </p:cNvPr>
@@ -11536,7 +11513,7 @@
           <p:cNvPr id="23" name="">
             <a:extLst xmlns:a="http://schemas.openxmlformats.org/drawingml/2006/main">
               <a:ext uri="{FF2B5EF4-FFF2-40B4-BE49-F238E27FC236}">
-                <a16:creationId xmlns:a16="http://schemas.microsoft.com/office/drawing/2014/main" id="{4C6F03E7-8E87-49E6-A5DF-AEBC6828F1EC}"/>
+                <a16:creationId xmlns:a16="http://schemas.microsoft.com/office/drawing/2014/main" id="{71B589BC-DEA5-4CC2-9603-00F015FFB476}"/>
               </a:ext>
             </a:extLst>
           </p:cNvPr>
@@ -11598,7 +11575,7 @@
     </p:spTree>
     <p:extLst>
       <p:ext uri="{BB962C8B-B14F-4D97-AF65-F5344CB8AC3E}">
-        <p14:creationId xmlns:p14="http://schemas.microsoft.com/office/powerpoint/2010/main" val="207821492"/>
+        <p14:creationId xmlns:p14="http://schemas.microsoft.com/office/powerpoint/2010/main" val="2018601810"/>
       </p:ext>
     </p:extLst>
   </p:cSld>
@@ -11622,7 +11599,7 @@
           <p:cNvPr id="1" name="">
             <a:extLst xmlns:a="http://schemas.openxmlformats.org/drawingml/2006/main">
               <a:ext uri="{FF2B5EF4-FFF2-40B4-BE49-F238E27FC236}">
-                <a16:creationId xmlns:a16="http://schemas.microsoft.com/office/drawing/2014/main" id="{77F6622C-DAA1-4E8A-9EBB-3C3616D3542B}"/>
+                <a16:creationId xmlns:a16="http://schemas.microsoft.com/office/drawing/2014/main" id="{7132F17F-A976-4D0B-A1F6-24673A9FAE3F}"/>
               </a:ext>
             </a:extLst>
           </p:cNvPr>
@@ -11657,7 +11634,7 @@
           <p:cNvPr id="2" name="">
             <a:extLst xmlns:a="http://schemas.openxmlformats.org/drawingml/2006/main">
               <a:ext uri="{FF2B5EF4-FFF2-40B4-BE49-F238E27FC236}">
-                <a16:creationId xmlns:a16="http://schemas.microsoft.com/office/drawing/2014/main" id="{A5A8749F-DBA4-4E7B-BF1B-F650CFBCD3A2}"/>
+                <a16:creationId xmlns:a16="http://schemas.microsoft.com/office/drawing/2014/main" id="{0D83026A-5AA3-4B5B-87F2-93C2DC529D81}"/>
               </a:ext>
             </a:extLst>
           </p:cNvPr>
@@ -11721,7 +11698,7 @@
           <p:cNvPr id="3" name="">
             <a:extLst xmlns:a="http://schemas.openxmlformats.org/drawingml/2006/main">
               <a:ext uri="{FF2B5EF4-FFF2-40B4-BE49-F238E27FC236}">
-                <a16:creationId xmlns:a16="http://schemas.microsoft.com/office/drawing/2014/main" id="{2BA50F6C-91E1-4EEE-90CF-7465A888C824}"/>
+                <a16:creationId xmlns:a16="http://schemas.microsoft.com/office/drawing/2014/main" id="{ADB01892-F912-4C59-84E3-5DBC8DB73988}"/>
               </a:ext>
             </a:extLst>
           </p:cNvPr>
@@ -11785,7 +11762,7 @@
           <p:cNvPr id="4" name="">
             <a:extLst xmlns:a="http://schemas.openxmlformats.org/drawingml/2006/main">
               <a:ext uri="{FF2B5EF4-FFF2-40B4-BE49-F238E27FC236}">
-                <a16:creationId xmlns:a16="http://schemas.microsoft.com/office/drawing/2014/main" id="{587043A4-8B18-4FE7-921D-BB3B5DF25994}"/>
+                <a16:creationId xmlns:a16="http://schemas.microsoft.com/office/drawing/2014/main" id="{9D157CCF-80EC-4579-A31B-EEC93D8AC3A5}"/>
               </a:ext>
             </a:extLst>
           </p:cNvPr>
@@ -11849,7 +11826,7 @@
           <p:cNvPr id="5" name="">
             <a:extLst xmlns:a="http://schemas.openxmlformats.org/drawingml/2006/main">
               <a:ext uri="{FF2B5EF4-FFF2-40B4-BE49-F238E27FC236}">
-                <a16:creationId xmlns:a16="http://schemas.microsoft.com/office/drawing/2014/main" id="{21F9D829-EC69-4558-8BC8-293454BB51FB}"/>
+                <a16:creationId xmlns:a16="http://schemas.microsoft.com/office/drawing/2014/main" id="{58962A06-71AA-4DF6-A8B5-896B717E135B}"/>
               </a:ext>
             </a:extLst>
           </p:cNvPr>
@@ -11884,7 +11861,7 @@
           <p:cNvPr id="6" name="">
             <a:extLst xmlns:a="http://schemas.openxmlformats.org/drawingml/2006/main">
               <a:ext uri="{FF2B5EF4-FFF2-40B4-BE49-F238E27FC236}">
-                <a16:creationId xmlns:a16="http://schemas.microsoft.com/office/drawing/2014/main" id="{1E6F288A-752C-4A98-A3CB-6116A241A15E}"/>
+                <a16:creationId xmlns:a16="http://schemas.microsoft.com/office/drawing/2014/main" id="{BD6AC3D3-A6A4-4010-81D9-2312DBB49232}"/>
               </a:ext>
             </a:extLst>
           </p:cNvPr>
@@ -11917,7 +11894,7 @@
           <p:cNvPr id="7" name="">
             <a:extLst xmlns:a="http://schemas.openxmlformats.org/drawingml/2006/main">
               <a:ext uri="{FF2B5EF4-FFF2-40B4-BE49-F238E27FC236}">
-                <a16:creationId xmlns:a16="http://schemas.microsoft.com/office/drawing/2014/main" id="{7030358E-A433-43CC-83B3-0FCE80497CEC}"/>
+                <a16:creationId xmlns:a16="http://schemas.microsoft.com/office/drawing/2014/main" id="{6EB1DDC3-D39D-4E23-8F58-D3C49345F33F}"/>
               </a:ext>
             </a:extLst>
           </p:cNvPr>
@@ -11981,7 +11958,7 @@
           <p:cNvPr id="8" name="">
             <a:extLst xmlns:a="http://schemas.openxmlformats.org/drawingml/2006/main">
               <a:ext uri="{FF2B5EF4-FFF2-40B4-BE49-F238E27FC236}">
-                <a16:creationId xmlns:a16="http://schemas.microsoft.com/office/drawing/2014/main" id="{B428867D-AB47-4222-A792-572F702D20E8}"/>
+                <a16:creationId xmlns:a16="http://schemas.microsoft.com/office/drawing/2014/main" id="{5E29F590-C95B-414A-9198-DB2C2690EC83}"/>
               </a:ext>
             </a:extLst>
           </p:cNvPr>
@@ -12045,7 +12022,7 @@
           <p:cNvPr id="9" name="">
             <a:extLst xmlns:a="http://schemas.openxmlformats.org/drawingml/2006/main">
               <a:ext uri="{FF2B5EF4-FFF2-40B4-BE49-F238E27FC236}">
-                <a16:creationId xmlns:a16="http://schemas.microsoft.com/office/drawing/2014/main" id="{924EDA2F-2869-482F-8E77-50CA2BA5AC52}"/>
+                <a16:creationId xmlns:a16="http://schemas.microsoft.com/office/drawing/2014/main" id="{C510C73E-0B0F-4C4B-93E0-CB4630A2BE0B}"/>
               </a:ext>
             </a:extLst>
           </p:cNvPr>
@@ -12109,7 +12086,7 @@
           <p:cNvPr id="10" name="">
             <a:extLst xmlns:a="http://schemas.openxmlformats.org/drawingml/2006/main">
               <a:ext uri="{FF2B5EF4-FFF2-40B4-BE49-F238E27FC236}">
-                <a16:creationId xmlns:a16="http://schemas.microsoft.com/office/drawing/2014/main" id="{5E70F17C-99B9-460D-9F3B-A496698E741D}"/>
+                <a16:creationId xmlns:a16="http://schemas.microsoft.com/office/drawing/2014/main" id="{290799B7-5C00-44B6-BE4F-EDE7212789DA}"/>
               </a:ext>
             </a:extLst>
           </p:cNvPr>
@@ -12142,7 +12119,7 @@
           <p:cNvPr id="11" name="">
             <a:extLst xmlns:a="http://schemas.openxmlformats.org/drawingml/2006/main">
               <a:ext uri="{FF2B5EF4-FFF2-40B4-BE49-F238E27FC236}">
-                <a16:creationId xmlns:a16="http://schemas.microsoft.com/office/drawing/2014/main" id="{711222F8-6162-4FFD-A970-4197AE9CC60F}"/>
+                <a16:creationId xmlns:a16="http://schemas.microsoft.com/office/drawing/2014/main" id="{340583E0-FAE3-4EDC-9107-13F71C3B7C6D}"/>
               </a:ext>
             </a:extLst>
           </p:cNvPr>
@@ -12206,7 +12183,7 @@
           <p:cNvPr id="12" name="">
             <a:extLst xmlns:a="http://schemas.openxmlformats.org/drawingml/2006/main">
               <a:ext uri="{FF2B5EF4-FFF2-40B4-BE49-F238E27FC236}">
-                <a16:creationId xmlns:a16="http://schemas.microsoft.com/office/drawing/2014/main" id="{95FB5043-9F0A-48A9-9D81-1C259DDF4C85}"/>
+                <a16:creationId xmlns:a16="http://schemas.microsoft.com/office/drawing/2014/main" id="{A7403EBA-D7C3-46DD-959D-953F03B0CDA7}"/>
               </a:ext>
             </a:extLst>
           </p:cNvPr>
@@ -12270,7 +12247,7 @@
           <p:cNvPr id="13" name="">
             <a:extLst xmlns:a="http://schemas.openxmlformats.org/drawingml/2006/main">
               <a:ext uri="{FF2B5EF4-FFF2-40B4-BE49-F238E27FC236}">
-                <a16:creationId xmlns:a16="http://schemas.microsoft.com/office/drawing/2014/main" id="{42328823-9AB1-4D8B-9422-A8E67EB1D14A}"/>
+                <a16:creationId xmlns:a16="http://schemas.microsoft.com/office/drawing/2014/main" id="{70B105D0-2476-4AC0-97A5-74741797A284}"/>
               </a:ext>
             </a:extLst>
           </p:cNvPr>
@@ -12334,7 +12311,7 @@
           <p:cNvPr id="14" name="">
             <a:extLst xmlns:a="http://schemas.openxmlformats.org/drawingml/2006/main">
               <a:ext uri="{FF2B5EF4-FFF2-40B4-BE49-F238E27FC236}">
-                <a16:creationId xmlns:a16="http://schemas.microsoft.com/office/drawing/2014/main" id="{72B67F7F-8852-4210-B9C0-B7E0CE9146BE}"/>
+                <a16:creationId xmlns:a16="http://schemas.microsoft.com/office/drawing/2014/main" id="{70EFD2B6-DDA8-4904-A799-507A41408F87}"/>
               </a:ext>
             </a:extLst>
           </p:cNvPr>
@@ -12367,7 +12344,7 @@
           <p:cNvPr id="15" name="">
             <a:extLst xmlns:a="http://schemas.openxmlformats.org/drawingml/2006/main">
               <a:ext uri="{FF2B5EF4-FFF2-40B4-BE49-F238E27FC236}">
-                <a16:creationId xmlns:a16="http://schemas.microsoft.com/office/drawing/2014/main" id="{29461B6E-8B97-43FB-A07F-422717245B4B}"/>
+                <a16:creationId xmlns:a16="http://schemas.microsoft.com/office/drawing/2014/main" id="{BA880B2B-70E9-4981-817B-DAE8273F1406}"/>
               </a:ext>
             </a:extLst>
           </p:cNvPr>
@@ -12431,7 +12408,7 @@
           <p:cNvPr id="16" name="">
             <a:extLst xmlns:a="http://schemas.openxmlformats.org/drawingml/2006/main">
               <a:ext uri="{FF2B5EF4-FFF2-40B4-BE49-F238E27FC236}">
-                <a16:creationId xmlns:a16="http://schemas.microsoft.com/office/drawing/2014/main" id="{9BB8B8B6-0501-4A5B-B556-9A0B9D83CF34}"/>
+                <a16:creationId xmlns:a16="http://schemas.microsoft.com/office/drawing/2014/main" id="{CD9903D2-FC9A-493F-9565-D6698302E633}"/>
               </a:ext>
             </a:extLst>
           </p:cNvPr>
@@ -12495,7 +12472,7 @@
           <p:cNvPr id="17" name="">
             <a:extLst xmlns:a="http://schemas.openxmlformats.org/drawingml/2006/main">
               <a:ext uri="{FF2B5EF4-FFF2-40B4-BE49-F238E27FC236}">
-                <a16:creationId xmlns:a16="http://schemas.microsoft.com/office/drawing/2014/main" id="{1873C4AD-57A6-4FC3-8C83-2F919E36DF0B}"/>
+                <a16:creationId xmlns:a16="http://schemas.microsoft.com/office/drawing/2014/main" id="{0811001F-35A9-4292-B2F5-509C5393AFBC}"/>
               </a:ext>
             </a:extLst>
           </p:cNvPr>
@@ -12559,7 +12536,7 @@
           <p:cNvPr id="18" name="">
             <a:extLst xmlns:a="http://schemas.openxmlformats.org/drawingml/2006/main">
               <a:ext uri="{FF2B5EF4-FFF2-40B4-BE49-F238E27FC236}">
-                <a16:creationId xmlns:a16="http://schemas.microsoft.com/office/drawing/2014/main" id="{31E449D5-B6D8-4667-825C-16498257E896}"/>
+                <a16:creationId xmlns:a16="http://schemas.microsoft.com/office/drawing/2014/main" id="{CD0CF9DA-F481-47A6-9875-B748912D9B7F}"/>
               </a:ext>
             </a:extLst>
           </p:cNvPr>
@@ -12592,7 +12569,7 @@
           <p:cNvPr id="19" name="">
             <a:extLst xmlns:a="http://schemas.openxmlformats.org/drawingml/2006/main">
               <a:ext uri="{FF2B5EF4-FFF2-40B4-BE49-F238E27FC236}">
-                <a16:creationId xmlns:a16="http://schemas.microsoft.com/office/drawing/2014/main" id="{661BB39F-8C27-4360-832B-BCFC1E95ABE4}"/>
+                <a16:creationId xmlns:a16="http://schemas.microsoft.com/office/drawing/2014/main" id="{D2BBA5B8-66CF-49F6-80A4-F58BC545569B}"/>
               </a:ext>
             </a:extLst>
           </p:cNvPr>
@@ -12656,7 +12633,7 @@
           <p:cNvPr id="20" name="">
             <a:extLst xmlns:a="http://schemas.openxmlformats.org/drawingml/2006/main">
               <a:ext uri="{FF2B5EF4-FFF2-40B4-BE49-F238E27FC236}">
-                <a16:creationId xmlns:a16="http://schemas.microsoft.com/office/drawing/2014/main" id="{3774D310-527A-43CD-9372-A2A3A00BD984}"/>
+                <a16:creationId xmlns:a16="http://schemas.microsoft.com/office/drawing/2014/main" id="{63AB91A6-1DFA-4684-AD4C-03020C74B27B}"/>
               </a:ext>
             </a:extLst>
           </p:cNvPr>
@@ -12720,7 +12697,7 @@
           <p:cNvPr id="21" name="">
             <a:extLst xmlns:a="http://schemas.openxmlformats.org/drawingml/2006/main">
               <a:ext uri="{FF2B5EF4-FFF2-40B4-BE49-F238E27FC236}">
-                <a16:creationId xmlns:a16="http://schemas.microsoft.com/office/drawing/2014/main" id="{804B51FD-EF55-4FB5-96E0-D58F3D00D547}"/>
+                <a16:creationId xmlns:a16="http://schemas.microsoft.com/office/drawing/2014/main" id="{7FBA018E-DF6B-4126-965E-0C9CC7B0762D}"/>
               </a:ext>
             </a:extLst>
           </p:cNvPr>
@@ -12784,7 +12761,7 @@
           <p:cNvPr id="22" name="">
             <a:extLst xmlns:a="http://schemas.openxmlformats.org/drawingml/2006/main">
               <a:ext uri="{FF2B5EF4-FFF2-40B4-BE49-F238E27FC236}">
-                <a16:creationId xmlns:a16="http://schemas.microsoft.com/office/drawing/2014/main" id="{DF3B7295-757B-4A87-AB08-B1D073AFDE0D}"/>
+                <a16:creationId xmlns:a16="http://schemas.microsoft.com/office/drawing/2014/main" id="{DF530B84-9D2B-4A40-B685-7B4488CCE588}"/>
               </a:ext>
             </a:extLst>
           </p:cNvPr>
@@ -12817,7 +12794,7 @@
           <p:cNvPr id="23" name="">
             <a:extLst xmlns:a="http://schemas.openxmlformats.org/drawingml/2006/main">
               <a:ext uri="{FF2B5EF4-FFF2-40B4-BE49-F238E27FC236}">
-                <a16:creationId xmlns:a16="http://schemas.microsoft.com/office/drawing/2014/main" id="{7921CEC9-9D99-476E-82F0-2333BA102D59}"/>
+                <a16:creationId xmlns:a16="http://schemas.microsoft.com/office/drawing/2014/main" id="{7916DCCB-51D7-4FBD-BF67-94A5881DBBEF}"/>
               </a:ext>
             </a:extLst>
           </p:cNvPr>
@@ -12881,7 +12858,7 @@
           <p:cNvPr id="24" name="">
             <a:extLst xmlns:a="http://schemas.openxmlformats.org/drawingml/2006/main">
               <a:ext uri="{FF2B5EF4-FFF2-40B4-BE49-F238E27FC236}">
-                <a16:creationId xmlns:a16="http://schemas.microsoft.com/office/drawing/2014/main" id="{42DCD209-A01F-44C5-A31C-4CC23FD766E5}"/>
+                <a16:creationId xmlns:a16="http://schemas.microsoft.com/office/drawing/2014/main" id="{04FBC01E-5830-4235-BA82-936C271305DB}"/>
               </a:ext>
             </a:extLst>
           </p:cNvPr>
@@ -12945,7 +12922,7 @@
           <p:cNvPr id="25" name="">
             <a:extLst xmlns:a="http://schemas.openxmlformats.org/drawingml/2006/main">
               <a:ext uri="{FF2B5EF4-FFF2-40B4-BE49-F238E27FC236}">
-                <a16:creationId xmlns:a16="http://schemas.microsoft.com/office/drawing/2014/main" id="{EB0FC325-75E3-4BD2-837F-C768E7DA91F2}"/>
+                <a16:creationId xmlns:a16="http://schemas.microsoft.com/office/drawing/2014/main" id="{8B369233-AD8C-4450-9F0B-701B39E7B457}"/>
               </a:ext>
             </a:extLst>
           </p:cNvPr>
@@ -13009,7 +12986,7 @@
           <p:cNvPr id="26" name="">
             <a:extLst xmlns:a="http://schemas.openxmlformats.org/drawingml/2006/main">
               <a:ext uri="{FF2B5EF4-FFF2-40B4-BE49-F238E27FC236}">
-                <a16:creationId xmlns:a16="http://schemas.microsoft.com/office/drawing/2014/main" id="{F3A5B6D7-498A-49B0-924A-0DE234E9EEA7}"/>
+                <a16:creationId xmlns:a16="http://schemas.microsoft.com/office/drawing/2014/main" id="{987B471F-100D-4C1B-940F-FB9FCABF33FF}"/>
               </a:ext>
             </a:extLst>
           </p:cNvPr>
@@ -13042,7 +13019,7 @@
           <p:cNvPr id="27" name="">
             <a:extLst xmlns:a="http://schemas.openxmlformats.org/drawingml/2006/main">
               <a:ext uri="{FF2B5EF4-FFF2-40B4-BE49-F238E27FC236}">
-                <a16:creationId xmlns:a16="http://schemas.microsoft.com/office/drawing/2014/main" id="{BACFC7C1-F6C6-4432-8477-A65BD40957D1}"/>
+                <a16:creationId xmlns:a16="http://schemas.microsoft.com/office/drawing/2014/main" id="{CDCE44A0-E9B5-4A37-9860-53FCFBEC89EC}"/>
               </a:ext>
             </a:extLst>
           </p:cNvPr>
@@ -13106,7 +13083,7 @@
           <p:cNvPr id="28" name="">
             <a:extLst xmlns:a="http://schemas.openxmlformats.org/drawingml/2006/main">
               <a:ext uri="{FF2B5EF4-FFF2-40B4-BE49-F238E27FC236}">
-                <a16:creationId xmlns:a16="http://schemas.microsoft.com/office/drawing/2014/main" id="{9130AE1D-506E-4170-AAB7-41F52BD33B10}"/>
+                <a16:creationId xmlns:a16="http://schemas.microsoft.com/office/drawing/2014/main" id="{DE8F2E9C-066E-405A-A9FC-4FC83239895A}"/>
               </a:ext>
             </a:extLst>
           </p:cNvPr>
@@ -13139,7 +13116,7 @@
           <p:cNvPr id="29" name="">
             <a:extLst xmlns:a="http://schemas.openxmlformats.org/drawingml/2006/main">
               <a:ext uri="{FF2B5EF4-FFF2-40B4-BE49-F238E27FC236}">
-                <a16:creationId xmlns:a16="http://schemas.microsoft.com/office/drawing/2014/main" id="{EDC250F9-CD20-4B8D-865D-2D269E2E71F3}"/>
+                <a16:creationId xmlns:a16="http://schemas.microsoft.com/office/drawing/2014/main" id="{4C536B06-7B4F-4928-A905-A4A20135781E}"/>
               </a:ext>
             </a:extLst>
           </p:cNvPr>
@@ -13174,7 +13151,7 @@
           <p:cNvPr id="30" name="">
             <a:extLst xmlns:a="http://schemas.openxmlformats.org/drawingml/2006/main">
               <a:ext uri="{FF2B5EF4-FFF2-40B4-BE49-F238E27FC236}">
-                <a16:creationId xmlns:a16="http://schemas.microsoft.com/office/drawing/2014/main" id="{383C4F6E-CED1-47FB-B442-621A201F2309}"/>
+                <a16:creationId xmlns:a16="http://schemas.microsoft.com/office/drawing/2014/main" id="{2EBA912B-8ED7-4520-AE19-EAF3158AFD52}"/>
               </a:ext>
             </a:extLst>
           </p:cNvPr>
@@ -13238,7 +13215,7 @@
           <p:cNvPr id="31" name="">
             <a:extLst xmlns:a="http://schemas.openxmlformats.org/drawingml/2006/main">
               <a:ext uri="{FF2B5EF4-FFF2-40B4-BE49-F238E27FC236}">
-                <a16:creationId xmlns:a16="http://schemas.microsoft.com/office/drawing/2014/main" id="{80221701-C62D-4FF5-BEB5-5A71F0E1DFA0}"/>
+                <a16:creationId xmlns:a16="http://schemas.microsoft.com/office/drawing/2014/main" id="{8B99A062-41B8-4210-B14D-1B049112041E}"/>
               </a:ext>
             </a:extLst>
           </p:cNvPr>
@@ -13302,7 +13279,7 @@
           <p:cNvPr id="32" name="">
             <a:extLst xmlns:a="http://schemas.openxmlformats.org/drawingml/2006/main">
               <a:ext uri="{FF2B5EF4-FFF2-40B4-BE49-F238E27FC236}">
-                <a16:creationId xmlns:a16="http://schemas.microsoft.com/office/drawing/2014/main" id="{0DDC7CB5-F93B-4DB8-AC73-1EFABB47FD9A}"/>
+                <a16:creationId xmlns:a16="http://schemas.microsoft.com/office/drawing/2014/main" id="{0A27C838-082D-4B21-9A96-70C6A19F416F}"/>
               </a:ext>
             </a:extLst>
           </p:cNvPr>
@@ -13366,7 +13343,7 @@
           <p:cNvPr id="33" name="">
             <a:extLst xmlns:a="http://schemas.openxmlformats.org/drawingml/2006/main">
               <a:ext uri="{FF2B5EF4-FFF2-40B4-BE49-F238E27FC236}">
-                <a16:creationId xmlns:a16="http://schemas.microsoft.com/office/drawing/2014/main" id="{9811AF2B-2DB1-47CF-AB5B-06A2A00A144C}"/>
+                <a16:creationId xmlns:a16="http://schemas.microsoft.com/office/drawing/2014/main" id="{B2624193-7D1D-4082-91CF-03FEC6B0BDD0}"/>
               </a:ext>
             </a:extLst>
           </p:cNvPr>
@@ -13428,7 +13405,7 @@
     </p:spTree>
     <p:extLst>
       <p:ext uri="{BB962C8B-B14F-4D97-AF65-F5344CB8AC3E}">
-        <p14:creationId xmlns:p14="http://schemas.microsoft.com/office/powerpoint/2010/main" val="1136636484"/>
+        <p14:creationId xmlns:p14="http://schemas.microsoft.com/office/powerpoint/2010/main" val="1053955207"/>
       </p:ext>
     </p:extLst>
   </p:cSld>
@@ -13452,7 +13429,7 @@
           <p:cNvPr id="1" name="">
             <a:extLst xmlns:a="http://schemas.openxmlformats.org/drawingml/2006/main">
               <a:ext uri="{FF2B5EF4-FFF2-40B4-BE49-F238E27FC236}">
-                <a16:creationId xmlns:a16="http://schemas.microsoft.com/office/drawing/2014/main" id="{900EBC3B-386B-420A-9BBE-559A9DE3B133}"/>
+                <a16:creationId xmlns:a16="http://schemas.microsoft.com/office/drawing/2014/main" id="{A151CCC9-E065-44ED-9510-81A866233966}"/>
               </a:ext>
             </a:extLst>
           </p:cNvPr>
@@ -13487,7 +13464,7 @@
           <p:cNvPr id="2" name="">
             <a:extLst xmlns:a="http://schemas.openxmlformats.org/drawingml/2006/main">
               <a:ext uri="{FF2B5EF4-FFF2-40B4-BE49-F238E27FC236}">
-                <a16:creationId xmlns:a16="http://schemas.microsoft.com/office/drawing/2014/main" id="{020682DB-183E-49A1-B951-132DC100CCB3}"/>
+                <a16:creationId xmlns:a16="http://schemas.microsoft.com/office/drawing/2014/main" id="{7E2634DE-5EC4-4992-B5DD-874CACB99354}"/>
               </a:ext>
             </a:extLst>
           </p:cNvPr>
@@ -13551,7 +13528,7 @@
           <p:cNvPr id="3" name="">
             <a:extLst xmlns:a="http://schemas.openxmlformats.org/drawingml/2006/main">
               <a:ext uri="{FF2B5EF4-FFF2-40B4-BE49-F238E27FC236}">
-                <a16:creationId xmlns:a16="http://schemas.microsoft.com/office/drawing/2014/main" id="{9D94236C-F381-4333-A115-B6090B6A6741}"/>
+                <a16:creationId xmlns:a16="http://schemas.microsoft.com/office/drawing/2014/main" id="{EC48FCB6-32AA-4F1A-8113-D4CA6BA9DB16}"/>
               </a:ext>
             </a:extLst>
           </p:cNvPr>
@@ -13615,7 +13592,7 @@
           <p:cNvPr id="4" name="">
             <a:extLst xmlns:a="http://schemas.openxmlformats.org/drawingml/2006/main">
               <a:ext uri="{FF2B5EF4-FFF2-40B4-BE49-F238E27FC236}">
-                <a16:creationId xmlns:a16="http://schemas.microsoft.com/office/drawing/2014/main" id="{FDEE0F50-8B25-4957-8AC5-BC85BB038A19}"/>
+                <a16:creationId xmlns:a16="http://schemas.microsoft.com/office/drawing/2014/main" id="{E108890F-456B-4CA2-BB40-55331FB4F501}"/>
               </a:ext>
             </a:extLst>
           </p:cNvPr>
@@ -13679,7 +13656,7 @@
           <p:cNvPr id="5" name="">
             <a:extLst xmlns:a="http://schemas.openxmlformats.org/drawingml/2006/main">
               <a:ext uri="{FF2B5EF4-FFF2-40B4-BE49-F238E27FC236}">
-                <a16:creationId xmlns:a16="http://schemas.microsoft.com/office/drawing/2014/main" id="{AC9C1E54-A12E-4560-B993-884247B02E06}"/>
+                <a16:creationId xmlns:a16="http://schemas.microsoft.com/office/drawing/2014/main" id="{5B744F81-589C-4B80-A1CB-EE02004679AC}"/>
               </a:ext>
             </a:extLst>
           </p:cNvPr>
@@ -13714,7 +13691,7 @@
           <p:cNvPr id="6" name="">
             <a:extLst xmlns:a="http://schemas.openxmlformats.org/drawingml/2006/main">
               <a:ext uri="{FF2B5EF4-FFF2-40B4-BE49-F238E27FC236}">
-                <a16:creationId xmlns:a16="http://schemas.microsoft.com/office/drawing/2014/main" id="{EE897554-F2E1-4114-A3E6-70BC301ECF66}"/>
+                <a16:creationId xmlns:a16="http://schemas.microsoft.com/office/drawing/2014/main" id="{14FC4F98-3549-426C-AB7C-7B649009018D}"/>
               </a:ext>
             </a:extLst>
           </p:cNvPr>
@@ -13747,7 +13724,7 @@
           <p:cNvPr id="7" name="">
             <a:extLst xmlns:a="http://schemas.openxmlformats.org/drawingml/2006/main">
               <a:ext uri="{FF2B5EF4-FFF2-40B4-BE49-F238E27FC236}">
-                <a16:creationId xmlns:a16="http://schemas.microsoft.com/office/drawing/2014/main" id="{E9E9CBCA-1661-4417-B1EB-24398917B148}"/>
+                <a16:creationId xmlns:a16="http://schemas.microsoft.com/office/drawing/2014/main" id="{D918AE3A-EC7B-40AB-A138-137AA2696E4D}"/>
               </a:ext>
             </a:extLst>
           </p:cNvPr>
@@ -13811,7 +13788,7 @@
           <p:cNvPr id="8" name="">
             <a:extLst xmlns:a="http://schemas.openxmlformats.org/drawingml/2006/main">
               <a:ext uri="{FF2B5EF4-FFF2-40B4-BE49-F238E27FC236}">
-                <a16:creationId xmlns:a16="http://schemas.microsoft.com/office/drawing/2014/main" id="{5447E241-A43D-4169-8ED8-6D0E6F9B1D7E}"/>
+                <a16:creationId xmlns:a16="http://schemas.microsoft.com/office/drawing/2014/main" id="{120B5874-3513-4801-9BDA-4886AEC4FB5A}"/>
               </a:ext>
             </a:extLst>
           </p:cNvPr>
@@ -13865,7 +13842,7 @@
                 <a:ea typeface="Microsoft YaHei"/>
                 <a:cs typeface="Microsoft YaHei"/>
               </a:rPr>
-              <a:t>材料识别</a:t>
+              <a:t>数据摄入</a:t>
             </a:r>
           </a:p>
         </p:txBody>
@@ -13875,7 +13852,7 @@
           <p:cNvPr id="9" name="">
             <a:extLst xmlns:a="http://schemas.openxmlformats.org/drawingml/2006/main">
               <a:ext uri="{FF2B5EF4-FFF2-40B4-BE49-F238E27FC236}">
-                <a16:creationId xmlns:a16="http://schemas.microsoft.com/office/drawing/2014/main" id="{976B2CA7-6EDE-42C0-B34A-C22D10309BCA}"/>
+                <a16:creationId xmlns:a16="http://schemas.microsoft.com/office/drawing/2014/main" id="{75E57FCF-1AD6-4607-A4DA-9248E36DD486}"/>
               </a:ext>
             </a:extLst>
           </p:cNvPr>
@@ -13929,7 +13906,7 @@
                 <a:ea typeface="Microsoft YaHei"/>
                 <a:cs typeface="Microsoft YaHei"/>
               </a:rPr>
-              <a:t>票据/流水/底稿</a:t>
+              <a:t>演示/CSV</a:t>
             </a:r>
           </a:p>
         </p:txBody>
@@ -13939,7 +13916,7 @@
           <p:cNvPr id="10" name="">
             <a:extLst xmlns:a="http://schemas.openxmlformats.org/drawingml/2006/main">
               <a:ext uri="{FF2B5EF4-FFF2-40B4-BE49-F238E27FC236}">
-                <a16:creationId xmlns:a16="http://schemas.microsoft.com/office/drawing/2014/main" id="{04FA41FC-895E-44BC-B5C6-EA204D51CF6F}"/>
+                <a16:creationId xmlns:a16="http://schemas.microsoft.com/office/drawing/2014/main" id="{3E7DCD19-D360-49B2-97E1-20FDB5008FE6}"/>
               </a:ext>
             </a:extLst>
           </p:cNvPr>
@@ -14003,7 +13980,7 @@
           <p:cNvPr id="11" name="">
             <a:extLst xmlns:a="http://schemas.openxmlformats.org/drawingml/2006/main">
               <a:ext uri="{FF2B5EF4-FFF2-40B4-BE49-F238E27FC236}">
-                <a16:creationId xmlns:a16="http://schemas.microsoft.com/office/drawing/2014/main" id="{197AF835-9319-436C-8818-5F4898F3C4F0}"/>
+                <a16:creationId xmlns:a16="http://schemas.microsoft.com/office/drawing/2014/main" id="{8B23C20F-559B-4CA1-AB97-C240F0C3C72C}"/>
               </a:ext>
             </a:extLst>
           </p:cNvPr>
@@ -14036,7 +14013,7 @@
           <p:cNvPr id="12" name="">
             <a:extLst xmlns:a="http://schemas.openxmlformats.org/drawingml/2006/main">
               <a:ext uri="{FF2B5EF4-FFF2-40B4-BE49-F238E27FC236}">
-                <a16:creationId xmlns:a16="http://schemas.microsoft.com/office/drawing/2014/main" id="{38A41F67-B519-4F2C-B3CD-2220AE0E2F47}"/>
+                <a16:creationId xmlns:a16="http://schemas.microsoft.com/office/drawing/2014/main" id="{5B88C19F-631B-474B-B2C3-9B76315B2F15}"/>
               </a:ext>
             </a:extLst>
           </p:cNvPr>
@@ -14100,7 +14077,7 @@
           <p:cNvPr id="13" name="">
             <a:extLst xmlns:a="http://schemas.openxmlformats.org/drawingml/2006/main">
               <a:ext uri="{FF2B5EF4-FFF2-40B4-BE49-F238E27FC236}">
-                <a16:creationId xmlns:a16="http://schemas.microsoft.com/office/drawing/2014/main" id="{FD2E988B-16C8-47E3-A8FE-B6136D31C967}"/>
+                <a16:creationId xmlns:a16="http://schemas.microsoft.com/office/drawing/2014/main" id="{59C67B72-D3A6-4907-9292-B9C7B92770F6}"/>
               </a:ext>
             </a:extLst>
           </p:cNvPr>
@@ -14154,7 +14131,7 @@
                 <a:ea typeface="Microsoft YaHei"/>
                 <a:cs typeface="Microsoft YaHei"/>
               </a:rPr>
-              <a:t>制度检索</a:t>
+              <a:t>清洗评分</a:t>
             </a:r>
           </a:p>
         </p:txBody>
@@ -14164,7 +14141,7 @@
           <p:cNvPr id="14" name="">
             <a:extLst xmlns:a="http://schemas.openxmlformats.org/drawingml/2006/main">
               <a:ext uri="{FF2B5EF4-FFF2-40B4-BE49-F238E27FC236}">
-                <a16:creationId xmlns:a16="http://schemas.microsoft.com/office/drawing/2014/main" id="{9BEFD15D-1E07-4A89-8D98-D04F49D9FCE8}"/>
+                <a16:creationId xmlns:a16="http://schemas.microsoft.com/office/drawing/2014/main" id="{5384CC12-8634-4C9B-96EE-15A62A7D588F}"/>
               </a:ext>
             </a:extLst>
           </p:cNvPr>
@@ -14218,7 +14195,7 @@
                 <a:ea typeface="Microsoft YaHei"/>
                 <a:cs typeface="Microsoft YaHei"/>
               </a:rPr>
-              <a:t>准则/报销政策</a:t>
+              <a:t>缺失/重复/FX</a:t>
             </a:r>
           </a:p>
         </p:txBody>
@@ -14228,7 +14205,7 @@
           <p:cNvPr id="15" name="">
             <a:extLst xmlns:a="http://schemas.openxmlformats.org/drawingml/2006/main">
               <a:ext uri="{FF2B5EF4-FFF2-40B4-BE49-F238E27FC236}">
-                <a16:creationId xmlns:a16="http://schemas.microsoft.com/office/drawing/2014/main" id="{8B2B3E44-BFD0-43D6-A797-CC4CF1B4F144}"/>
+                <a16:creationId xmlns:a16="http://schemas.microsoft.com/office/drawing/2014/main" id="{D3D862BE-7757-49E7-8800-006EC0DE87EC}"/>
               </a:ext>
             </a:extLst>
           </p:cNvPr>
@@ -14292,7 +14269,7 @@
           <p:cNvPr id="16" name="">
             <a:extLst xmlns:a="http://schemas.openxmlformats.org/drawingml/2006/main">
               <a:ext uri="{FF2B5EF4-FFF2-40B4-BE49-F238E27FC236}">
-                <a16:creationId xmlns:a16="http://schemas.microsoft.com/office/drawing/2014/main" id="{3469B5AE-8D7B-475E-A2B4-B907B7C0F33B}"/>
+                <a16:creationId xmlns:a16="http://schemas.microsoft.com/office/drawing/2014/main" id="{766E8D5E-7BAF-49E1-BDD0-D2A0B217FD3C}"/>
               </a:ext>
             </a:extLst>
           </p:cNvPr>
@@ -14325,7 +14302,7 @@
           <p:cNvPr id="17" name="">
             <a:extLst xmlns:a="http://schemas.openxmlformats.org/drawingml/2006/main">
               <a:ext uri="{FF2B5EF4-FFF2-40B4-BE49-F238E27FC236}">
-                <a16:creationId xmlns:a16="http://schemas.microsoft.com/office/drawing/2014/main" id="{4027D538-C5A2-4967-A14B-88EAC4D1CE3E}"/>
+                <a16:creationId xmlns:a16="http://schemas.microsoft.com/office/drawing/2014/main" id="{11951F1E-E832-4752-ADF6-8A42FFB6A319}"/>
               </a:ext>
             </a:extLst>
           </p:cNvPr>
@@ -14389,7 +14366,7 @@
           <p:cNvPr id="18" name="">
             <a:extLst xmlns:a="http://schemas.openxmlformats.org/drawingml/2006/main">
               <a:ext uri="{FF2B5EF4-FFF2-40B4-BE49-F238E27FC236}">
-                <a16:creationId xmlns:a16="http://schemas.microsoft.com/office/drawing/2014/main" id="{E23EBF4A-8D1A-4E59-9A94-D10C9482A3D4}"/>
+                <a16:creationId xmlns:a16="http://schemas.microsoft.com/office/drawing/2014/main" id="{12A247B9-D510-46D1-A2D5-3A0B688C818A}"/>
               </a:ext>
             </a:extLst>
           </p:cNvPr>
@@ -14443,7 +14420,7 @@
                 <a:ea typeface="Microsoft YaHei"/>
                 <a:cs typeface="Microsoft YaHei"/>
               </a:rPr>
-              <a:t>字段比对</a:t>
+              <a:t>规则扫描</a:t>
             </a:r>
           </a:p>
         </p:txBody>
@@ -14453,7 +14430,7 @@
           <p:cNvPr id="19" name="">
             <a:extLst xmlns:a="http://schemas.openxmlformats.org/drawingml/2006/main">
               <a:ext uri="{FF2B5EF4-FFF2-40B4-BE49-F238E27FC236}">
-                <a16:creationId xmlns:a16="http://schemas.microsoft.com/office/drawing/2014/main" id="{10DF6A86-612B-4BF6-B713-CE2116DEC4CE}"/>
+                <a16:creationId xmlns:a16="http://schemas.microsoft.com/office/drawing/2014/main" id="{99DC0B13-7A3C-40C1-A53D-8A4394F50B80}"/>
               </a:ext>
             </a:extLst>
           </p:cNvPr>
@@ -14507,7 +14484,7 @@
                 <a:ea typeface="Microsoft YaHei"/>
                 <a:cs typeface="Microsoft YaHei"/>
               </a:rPr>
-              <a:t>金额/日期/主体</a:t>
+              <a:t>ISA 240/520</a:t>
             </a:r>
           </a:p>
         </p:txBody>
@@ -14517,7 +14494,7 @@
           <p:cNvPr id="20" name="">
             <a:extLst xmlns:a="http://schemas.openxmlformats.org/drawingml/2006/main">
               <a:ext uri="{FF2B5EF4-FFF2-40B4-BE49-F238E27FC236}">
-                <a16:creationId xmlns:a16="http://schemas.microsoft.com/office/drawing/2014/main" id="{65F10C6F-1846-4E1A-B26C-A09B333D2F78}"/>
+                <a16:creationId xmlns:a16="http://schemas.microsoft.com/office/drawing/2014/main" id="{E98E289F-BA2F-4727-BB91-F8F620B5902B}"/>
               </a:ext>
             </a:extLst>
           </p:cNvPr>
@@ -14581,7 +14558,7 @@
           <p:cNvPr id="21" name="">
             <a:extLst xmlns:a="http://schemas.openxmlformats.org/drawingml/2006/main">
               <a:ext uri="{FF2B5EF4-FFF2-40B4-BE49-F238E27FC236}">
-                <a16:creationId xmlns:a16="http://schemas.microsoft.com/office/drawing/2014/main" id="{A50E02B6-B8A5-47CD-9147-836900C2557D}"/>
+                <a16:creationId xmlns:a16="http://schemas.microsoft.com/office/drawing/2014/main" id="{A004C1C8-D5A7-43F5-B9FA-219DF39FDDA3}"/>
               </a:ext>
             </a:extLst>
           </p:cNvPr>
@@ -14614,7 +14591,7 @@
           <p:cNvPr id="22" name="">
             <a:extLst xmlns:a="http://schemas.openxmlformats.org/drawingml/2006/main">
               <a:ext uri="{FF2B5EF4-FFF2-40B4-BE49-F238E27FC236}">
-                <a16:creationId xmlns:a16="http://schemas.microsoft.com/office/drawing/2014/main" id="{CAD3FE19-A0FA-4B72-BC6F-E3CA46AB0C78}"/>
+                <a16:creationId xmlns:a16="http://schemas.microsoft.com/office/drawing/2014/main" id="{B3746AE9-5720-4EB6-9C3B-87264F03B651}"/>
               </a:ext>
             </a:extLst>
           </p:cNvPr>
@@ -14678,7 +14655,7 @@
           <p:cNvPr id="23" name="">
             <a:extLst xmlns:a="http://schemas.openxmlformats.org/drawingml/2006/main">
               <a:ext uri="{FF2B5EF4-FFF2-40B4-BE49-F238E27FC236}">
-                <a16:creationId xmlns:a16="http://schemas.microsoft.com/office/drawing/2014/main" id="{AAE34417-631C-4F03-B4E6-A97A2A55BDBD}"/>
+                <a16:creationId xmlns:a16="http://schemas.microsoft.com/office/drawing/2014/main" id="{F4C0278C-0344-4DC3-882E-18CE3C998B1A}"/>
               </a:ext>
             </a:extLst>
           </p:cNvPr>
@@ -14732,7 +14709,7 @@
                 <a:ea typeface="Microsoft YaHei"/>
                 <a:cs typeface="Microsoft YaHei"/>
               </a:rPr>
-              <a:t>异常判断</a:t>
+              <a:t>AI 分析</a:t>
             </a:r>
           </a:p>
         </p:txBody>
@@ -14742,7 +14719,7 @@
           <p:cNvPr id="24" name="">
             <a:extLst xmlns:a="http://schemas.openxmlformats.org/drawingml/2006/main">
               <a:ext uri="{FF2B5EF4-FFF2-40B4-BE49-F238E27FC236}">
-                <a16:creationId xmlns:a16="http://schemas.microsoft.com/office/drawing/2014/main" id="{B01CF35E-FC11-4F9A-A956-EF1CFE7B7642}"/>
+                <a16:creationId xmlns:a16="http://schemas.microsoft.com/office/drawing/2014/main" id="{631BCAE5-BED0-4EE0-8D95-D6C70197BB75}"/>
               </a:ext>
             </a:extLst>
           </p:cNvPr>
@@ -14796,7 +14773,7 @@
                 <a:ea typeface="Microsoft YaHei"/>
                 <a:cs typeface="Microsoft YaHei"/>
               </a:rPr>
-              <a:t>规则 + 模型</a:t>
+              <a:t>DeepSeek/离线</a:t>
             </a:r>
           </a:p>
         </p:txBody>
@@ -14806,7 +14783,7 @@
           <p:cNvPr id="25" name="">
             <a:extLst xmlns:a="http://schemas.openxmlformats.org/drawingml/2006/main">
               <a:ext uri="{FF2B5EF4-FFF2-40B4-BE49-F238E27FC236}">
-                <a16:creationId xmlns:a16="http://schemas.microsoft.com/office/drawing/2014/main" id="{DAC5FF9B-7E49-44B1-9213-B78077C1F6CA}"/>
+                <a16:creationId xmlns:a16="http://schemas.microsoft.com/office/drawing/2014/main" id="{E19CADB4-2CC0-4001-8E36-B6F4985ED48B}"/>
               </a:ext>
             </a:extLst>
           </p:cNvPr>
@@ -14870,7 +14847,7 @@
           <p:cNvPr id="26" name="">
             <a:extLst xmlns:a="http://schemas.openxmlformats.org/drawingml/2006/main">
               <a:ext uri="{FF2B5EF4-FFF2-40B4-BE49-F238E27FC236}">
-                <a16:creationId xmlns:a16="http://schemas.microsoft.com/office/drawing/2014/main" id="{ACD9F9FC-DDD3-470E-94BF-48A885CAFEDA}"/>
+                <a16:creationId xmlns:a16="http://schemas.microsoft.com/office/drawing/2014/main" id="{CB3D4D8C-77DB-4BB7-88D4-DFB75A6D35E5}"/>
               </a:ext>
             </a:extLst>
           </p:cNvPr>
@@ -14903,7 +14880,7 @@
           <p:cNvPr id="27" name="">
             <a:extLst xmlns:a="http://schemas.openxmlformats.org/drawingml/2006/main">
               <a:ext uri="{FF2B5EF4-FFF2-40B4-BE49-F238E27FC236}">
-                <a16:creationId xmlns:a16="http://schemas.microsoft.com/office/drawing/2014/main" id="{989E70F0-4A58-44F7-8136-41A2D82E9775}"/>
+                <a16:creationId xmlns:a16="http://schemas.microsoft.com/office/drawing/2014/main" id="{83C11FC3-5FE4-4CBE-871A-AA97B71D4932}"/>
               </a:ext>
             </a:extLst>
           </p:cNvPr>
@@ -14967,7 +14944,7 @@
           <p:cNvPr id="28" name="">
             <a:extLst xmlns:a="http://schemas.openxmlformats.org/drawingml/2006/main">
               <a:ext uri="{FF2B5EF4-FFF2-40B4-BE49-F238E27FC236}">
-                <a16:creationId xmlns:a16="http://schemas.microsoft.com/office/drawing/2014/main" id="{59FD3EE0-F1B6-4917-970E-AC00CE625D25}"/>
+                <a16:creationId xmlns:a16="http://schemas.microsoft.com/office/drawing/2014/main" id="{224AEF7C-36A6-4714-A233-82398341B0FC}"/>
               </a:ext>
             </a:extLst>
           </p:cNvPr>
@@ -15021,7 +14998,7 @@
                 <a:ea typeface="Microsoft YaHei"/>
                 <a:cs typeface="Microsoft YaHei"/>
               </a:rPr>
-              <a:t>证据引用</a:t>
+              <a:t>资金核对</a:t>
             </a:r>
           </a:p>
         </p:txBody>
@@ -15031,7 +15008,7 @@
           <p:cNvPr id="29" name="">
             <a:extLst xmlns:a="http://schemas.openxmlformats.org/drawingml/2006/main">
               <a:ext uri="{FF2B5EF4-FFF2-40B4-BE49-F238E27FC236}">
-                <a16:creationId xmlns:a16="http://schemas.microsoft.com/office/drawing/2014/main" id="{6D557A45-B190-43E1-BCD5-A87494ACA688}"/>
+                <a16:creationId xmlns:a16="http://schemas.microsoft.com/office/drawing/2014/main" id="{86519517-5C61-4FC9-9F92-590DAEBC7A62}"/>
               </a:ext>
             </a:extLst>
           </p:cNvPr>
@@ -15085,7 +15062,7 @@
                 <a:ea typeface="Microsoft YaHei"/>
                 <a:cs typeface="Microsoft YaHei"/>
               </a:rPr>
-              <a:t>来源留痕</a:t>
+              <a:t>应收/实收</a:t>
             </a:r>
           </a:p>
         </p:txBody>
@@ -15095,7 +15072,7 @@
           <p:cNvPr id="30" name="">
             <a:extLst xmlns:a="http://schemas.openxmlformats.org/drawingml/2006/main">
               <a:ext uri="{FF2B5EF4-FFF2-40B4-BE49-F238E27FC236}">
-                <a16:creationId xmlns:a16="http://schemas.microsoft.com/office/drawing/2014/main" id="{2C193257-51AD-4A6D-A7AC-C28BFB218043}"/>
+                <a16:creationId xmlns:a16="http://schemas.microsoft.com/office/drawing/2014/main" id="{F1EB1400-674E-4ADA-9D6B-58DFE23EB3A3}"/>
               </a:ext>
             </a:extLst>
           </p:cNvPr>
@@ -15159,7 +15136,7 @@
           <p:cNvPr id="31" name="">
             <a:extLst xmlns:a="http://schemas.openxmlformats.org/drawingml/2006/main">
               <a:ext uri="{FF2B5EF4-FFF2-40B4-BE49-F238E27FC236}">
-                <a16:creationId xmlns:a16="http://schemas.microsoft.com/office/drawing/2014/main" id="{9DB1E3FE-0B2E-4861-AE20-8383474CAC87}"/>
+                <a16:creationId xmlns:a16="http://schemas.microsoft.com/office/drawing/2014/main" id="{3398B31A-CB2D-4E7A-B634-92CF55F95F42}"/>
               </a:ext>
             </a:extLst>
           </p:cNvPr>
@@ -15192,7 +15169,7 @@
           <p:cNvPr id="32" name="">
             <a:extLst xmlns:a="http://schemas.openxmlformats.org/drawingml/2006/main">
               <a:ext uri="{FF2B5EF4-FFF2-40B4-BE49-F238E27FC236}">
-                <a16:creationId xmlns:a16="http://schemas.microsoft.com/office/drawing/2014/main" id="{8A7E0E8A-8CA2-4332-AAEC-3B3CAA2F7B3F}"/>
+                <a16:creationId xmlns:a16="http://schemas.microsoft.com/office/drawing/2014/main" id="{DD2E4C2C-9263-4608-BAE7-1B2FA873E582}"/>
               </a:ext>
             </a:extLst>
           </p:cNvPr>
@@ -15256,7 +15233,7 @@
           <p:cNvPr id="33" name="">
             <a:extLst xmlns:a="http://schemas.openxmlformats.org/drawingml/2006/main">
               <a:ext uri="{FF2B5EF4-FFF2-40B4-BE49-F238E27FC236}">
-                <a16:creationId xmlns:a16="http://schemas.microsoft.com/office/drawing/2014/main" id="{5AD1FFEA-EE87-4BCD-993E-1020A349C0A1}"/>
+                <a16:creationId xmlns:a16="http://schemas.microsoft.com/office/drawing/2014/main" id="{DE6C169B-CDF5-47E6-AF0F-92813BA52918}"/>
               </a:ext>
             </a:extLst>
           </p:cNvPr>
@@ -15310,7 +15287,7 @@
                 <a:ea typeface="Microsoft YaHei"/>
                 <a:cs typeface="Microsoft YaHei"/>
               </a:rPr>
-              <a:t>人工复核</a:t>
+              <a:t>报告生成</a:t>
             </a:r>
           </a:p>
         </p:txBody>
@@ -15320,7 +15297,7 @@
           <p:cNvPr id="34" name="">
             <a:extLst xmlns:a="http://schemas.openxmlformats.org/drawingml/2006/main">
               <a:ext uri="{FF2B5EF4-FFF2-40B4-BE49-F238E27FC236}">
-                <a16:creationId xmlns:a16="http://schemas.microsoft.com/office/drawing/2014/main" id="{957CBE62-C6C3-423F-951F-D724C9DC6F12}"/>
+                <a16:creationId xmlns:a16="http://schemas.microsoft.com/office/drawing/2014/main" id="{08D9B38A-B146-4F99-A6A2-E2C58A670308}"/>
               </a:ext>
             </a:extLst>
           </p:cNvPr>
@@ -15374,7 +15351,7 @@
                 <a:ea typeface="Microsoft YaHei"/>
                 <a:cs typeface="Microsoft YaHei"/>
               </a:rPr>
-              <a:t>低置信度兜底</a:t>
+              <a:t>图表/Markdown</a:t>
             </a:r>
           </a:p>
         </p:txBody>
@@ -15384,7 +15361,7 @@
           <p:cNvPr id="35" name="">
             <a:extLst xmlns:a="http://schemas.openxmlformats.org/drawingml/2006/main">
               <a:ext uri="{FF2B5EF4-FFF2-40B4-BE49-F238E27FC236}">
-                <a16:creationId xmlns:a16="http://schemas.microsoft.com/office/drawing/2014/main" id="{EA43906E-D747-4FB3-9B9C-52CFFFA6F5F8}"/>
+                <a16:creationId xmlns:a16="http://schemas.microsoft.com/office/drawing/2014/main" id="{E13223C3-F60A-4332-B6B3-7701140D4595}"/>
               </a:ext>
             </a:extLst>
           </p:cNvPr>
@@ -15448,7 +15425,7 @@
           <p:cNvPr id="36" name="">
             <a:extLst xmlns:a="http://schemas.openxmlformats.org/drawingml/2006/main">
               <a:ext uri="{FF2B5EF4-FFF2-40B4-BE49-F238E27FC236}">
-                <a16:creationId xmlns:a16="http://schemas.microsoft.com/office/drawing/2014/main" id="{90A0C59D-E0EE-4E54-B818-86CF6D76911C}"/>
+                <a16:creationId xmlns:a16="http://schemas.microsoft.com/office/drawing/2014/main" id="{468A4A70-92DA-48EF-B7D5-46FE46861F31}"/>
               </a:ext>
             </a:extLst>
           </p:cNvPr>
@@ -15481,7 +15458,7 @@
           <p:cNvPr id="37" name="">
             <a:extLst xmlns:a="http://schemas.openxmlformats.org/drawingml/2006/main">
               <a:ext uri="{FF2B5EF4-FFF2-40B4-BE49-F238E27FC236}">
-                <a16:creationId xmlns:a16="http://schemas.microsoft.com/office/drawing/2014/main" id="{5244D28C-71A3-4F84-92D9-B6C2478C0E31}"/>
+                <a16:creationId xmlns:a16="http://schemas.microsoft.com/office/drawing/2014/main" id="{A7BD3A6E-FE8E-475E-A634-A8BACD05ADF4}"/>
               </a:ext>
             </a:extLst>
           </p:cNvPr>
@@ -15545,7 +15522,7 @@
           <p:cNvPr id="38" name="">
             <a:extLst xmlns:a="http://schemas.openxmlformats.org/drawingml/2006/main">
               <a:ext uri="{FF2B5EF4-FFF2-40B4-BE49-F238E27FC236}">
-                <a16:creationId xmlns:a16="http://schemas.microsoft.com/office/drawing/2014/main" id="{3FBAF278-684E-4F77-B087-2A6BF59A6528}"/>
+                <a16:creationId xmlns:a16="http://schemas.microsoft.com/office/drawing/2014/main" id="{F6C80C07-05EB-4570-8AC2-7154E8C388A6}"/>
               </a:ext>
             </a:extLst>
           </p:cNvPr>
@@ -15599,7 +15576,7 @@
                 <a:ea typeface="Microsoft YaHei"/>
                 <a:cs typeface="Microsoft YaHei"/>
               </a:rPr>
-              <a:t>结果归档</a:t>
+              <a:t>人工复核</a:t>
             </a:r>
           </a:p>
         </p:txBody>
@@ -15609,7 +15586,7 @@
           <p:cNvPr id="39" name="">
             <a:extLst xmlns:a="http://schemas.openxmlformats.org/drawingml/2006/main">
               <a:ext uri="{FF2B5EF4-FFF2-40B4-BE49-F238E27FC236}">
-                <a16:creationId xmlns:a16="http://schemas.microsoft.com/office/drawing/2014/main" id="{77A7322C-B903-4730-9C71-A429650097C8}"/>
+                <a16:creationId xmlns:a16="http://schemas.microsoft.com/office/drawing/2014/main" id="{978E3289-C0CB-468A-835A-93EA21550D66}"/>
               </a:ext>
             </a:extLst>
           </p:cNvPr>
@@ -15663,7 +15640,7 @@
                 <a:ea typeface="Microsoft YaHei"/>
                 <a:cs typeface="Microsoft YaHei"/>
               </a:rPr>
-              <a:t>Excel/日志</a:t>
+              <a:t>高风险兜底</a:t>
             </a:r>
           </a:p>
         </p:txBody>
@@ -15673,7 +15650,7 @@
           <p:cNvPr id="40" name="">
             <a:extLst xmlns:a="http://schemas.openxmlformats.org/drawingml/2006/main">
               <a:ext uri="{FF2B5EF4-FFF2-40B4-BE49-F238E27FC236}">
-                <a16:creationId xmlns:a16="http://schemas.microsoft.com/office/drawing/2014/main" id="{A5402DD8-8A9F-41EC-8596-1941D253D252}"/>
+                <a16:creationId xmlns:a16="http://schemas.microsoft.com/office/drawing/2014/main" id="{904C25BC-A6F5-4EDA-8DB0-C463A131D4BE}"/>
               </a:ext>
             </a:extLst>
           </p:cNvPr>
@@ -15706,7 +15683,7 @@
           <p:cNvPr id="41" name="">
             <a:extLst xmlns:a="http://schemas.openxmlformats.org/drawingml/2006/main">
               <a:ext uri="{FF2B5EF4-FFF2-40B4-BE49-F238E27FC236}">
-                <a16:creationId xmlns:a16="http://schemas.microsoft.com/office/drawing/2014/main" id="{890E6C70-D34C-49E2-805C-B50EE96579B7}"/>
+                <a16:creationId xmlns:a16="http://schemas.microsoft.com/office/drawing/2014/main" id="{D3ECC7D7-9580-4E0F-A545-5F3B5079BF4F}"/>
               </a:ext>
             </a:extLst>
           </p:cNvPr>
@@ -15741,7 +15718,7 @@
           <p:cNvPr id="42" name="">
             <a:extLst xmlns:a="http://schemas.openxmlformats.org/drawingml/2006/main">
               <a:ext uri="{FF2B5EF4-FFF2-40B4-BE49-F238E27FC236}">
-                <a16:creationId xmlns:a16="http://schemas.microsoft.com/office/drawing/2014/main" id="{F03FF724-2975-43AA-A569-E1719483ABC8}"/>
+                <a16:creationId xmlns:a16="http://schemas.microsoft.com/office/drawing/2014/main" id="{97FFC198-DEB9-4A61-913C-F6215C7E3168}"/>
               </a:ext>
             </a:extLst>
           </p:cNvPr>
@@ -15805,7 +15782,7 @@
           <p:cNvPr id="43" name="">
             <a:extLst xmlns:a="http://schemas.openxmlformats.org/drawingml/2006/main">
               <a:ext uri="{FF2B5EF4-FFF2-40B4-BE49-F238E27FC236}">
-                <a16:creationId xmlns:a16="http://schemas.microsoft.com/office/drawing/2014/main" id="{295E38F4-E30F-4CC9-B196-1B3DDB8729D4}"/>
+                <a16:creationId xmlns:a16="http://schemas.microsoft.com/office/drawing/2014/main" id="{02CF0B51-4CDE-44DA-A1E3-BC27C90E8F7A}"/>
               </a:ext>
             </a:extLst>
           </p:cNvPr>
@@ -15859,7 +15836,7 @@
                 <a:ea typeface="Microsoft YaHei"/>
                 <a:cs typeface="Microsoft YaHei"/>
               </a:rPr>
-              <a:t>Agent 只应该在某些节点里做智能任务，比如识别异常、检索制度、解释证据，而不是自己控制整个财务流程。</a:t>
+              <a:t>Agent 只在风险解释、补充发现、合规分析等节点做智能任务；交易清洗和规则扫描仍由确定性代码承担。</a:t>
             </a:r>
           </a:p>
         </p:txBody>
@@ -15869,7 +15846,7 @@
           <p:cNvPr id="44" name="">
             <a:extLst xmlns:a="http://schemas.openxmlformats.org/drawingml/2006/main">
               <a:ext uri="{FF2B5EF4-FFF2-40B4-BE49-F238E27FC236}">
-                <a16:creationId xmlns:a16="http://schemas.microsoft.com/office/drawing/2014/main" id="{B6B020A1-B19D-4216-AFDD-F0E4EDCE3BB7}"/>
+                <a16:creationId xmlns:a16="http://schemas.microsoft.com/office/drawing/2014/main" id="{379BB656-B163-47DD-A372-6CDCD52A1901}"/>
               </a:ext>
             </a:extLst>
           </p:cNvPr>
@@ -15902,7 +15879,7 @@
           <p:cNvPr id="45" name="">
             <a:extLst xmlns:a="http://schemas.openxmlformats.org/drawingml/2006/main">
               <a:ext uri="{FF2B5EF4-FFF2-40B4-BE49-F238E27FC236}">
-                <a16:creationId xmlns:a16="http://schemas.microsoft.com/office/drawing/2014/main" id="{BA6E5B37-478E-4410-B9AC-5DE3B30E6A92}"/>
+                <a16:creationId xmlns:a16="http://schemas.microsoft.com/office/drawing/2014/main" id="{2D6E1B24-EDEE-41FE-9DDA-DAAE34C79388}"/>
               </a:ext>
             </a:extLst>
           </p:cNvPr>
@@ -15966,7 +15943,7 @@
           <p:cNvPr id="46" name="">
             <a:extLst xmlns:a="http://schemas.openxmlformats.org/drawingml/2006/main">
               <a:ext uri="{FF2B5EF4-FFF2-40B4-BE49-F238E27FC236}">
-                <a16:creationId xmlns:a16="http://schemas.microsoft.com/office/drawing/2014/main" id="{97FE4429-4EFE-4877-A6DB-90759A0B796B}"/>
+                <a16:creationId xmlns:a16="http://schemas.microsoft.com/office/drawing/2014/main" id="{425E23B1-63D7-428E-AEAB-292D401A0BC5}"/>
               </a:ext>
             </a:extLst>
           </p:cNvPr>
@@ -16030,7 +16007,7 @@
           <p:cNvPr id="47" name="">
             <a:extLst xmlns:a="http://schemas.openxmlformats.org/drawingml/2006/main">
               <a:ext uri="{FF2B5EF4-FFF2-40B4-BE49-F238E27FC236}">
-                <a16:creationId xmlns:a16="http://schemas.microsoft.com/office/drawing/2014/main" id="{4343B97B-B2C3-42F0-947C-5C01FCDDDBF6}"/>
+                <a16:creationId xmlns:a16="http://schemas.microsoft.com/office/drawing/2014/main" id="{AA30AC33-FD52-407C-A91C-6AEB02864E9B}"/>
               </a:ext>
             </a:extLst>
           </p:cNvPr>
@@ -16092,7 +16069,7 @@
     </p:spTree>
     <p:extLst>
       <p:ext uri="{BB962C8B-B14F-4D97-AF65-F5344CB8AC3E}">
-        <p14:creationId xmlns:p14="http://schemas.microsoft.com/office/powerpoint/2010/main" val="1102962460"/>
+        <p14:creationId xmlns:p14="http://schemas.microsoft.com/office/powerpoint/2010/main" val="530938034"/>
       </p:ext>
     </p:extLst>
   </p:cSld>
@@ -16116,7 +16093,7 @@
           <p:cNvPr id="1" name="">
             <a:extLst xmlns:a="http://schemas.openxmlformats.org/drawingml/2006/main">
               <a:ext uri="{FF2B5EF4-FFF2-40B4-BE49-F238E27FC236}">
-                <a16:creationId xmlns:a16="http://schemas.microsoft.com/office/drawing/2014/main" id="{4BA2586E-65D5-4DB2-B369-2E345E2C1DF9}"/>
+                <a16:creationId xmlns:a16="http://schemas.microsoft.com/office/drawing/2014/main" id="{60DAA210-56ED-4210-9C48-C8FF653F7463}"/>
               </a:ext>
             </a:extLst>
           </p:cNvPr>
@@ -16151,7 +16128,7 @@
           <p:cNvPr id="2" name="">
             <a:extLst xmlns:a="http://schemas.openxmlformats.org/drawingml/2006/main">
               <a:ext uri="{FF2B5EF4-FFF2-40B4-BE49-F238E27FC236}">
-                <a16:creationId xmlns:a16="http://schemas.microsoft.com/office/drawing/2014/main" id="{5D2BDCB4-C97F-4E89-91AC-4B7CF668D41F}"/>
+                <a16:creationId xmlns:a16="http://schemas.microsoft.com/office/drawing/2014/main" id="{FBB30FAC-1436-4525-86C7-FA9F886A4902}"/>
               </a:ext>
             </a:extLst>
           </p:cNvPr>
@@ -16215,7 +16192,7 @@
           <p:cNvPr id="3" name="">
             <a:extLst xmlns:a="http://schemas.openxmlformats.org/drawingml/2006/main">
               <a:ext uri="{FF2B5EF4-FFF2-40B4-BE49-F238E27FC236}">
-                <a16:creationId xmlns:a16="http://schemas.microsoft.com/office/drawing/2014/main" id="{C4D73BDC-C641-4F6B-BB3F-39772BAC588C}"/>
+                <a16:creationId xmlns:a16="http://schemas.microsoft.com/office/drawing/2014/main" id="{DB82F356-559A-49EF-AB40-6221D2B39489}"/>
               </a:ext>
             </a:extLst>
           </p:cNvPr>
@@ -16279,7 +16256,7 @@
           <p:cNvPr id="4" name="">
             <a:extLst xmlns:a="http://schemas.openxmlformats.org/drawingml/2006/main">
               <a:ext uri="{FF2B5EF4-FFF2-40B4-BE49-F238E27FC236}">
-                <a16:creationId xmlns:a16="http://schemas.microsoft.com/office/drawing/2014/main" id="{4310E2D4-EF01-4CF7-906B-EEC4D4191BC5}"/>
+                <a16:creationId xmlns:a16="http://schemas.microsoft.com/office/drawing/2014/main" id="{9E5CA247-415C-4196-8EB8-CCBE7BD94339}"/>
               </a:ext>
             </a:extLst>
           </p:cNvPr>
@@ -16343,7 +16320,7 @@
           <p:cNvPr id="5" name="">
             <a:extLst xmlns:a="http://schemas.openxmlformats.org/drawingml/2006/main">
               <a:ext uri="{FF2B5EF4-FFF2-40B4-BE49-F238E27FC236}">
-                <a16:creationId xmlns:a16="http://schemas.microsoft.com/office/drawing/2014/main" id="{52AF7085-37E7-40C9-8624-DCD58D9083AC}"/>
+                <a16:creationId xmlns:a16="http://schemas.microsoft.com/office/drawing/2014/main" id="{A72B4B19-A645-4D20-AF67-906E754B7542}"/>
               </a:ext>
             </a:extLst>
           </p:cNvPr>
@@ -16378,7 +16355,7 @@
           <p:cNvPr id="6" name="">
             <a:extLst xmlns:a="http://schemas.openxmlformats.org/drawingml/2006/main">
               <a:ext uri="{FF2B5EF4-FFF2-40B4-BE49-F238E27FC236}">
-                <a16:creationId xmlns:a16="http://schemas.microsoft.com/office/drawing/2014/main" id="{B8AB6245-CACD-431B-919C-74AE2B56F9A7}"/>
+                <a16:creationId xmlns:a16="http://schemas.microsoft.com/office/drawing/2014/main" id="{665604A4-C9A5-4134-B3DC-5C0E2F856039}"/>
               </a:ext>
             </a:extLst>
           </p:cNvPr>
@@ -16411,7 +16388,7 @@
           <p:cNvPr id="7" name="">
             <a:extLst xmlns:a="http://schemas.openxmlformats.org/drawingml/2006/main">
               <a:ext uri="{FF2B5EF4-FFF2-40B4-BE49-F238E27FC236}">
-                <a16:creationId xmlns:a16="http://schemas.microsoft.com/office/drawing/2014/main" id="{9F8F978B-8728-4FAA-8B42-C892C54A1055}"/>
+                <a16:creationId xmlns:a16="http://schemas.microsoft.com/office/drawing/2014/main" id="{10D322AB-11DE-4622-AC7A-D10862EDE1C3}"/>
               </a:ext>
             </a:extLst>
           </p:cNvPr>
@@ -16446,7 +16423,7 @@
           <p:cNvPr id="8" name="">
             <a:extLst xmlns:a="http://schemas.openxmlformats.org/drawingml/2006/main">
               <a:ext uri="{FF2B5EF4-FFF2-40B4-BE49-F238E27FC236}">
-                <a16:creationId xmlns:a16="http://schemas.microsoft.com/office/drawing/2014/main" id="{00288868-309E-4BA8-854E-CFA0DFA0060C}"/>
+                <a16:creationId xmlns:a16="http://schemas.microsoft.com/office/drawing/2014/main" id="{4592C7E1-23AD-468F-BDAB-3215282B08B0}"/>
               </a:ext>
             </a:extLst>
           </p:cNvPr>
@@ -16510,7 +16487,7 @@
           <p:cNvPr id="9" name="">
             <a:extLst xmlns:a="http://schemas.openxmlformats.org/drawingml/2006/main">
               <a:ext uri="{FF2B5EF4-FFF2-40B4-BE49-F238E27FC236}">
-                <a16:creationId xmlns:a16="http://schemas.microsoft.com/office/drawing/2014/main" id="{A2FCD082-6817-4A33-966D-C38AE2D5CA3B}"/>
+                <a16:creationId xmlns:a16="http://schemas.microsoft.com/office/drawing/2014/main" id="{3EFB28EF-3E13-495B-833B-86B4C62E81E3}"/>
               </a:ext>
             </a:extLst>
           </p:cNvPr>
@@ -16564,7 +16541,7 @@
                 <a:ea typeface="Microsoft YaHei"/>
                 <a:cs typeface="Microsoft YaHei"/>
               </a:rPr>
-              <a:t>财务和审计不是写作场景。模型一旦把缺失证据说成确定事实，后果会直接进入工作底稿和复核链条。</a:t>
+              <a:t>财务和审计不是写作场景。模型一旦把缺失证据说成确定事实，会直接影响风险判断和后续审计程序。</a:t>
             </a:r>
           </a:p>
         </p:txBody>
@@ -16574,7 +16551,7 @@
           <p:cNvPr id="10" name="">
             <a:extLst xmlns:a="http://schemas.openxmlformats.org/drawingml/2006/main">
               <a:ext uri="{FF2B5EF4-FFF2-40B4-BE49-F238E27FC236}">
-                <a16:creationId xmlns:a16="http://schemas.microsoft.com/office/drawing/2014/main" id="{563D17CE-A385-42B8-8B2B-F75EA67046C6}"/>
+                <a16:creationId xmlns:a16="http://schemas.microsoft.com/office/drawing/2014/main" id="{F2831353-CF38-499B-83FB-EA680755DAF1}"/>
               </a:ext>
             </a:extLst>
           </p:cNvPr>
@@ -16607,7 +16584,7 @@
           <p:cNvPr id="11" name="">
             <a:extLst xmlns:a="http://schemas.openxmlformats.org/drawingml/2006/main">
               <a:ext uri="{FF2B5EF4-FFF2-40B4-BE49-F238E27FC236}">
-                <a16:creationId xmlns:a16="http://schemas.microsoft.com/office/drawing/2014/main" id="{6FD6B563-2897-43C6-985C-32D185D1F43D}"/>
+                <a16:creationId xmlns:a16="http://schemas.microsoft.com/office/drawing/2014/main" id="{5CF74C73-ED3A-4BC3-ADBE-D3BDE96A1D47}"/>
               </a:ext>
             </a:extLst>
           </p:cNvPr>
@@ -16642,7 +16619,7 @@
           <p:cNvPr id="12" name="">
             <a:extLst xmlns:a="http://schemas.openxmlformats.org/drawingml/2006/main">
               <a:ext uri="{FF2B5EF4-FFF2-40B4-BE49-F238E27FC236}">
-                <a16:creationId xmlns:a16="http://schemas.microsoft.com/office/drawing/2014/main" id="{C3932945-DB82-45CA-8D1F-DC13EB74D289}"/>
+                <a16:creationId xmlns:a16="http://schemas.microsoft.com/office/drawing/2014/main" id="{A7B876E9-6C9F-4EED-A74D-B48A0EB88E44}"/>
               </a:ext>
             </a:extLst>
           </p:cNvPr>
@@ -16706,7 +16683,7 @@
           <p:cNvPr id="13" name="">
             <a:extLst xmlns:a="http://schemas.openxmlformats.org/drawingml/2006/main">
               <a:ext uri="{FF2B5EF4-FFF2-40B4-BE49-F238E27FC236}">
-                <a16:creationId xmlns:a16="http://schemas.microsoft.com/office/drawing/2014/main" id="{A94F6B83-ABF5-4DAA-93FD-59744A2172C6}"/>
+                <a16:creationId xmlns:a16="http://schemas.microsoft.com/office/drawing/2014/main" id="{5D6B00C7-3223-454F-85FF-A50B6F1338BA}"/>
               </a:ext>
             </a:extLst>
           </p:cNvPr>
@@ -16770,7 +16747,7 @@
           <p:cNvPr id="14" name="">
             <a:extLst xmlns:a="http://schemas.openxmlformats.org/drawingml/2006/main">
               <a:ext uri="{FF2B5EF4-FFF2-40B4-BE49-F238E27FC236}">
-                <a16:creationId xmlns:a16="http://schemas.microsoft.com/office/drawing/2014/main" id="{1662682E-6589-477D-9760-1FAB38540394}"/>
+                <a16:creationId xmlns:a16="http://schemas.microsoft.com/office/drawing/2014/main" id="{D2E7D759-F389-433C-8786-C4145C19E028}"/>
               </a:ext>
             </a:extLst>
           </p:cNvPr>
@@ -16803,7 +16780,7 @@
           <p:cNvPr id="15" name="">
             <a:extLst xmlns:a="http://schemas.openxmlformats.org/drawingml/2006/main">
               <a:ext uri="{FF2B5EF4-FFF2-40B4-BE49-F238E27FC236}">
-                <a16:creationId xmlns:a16="http://schemas.microsoft.com/office/drawing/2014/main" id="{7068F6AC-6B7C-4E96-9B65-E454C076CBC1}"/>
+                <a16:creationId xmlns:a16="http://schemas.microsoft.com/office/drawing/2014/main" id="{F201F268-CA87-42BE-BC7E-660FB2DD4934}"/>
               </a:ext>
             </a:extLst>
           </p:cNvPr>
@@ -16838,7 +16815,7 @@
           <p:cNvPr id="16" name="">
             <a:extLst xmlns:a="http://schemas.openxmlformats.org/drawingml/2006/main">
               <a:ext uri="{FF2B5EF4-FFF2-40B4-BE49-F238E27FC236}">
-                <a16:creationId xmlns:a16="http://schemas.microsoft.com/office/drawing/2014/main" id="{7AAD7EF5-5D72-4CF1-B968-CC52547B8ADE}"/>
+                <a16:creationId xmlns:a16="http://schemas.microsoft.com/office/drawing/2014/main" id="{112B4979-4476-4AFD-851A-6DCBE743DF85}"/>
               </a:ext>
             </a:extLst>
           </p:cNvPr>
@@ -16902,7 +16879,7 @@
           <p:cNvPr id="17" name="">
             <a:extLst xmlns:a="http://schemas.openxmlformats.org/drawingml/2006/main">
               <a:ext uri="{FF2B5EF4-FFF2-40B4-BE49-F238E27FC236}">
-                <a16:creationId xmlns:a16="http://schemas.microsoft.com/office/drawing/2014/main" id="{7171D302-039E-4928-8320-743D3EAD8F5A}"/>
+                <a16:creationId xmlns:a16="http://schemas.microsoft.com/office/drawing/2014/main" id="{C898EAC1-7CA4-425A-A97E-EB016CA1D2DE}"/>
               </a:ext>
             </a:extLst>
           </p:cNvPr>
@@ -16956,7 +16933,7 @@
                 <a:ea typeface="Microsoft YaHei"/>
                 <a:cs typeface="Microsoft YaHei"/>
               </a:rPr>
-              <a:t>像实习生底稿一样，最后需要正式人员复核把关。Agent 只能辅助，不能替代责任主体。</a:t>
+              <a:t>Agent 可以提示高风险交易、生成分析叙述，但最终审计判断必须由审计人员复核把关。</a:t>
             </a:r>
           </a:p>
         </p:txBody>
@@ -16966,7 +16943,7 @@
           <p:cNvPr id="18" name="">
             <a:extLst xmlns:a="http://schemas.openxmlformats.org/drawingml/2006/main">
               <a:ext uri="{FF2B5EF4-FFF2-40B4-BE49-F238E27FC236}">
-                <a16:creationId xmlns:a16="http://schemas.microsoft.com/office/drawing/2014/main" id="{A3C4208A-8FFE-47B7-8C78-4F3CA734C4F8}"/>
+                <a16:creationId xmlns:a16="http://schemas.microsoft.com/office/drawing/2014/main" id="{0A530314-9270-494F-A0C2-CC6C959C7387}"/>
               </a:ext>
             </a:extLst>
           </p:cNvPr>
@@ -16999,7 +16976,7 @@
           <p:cNvPr id="19" name="">
             <a:extLst xmlns:a="http://schemas.openxmlformats.org/drawingml/2006/main">
               <a:ext uri="{FF2B5EF4-FFF2-40B4-BE49-F238E27FC236}">
-                <a16:creationId xmlns:a16="http://schemas.microsoft.com/office/drawing/2014/main" id="{FA2A562F-3CCA-4C49-8762-14D35904D369}"/>
+                <a16:creationId xmlns:a16="http://schemas.microsoft.com/office/drawing/2014/main" id="{32562637-58AE-4C3B-8DB2-18CC06EB104D}"/>
               </a:ext>
             </a:extLst>
           </p:cNvPr>
@@ -17063,7 +17040,7 @@
           <p:cNvPr id="20" name="">
             <a:extLst xmlns:a="http://schemas.openxmlformats.org/drawingml/2006/main">
               <a:ext uri="{FF2B5EF4-FFF2-40B4-BE49-F238E27FC236}">
-                <a16:creationId xmlns:a16="http://schemas.microsoft.com/office/drawing/2014/main" id="{1CC37DB3-2089-4BA7-9077-A8DF40A2A70F}"/>
+                <a16:creationId xmlns:a16="http://schemas.microsoft.com/office/drawing/2014/main" id="{70AB01D0-C9EC-4374-AEFD-72C037CC7289}"/>
               </a:ext>
             </a:extLst>
           </p:cNvPr>
@@ -17127,7 +17104,7 @@
           <p:cNvPr id="21" name="">
             <a:extLst xmlns:a="http://schemas.openxmlformats.org/drawingml/2006/main">
               <a:ext uri="{FF2B5EF4-FFF2-40B4-BE49-F238E27FC236}">
-                <a16:creationId xmlns:a16="http://schemas.microsoft.com/office/drawing/2014/main" id="{E53AE3B1-D61F-4A06-B451-97B6FEA74FBB}"/>
+                <a16:creationId xmlns:a16="http://schemas.microsoft.com/office/drawing/2014/main" id="{4FA60586-9590-4482-AB20-C5BA0CDA4649}"/>
               </a:ext>
             </a:extLst>
           </p:cNvPr>
@@ -17189,7 +17166,7 @@
     </p:spTree>
     <p:extLst>
       <p:ext uri="{BB962C8B-B14F-4D97-AF65-F5344CB8AC3E}">
-        <p14:creationId xmlns:p14="http://schemas.microsoft.com/office/powerpoint/2010/main" val="164649495"/>
+        <p14:creationId xmlns:p14="http://schemas.microsoft.com/office/powerpoint/2010/main" val="1462327788"/>
       </p:ext>
     </p:extLst>
   </p:cSld>
@@ -17213,7 +17190,7 @@
           <p:cNvPr id="1" name="">
             <a:extLst xmlns:a="http://schemas.openxmlformats.org/drawingml/2006/main">
               <a:ext uri="{FF2B5EF4-FFF2-40B4-BE49-F238E27FC236}">
-                <a16:creationId xmlns:a16="http://schemas.microsoft.com/office/drawing/2014/main" id="{F7445216-FE1A-498D-A3FD-4B69336119EE}"/>
+                <a16:creationId xmlns:a16="http://schemas.microsoft.com/office/drawing/2014/main" id="{EBE3D065-F371-409E-A43D-0ABDBBD8FD32}"/>
               </a:ext>
             </a:extLst>
           </p:cNvPr>
@@ -17248,7 +17225,7 @@
           <p:cNvPr id="2" name="">
             <a:extLst xmlns:a="http://schemas.openxmlformats.org/drawingml/2006/main">
               <a:ext uri="{FF2B5EF4-FFF2-40B4-BE49-F238E27FC236}">
-                <a16:creationId xmlns:a16="http://schemas.microsoft.com/office/drawing/2014/main" id="{C8F327E5-5C0C-4737-B414-D40FBFED1D3D}"/>
+                <a16:creationId xmlns:a16="http://schemas.microsoft.com/office/drawing/2014/main" id="{C2EA3E3A-D610-47FC-9AE3-6673BBF3BD52}"/>
               </a:ext>
             </a:extLst>
           </p:cNvPr>
@@ -17312,7 +17289,7 @@
           <p:cNvPr id="3" name="">
             <a:extLst xmlns:a="http://schemas.openxmlformats.org/drawingml/2006/main">
               <a:ext uri="{FF2B5EF4-FFF2-40B4-BE49-F238E27FC236}">
-                <a16:creationId xmlns:a16="http://schemas.microsoft.com/office/drawing/2014/main" id="{6EF61CC1-734A-4D19-BE82-2E955E6F2042}"/>
+                <a16:creationId xmlns:a16="http://schemas.microsoft.com/office/drawing/2014/main" id="{7AB68FA7-ED43-4D79-9768-7C219838562E}"/>
               </a:ext>
             </a:extLst>
           </p:cNvPr>
@@ -17366,7 +17343,7 @@
                 <a:ea typeface="Microsoft YaHei"/>
                 <a:cs typeface="Microsoft YaHei"/>
               </a:rPr>
-              <a:t>不能全自动，不代表没有商业价值：替代实习生 dirtywork 可能更早发生。</a:t>
+              <a:t>不能全自动，不代表没有价值：资金流异常扫描本身就值得做。</a:t>
             </a:r>
           </a:p>
         </p:txBody>
@@ -17376,7 +17353,7 @@
           <p:cNvPr id="4" name="">
             <a:extLst xmlns:a="http://schemas.openxmlformats.org/drawingml/2006/main">
               <a:ext uri="{FF2B5EF4-FFF2-40B4-BE49-F238E27FC236}">
-                <a16:creationId xmlns:a16="http://schemas.microsoft.com/office/drawing/2014/main" id="{E1CBCCBB-3A9D-4B51-8F9E-7184C19A9D39}"/>
+                <a16:creationId xmlns:a16="http://schemas.microsoft.com/office/drawing/2014/main" id="{743A3324-8268-4EBC-99CD-93D579AF4F6D}"/>
               </a:ext>
             </a:extLst>
           </p:cNvPr>
@@ -17440,7 +17417,7 @@
           <p:cNvPr id="5" name="">
             <a:extLst xmlns:a="http://schemas.openxmlformats.org/drawingml/2006/main">
               <a:ext uri="{FF2B5EF4-FFF2-40B4-BE49-F238E27FC236}">
-                <a16:creationId xmlns:a16="http://schemas.microsoft.com/office/drawing/2014/main" id="{E4A4DD36-BD9A-4EEB-B58E-93785D494CE8}"/>
+                <a16:creationId xmlns:a16="http://schemas.microsoft.com/office/drawing/2014/main" id="{3B66C8A9-9080-4884-9A06-6C939F9A977E}"/>
               </a:ext>
             </a:extLst>
           </p:cNvPr>
@@ -17475,7 +17452,7 @@
           <p:cNvPr id="6" name="">
             <a:extLst xmlns:a="http://schemas.openxmlformats.org/drawingml/2006/main">
               <a:ext uri="{FF2B5EF4-FFF2-40B4-BE49-F238E27FC236}">
-                <a16:creationId xmlns:a16="http://schemas.microsoft.com/office/drawing/2014/main" id="{30E0346B-EBC2-4D43-89D4-10E3A3DC8B67}"/>
+                <a16:creationId xmlns:a16="http://schemas.microsoft.com/office/drawing/2014/main" id="{559131C4-528A-4D00-AF6A-C6F112B98A9D}"/>
               </a:ext>
             </a:extLst>
           </p:cNvPr>
@@ -17508,7 +17485,7 @@
           <p:cNvPr id="7" name="">
             <a:extLst xmlns:a="http://schemas.openxmlformats.org/drawingml/2006/main">
               <a:ext uri="{FF2B5EF4-FFF2-40B4-BE49-F238E27FC236}">
-                <a16:creationId xmlns:a16="http://schemas.microsoft.com/office/drawing/2014/main" id="{7839900E-FB3E-4FE0-A04A-A10371617C7A}"/>
+                <a16:creationId xmlns:a16="http://schemas.microsoft.com/office/drawing/2014/main" id="{FFEF7E19-AE9D-4896-BFD5-BBA4521B1B2F}"/>
               </a:ext>
             </a:extLst>
           </p:cNvPr>
@@ -17562,7 +17539,7 @@
                 <a:ea typeface="Microsoft YaHei"/>
                 <a:cs typeface="Microsoft YaHei"/>
               </a:rPr>
-              <a:t>人做的时间 -（AI 做的时间 + 人核对并修改的时间）&gt; 0</a:t>
+              <a:t>人做的时间 -（AI 跑流水线 + 人复核高风险项的时间）&gt; 0</a:t>
             </a:r>
           </a:p>
         </p:txBody>
@@ -17572,7 +17549,7 @@
           <p:cNvPr id="8" name="">
             <a:extLst xmlns:a="http://schemas.openxmlformats.org/drawingml/2006/main">
               <a:ext uri="{FF2B5EF4-FFF2-40B4-BE49-F238E27FC236}">
-                <a16:creationId xmlns:a16="http://schemas.microsoft.com/office/drawing/2014/main" id="{3F0F75D6-404A-473E-B726-B18193E5C19C}"/>
+                <a16:creationId xmlns:a16="http://schemas.microsoft.com/office/drawing/2014/main" id="{0664083B-FC1F-4C16-A44D-A03086FD952C}"/>
               </a:ext>
             </a:extLst>
           </p:cNvPr>
@@ -17605,7 +17582,7 @@
           <p:cNvPr id="9" name="">
             <a:extLst xmlns:a="http://schemas.openxmlformats.org/drawingml/2006/main">
               <a:ext uri="{FF2B5EF4-FFF2-40B4-BE49-F238E27FC236}">
-                <a16:creationId xmlns:a16="http://schemas.microsoft.com/office/drawing/2014/main" id="{23CE6158-911B-4A64-B57A-9F90389C1782}"/>
+                <a16:creationId xmlns:a16="http://schemas.microsoft.com/office/drawing/2014/main" id="{46D3F650-B05B-403E-B7A8-CB611A67D879}"/>
               </a:ext>
             </a:extLst>
           </p:cNvPr>
@@ -17640,7 +17617,7 @@
           <p:cNvPr id="10" name="">
             <a:extLst xmlns:a="http://schemas.openxmlformats.org/drawingml/2006/main">
               <a:ext uri="{FF2B5EF4-FFF2-40B4-BE49-F238E27FC236}">
-                <a16:creationId xmlns:a16="http://schemas.microsoft.com/office/drawing/2014/main" id="{4678896E-E35A-4D2C-BE3F-7B6C1AAC7115}"/>
+                <a16:creationId xmlns:a16="http://schemas.microsoft.com/office/drawing/2014/main" id="{557E60B6-76BF-447C-AEB6-2436DEF6E51E}"/>
               </a:ext>
             </a:extLst>
           </p:cNvPr>
@@ -17704,7 +17681,7 @@
           <p:cNvPr id="11" name="">
             <a:extLst xmlns:a="http://schemas.openxmlformats.org/drawingml/2006/main">
               <a:ext uri="{FF2B5EF4-FFF2-40B4-BE49-F238E27FC236}">
-                <a16:creationId xmlns:a16="http://schemas.microsoft.com/office/drawing/2014/main" id="{41F4376A-6FA6-4EB3-B7D6-21581ACEECAD}"/>
+                <a16:creationId xmlns:a16="http://schemas.microsoft.com/office/drawing/2014/main" id="{3AD422D8-E1F9-4F8F-B0AA-61F59A90138F}"/>
               </a:ext>
             </a:extLst>
           </p:cNvPr>
@@ -17758,7 +17735,7 @@
                 <a:ea typeface="Microsoft YaHei"/>
                 <a:cs typeface="Microsoft YaHei"/>
               </a:rPr>
-              <a:t>货币资金底稿、简单抽凭、复制粘贴、筛选和查找函数等高频模板化工作。</a:t>
+              <a:t>多平台流水归集、异常金额筛选、FX 转换检查、重复入账和广告投放超支扫描。</a:t>
             </a:r>
           </a:p>
         </p:txBody>
@@ -17768,7 +17745,7 @@
           <p:cNvPr id="12" name="">
             <a:extLst xmlns:a="http://schemas.openxmlformats.org/drawingml/2006/main">
               <a:ext uri="{FF2B5EF4-FFF2-40B4-BE49-F238E27FC236}">
-                <a16:creationId xmlns:a16="http://schemas.microsoft.com/office/drawing/2014/main" id="{FF587871-8275-4760-A3A1-6F8F015F925B}"/>
+                <a16:creationId xmlns:a16="http://schemas.microsoft.com/office/drawing/2014/main" id="{7BEC4632-BEC5-4653-B9CF-07AF0CC4870B}"/>
               </a:ext>
             </a:extLst>
           </p:cNvPr>
@@ -17801,7 +17778,7 @@
           <p:cNvPr id="13" name="">
             <a:extLst xmlns:a="http://schemas.openxmlformats.org/drawingml/2006/main">
               <a:ext uri="{FF2B5EF4-FFF2-40B4-BE49-F238E27FC236}">
-                <a16:creationId xmlns:a16="http://schemas.microsoft.com/office/drawing/2014/main" id="{2480B65C-27F6-4C9F-B9CD-28DDE1FEC269}"/>
+                <a16:creationId xmlns:a16="http://schemas.microsoft.com/office/drawing/2014/main" id="{AD848B6F-6626-4B43-BE54-EB1CC4ED68D5}"/>
               </a:ext>
             </a:extLst>
           </p:cNvPr>
@@ -17836,7 +17813,7 @@
           <p:cNvPr id="14" name="">
             <a:extLst xmlns:a="http://schemas.openxmlformats.org/drawingml/2006/main">
               <a:ext uri="{FF2B5EF4-FFF2-40B4-BE49-F238E27FC236}">
-                <a16:creationId xmlns:a16="http://schemas.microsoft.com/office/drawing/2014/main" id="{1EBF1F25-7434-4169-B17E-BCA18C0E8713}"/>
+                <a16:creationId xmlns:a16="http://schemas.microsoft.com/office/drawing/2014/main" id="{54CA6CE7-B42B-4EA4-9BBF-14B8699FA90D}"/>
               </a:ext>
             </a:extLst>
           </p:cNvPr>
@@ -17900,7 +17877,7 @@
           <p:cNvPr id="15" name="">
             <a:extLst xmlns:a="http://schemas.openxmlformats.org/drawingml/2006/main">
               <a:ext uri="{FF2B5EF4-FFF2-40B4-BE49-F238E27FC236}">
-                <a16:creationId xmlns:a16="http://schemas.microsoft.com/office/drawing/2014/main" id="{D3FDB58E-F69C-4265-A9FF-26B16B7589F7}"/>
+                <a16:creationId xmlns:a16="http://schemas.microsoft.com/office/drawing/2014/main" id="{C3833198-D188-4156-BC34-E6D5E270935A}"/>
               </a:ext>
             </a:extLst>
           </p:cNvPr>
@@ -17954,7 +17931,7 @@
                 <a:ea typeface="Microsoft YaHei"/>
                 <a:cs typeface="Microsoft YaHei"/>
               </a:rPr>
-              <a:t>用模板、字段 schema、规则扫描、cell_map 和 mock/私有部署，把模型限制在可检查的动作里。</a:t>
+              <a:t>用合成数据、字段 schema、规则扫描、RAG 依据和 mock/私有部署，把模型限制在可检查动作里。</a:t>
             </a:r>
           </a:p>
         </p:txBody>
@@ -17964,7 +17941,7 @@
           <p:cNvPr id="16" name="">
             <a:extLst xmlns:a="http://schemas.openxmlformats.org/drawingml/2006/main">
               <a:ext uri="{FF2B5EF4-FFF2-40B4-BE49-F238E27FC236}">
-                <a16:creationId xmlns:a16="http://schemas.microsoft.com/office/drawing/2014/main" id="{481A5556-F554-4DC6-A415-F6DEDF461195}"/>
+                <a16:creationId xmlns:a16="http://schemas.microsoft.com/office/drawing/2014/main" id="{2EAE7F52-D77F-4FA4-985C-5BD183B7CA6D}"/>
               </a:ext>
             </a:extLst>
           </p:cNvPr>
@@ -17997,7 +17974,7 @@
           <p:cNvPr id="17" name="">
             <a:extLst xmlns:a="http://schemas.openxmlformats.org/drawingml/2006/main">
               <a:ext uri="{FF2B5EF4-FFF2-40B4-BE49-F238E27FC236}">
-                <a16:creationId xmlns:a16="http://schemas.microsoft.com/office/drawing/2014/main" id="{1DAAEB54-422C-4475-805C-78E49444FC97}"/>
+                <a16:creationId xmlns:a16="http://schemas.microsoft.com/office/drawing/2014/main" id="{9799D75D-BAE7-4588-B7E4-F49185FBC048}"/>
               </a:ext>
             </a:extLst>
           </p:cNvPr>
@@ -18032,7 +18009,7 @@
           <p:cNvPr id="18" name="">
             <a:extLst xmlns:a="http://schemas.openxmlformats.org/drawingml/2006/main">
               <a:ext uri="{FF2B5EF4-FFF2-40B4-BE49-F238E27FC236}">
-                <a16:creationId xmlns:a16="http://schemas.microsoft.com/office/drawing/2014/main" id="{BBAE1504-7E53-4C54-B623-9C39A7EFE0D2}"/>
+                <a16:creationId xmlns:a16="http://schemas.microsoft.com/office/drawing/2014/main" id="{093321D1-F2B1-4F19-962F-AC7A191FEF5D}"/>
               </a:ext>
             </a:extLst>
           </p:cNvPr>
@@ -18096,7 +18073,7 @@
           <p:cNvPr id="19" name="">
             <a:extLst xmlns:a="http://schemas.openxmlformats.org/drawingml/2006/main">
               <a:ext uri="{FF2B5EF4-FFF2-40B4-BE49-F238E27FC236}">
-                <a16:creationId xmlns:a16="http://schemas.microsoft.com/office/drawing/2014/main" id="{BAC04F01-C402-499F-99C2-2B88CE51120F}"/>
+                <a16:creationId xmlns:a16="http://schemas.microsoft.com/office/drawing/2014/main" id="{72385C8C-2202-476D-A8CD-905504F9033A}"/>
               </a:ext>
             </a:extLst>
           </p:cNvPr>
@@ -18150,7 +18127,7 @@
                 <a:ea typeface="Microsoft YaHei"/>
                 <a:cs typeface="Microsoft YaHei"/>
               </a:rPr>
-              <a:t>产出像实习生交底稿一样进入 Maker-Checker 流程；AI 负责提效，人负责最终判断。</a:t>
+              <a:t>系统产出风险清单和审计叙述，审计人员复核证据、确认重大性和后续程序。</a:t>
             </a:r>
           </a:p>
         </p:txBody>
@@ -18160,7 +18137,7 @@
           <p:cNvPr id="20" name="">
             <a:extLst xmlns:a="http://schemas.openxmlformats.org/drawingml/2006/main">
               <a:ext uri="{FF2B5EF4-FFF2-40B4-BE49-F238E27FC236}">
-                <a16:creationId xmlns:a16="http://schemas.microsoft.com/office/drawing/2014/main" id="{BB377C0C-A589-4446-9ECC-869068DCD31C}"/>
+                <a16:creationId xmlns:a16="http://schemas.microsoft.com/office/drawing/2014/main" id="{0E5E5595-54B0-45E8-8A4B-19C1DDD3D7A7}"/>
               </a:ext>
             </a:extLst>
           </p:cNvPr>
@@ -18214,7 +18191,7 @@
                 <a:ea typeface="Microsoft YaHei"/>
                 <a:cs typeface="Microsoft YaHei"/>
               </a:rPr>
-              <a:t>课堂里可以把这个观点讲得更尖锐：全流程自动化很难，但低风险重复劳动会先被重构。</a:t>
+              <a:t>课堂里可以把观点讲清楚：全自动审计很难，但资金流异常扫描和风险叙述可以先提升效率。</a:t>
             </a:r>
           </a:p>
         </p:txBody>
@@ -18224,7 +18201,7 @@
           <p:cNvPr id="21" name="">
             <a:extLst xmlns:a="http://schemas.openxmlformats.org/drawingml/2006/main">
               <a:ext uri="{FF2B5EF4-FFF2-40B4-BE49-F238E27FC236}">
-                <a16:creationId xmlns:a16="http://schemas.microsoft.com/office/drawing/2014/main" id="{805E3813-EFF4-4ACB-B792-FF73F6A7F04A}"/>
+                <a16:creationId xmlns:a16="http://schemas.microsoft.com/office/drawing/2014/main" id="{31E0A821-3D6B-494C-9FED-31E83429C4E9}"/>
               </a:ext>
             </a:extLst>
           </p:cNvPr>
@@ -18288,7 +18265,7 @@
           <p:cNvPr id="22" name="">
             <a:extLst xmlns:a="http://schemas.openxmlformats.org/drawingml/2006/main">
               <a:ext uri="{FF2B5EF4-FFF2-40B4-BE49-F238E27FC236}">
-                <a16:creationId xmlns:a16="http://schemas.microsoft.com/office/drawing/2014/main" id="{9C6A2E48-9F88-4302-8BAA-EE9D16B84D48}"/>
+                <a16:creationId xmlns:a16="http://schemas.microsoft.com/office/drawing/2014/main" id="{F79EE0A5-AD1A-44C9-B807-D5B0227C4ADE}"/>
               </a:ext>
             </a:extLst>
           </p:cNvPr>
@@ -18350,7 +18327,7 @@
     </p:spTree>
     <p:extLst>
       <p:ext uri="{BB962C8B-B14F-4D97-AF65-F5344CB8AC3E}">
-        <p14:creationId xmlns:p14="http://schemas.microsoft.com/office/powerpoint/2010/main" val="672326592"/>
+        <p14:creationId xmlns:p14="http://schemas.microsoft.com/office/powerpoint/2010/main" val="1362594866"/>
       </p:ext>
     </p:extLst>
   </p:cSld>
@@ -18374,7 +18351,7 @@
           <p:cNvPr id="1" name="">
             <a:extLst xmlns:a="http://schemas.openxmlformats.org/drawingml/2006/main">
               <a:ext uri="{FF2B5EF4-FFF2-40B4-BE49-F238E27FC236}">
-                <a16:creationId xmlns:a16="http://schemas.microsoft.com/office/drawing/2014/main" id="{686FD0DA-2A03-4E05-983A-D9B9C20E1D24}"/>
+                <a16:creationId xmlns:a16="http://schemas.microsoft.com/office/drawing/2014/main" id="{AFAD3B0A-0461-458D-A4D6-CF3A2E972AE2}"/>
               </a:ext>
             </a:extLst>
           </p:cNvPr>
@@ -18409,7 +18386,7 @@
           <p:cNvPr id="2" name="">
             <a:extLst xmlns:a="http://schemas.openxmlformats.org/drawingml/2006/main">
               <a:ext uri="{FF2B5EF4-FFF2-40B4-BE49-F238E27FC236}">
-                <a16:creationId xmlns:a16="http://schemas.microsoft.com/office/drawing/2014/main" id="{F263175F-A2B8-4BC2-A045-EB73ED6F0EBD}"/>
+                <a16:creationId xmlns:a16="http://schemas.microsoft.com/office/drawing/2014/main" id="{F0A9B2D1-D76C-49DF-8408-DA7485A09559}"/>
               </a:ext>
             </a:extLst>
           </p:cNvPr>
@@ -18473,7 +18450,7 @@
           <p:cNvPr id="3" name="">
             <a:extLst xmlns:a="http://schemas.openxmlformats.org/drawingml/2006/main">
               <a:ext uri="{FF2B5EF4-FFF2-40B4-BE49-F238E27FC236}">
-                <a16:creationId xmlns:a16="http://schemas.microsoft.com/office/drawing/2014/main" id="{0958F594-C1D1-428C-91B7-BBBBDC2B0290}"/>
+                <a16:creationId xmlns:a16="http://schemas.microsoft.com/office/drawing/2014/main" id="{A3AD4BD6-7CF9-4DF8-ADEE-7F50A5A305B9}"/>
               </a:ext>
             </a:extLst>
           </p:cNvPr>
@@ -18527,7 +18504,7 @@
                 <a:ea typeface="Microsoft YaHei"/>
                 <a:cs typeface="Microsoft YaHei"/>
               </a:rPr>
-              <a:t>这版项目就是把最初的大问题收敛成一个可复核的底稿 Workflow。</a:t>
+              <a:t>当前项目主线：跨境电商交易流水进入规则引擎和多 Agent 审计分析。</a:t>
             </a:r>
           </a:p>
         </p:txBody>
@@ -18537,7 +18514,7 @@
           <p:cNvPr id="4" name="">
             <a:extLst xmlns:a="http://schemas.openxmlformats.org/drawingml/2006/main">
               <a:ext uri="{FF2B5EF4-FFF2-40B4-BE49-F238E27FC236}">
-                <a16:creationId xmlns:a16="http://schemas.microsoft.com/office/drawing/2014/main" id="{234B299A-AEE8-4B03-B8C7-DD857485DE49}"/>
+                <a16:creationId xmlns:a16="http://schemas.microsoft.com/office/drawing/2014/main" id="{F38B9481-4384-467B-BAD6-CC7608967A1F}"/>
               </a:ext>
             </a:extLst>
           </p:cNvPr>
@@ -18601,7 +18578,7 @@
           <p:cNvPr id="5" name="">
             <a:extLst xmlns:a="http://schemas.openxmlformats.org/drawingml/2006/main">
               <a:ext uri="{FF2B5EF4-FFF2-40B4-BE49-F238E27FC236}">
-                <a16:creationId xmlns:a16="http://schemas.microsoft.com/office/drawing/2014/main" id="{8E223097-41C7-4C1D-B9AC-EE417542E12A}"/>
+                <a16:creationId xmlns:a16="http://schemas.microsoft.com/office/drawing/2014/main" id="{7DA1B9A6-D0FD-4BD6-954F-F0E004F93486}"/>
               </a:ext>
             </a:extLst>
           </p:cNvPr>
@@ -18636,7 +18613,7 @@
           <p:cNvPr id="6" name="">
             <a:extLst xmlns:a="http://schemas.openxmlformats.org/drawingml/2006/main">
               <a:ext uri="{FF2B5EF4-FFF2-40B4-BE49-F238E27FC236}">
-                <a16:creationId xmlns:a16="http://schemas.microsoft.com/office/drawing/2014/main" id="{DFFCE32A-AB79-4EDD-B3A8-22E06CA431C3}"/>
+                <a16:creationId xmlns:a16="http://schemas.microsoft.com/office/drawing/2014/main" id="{8BA83A4A-67EE-4A32-BDE5-B8114C427D03}"/>
               </a:ext>
             </a:extLst>
           </p:cNvPr>
@@ -18669,7 +18646,7 @@
           <p:cNvPr id="7" name="">
             <a:extLst xmlns:a="http://schemas.openxmlformats.org/drawingml/2006/main">
               <a:ext uri="{FF2B5EF4-FFF2-40B4-BE49-F238E27FC236}">
-                <a16:creationId xmlns:a16="http://schemas.microsoft.com/office/drawing/2014/main" id="{84B38729-6841-4D6A-B894-95D354BB87EC}"/>
+                <a16:creationId xmlns:a16="http://schemas.microsoft.com/office/drawing/2014/main" id="{38EFABB8-021F-4B61-9565-675C571017E3}"/>
               </a:ext>
             </a:extLst>
           </p:cNvPr>
@@ -18733,7 +18710,7 @@
           <p:cNvPr id="8" name="">
             <a:extLst xmlns:a="http://schemas.openxmlformats.org/drawingml/2006/main">
               <a:ext uri="{FF2B5EF4-FFF2-40B4-BE49-F238E27FC236}">
-                <a16:creationId xmlns:a16="http://schemas.microsoft.com/office/drawing/2014/main" id="{F22519FC-DA9D-4952-A1B5-F89B9578DE00}"/>
+                <a16:creationId xmlns:a16="http://schemas.microsoft.com/office/drawing/2014/main" id="{C08C6F1D-6605-4E22-8B1B-CD3B22E00A0E}"/>
               </a:ext>
             </a:extLst>
           </p:cNvPr>
@@ -18787,7 +18764,7 @@
                 <a:ea typeface="Microsoft YaHei"/>
                 <a:cs typeface="Microsoft YaHei"/>
               </a:rPr>
-              <a:t>材料包</a:t>
+              <a:t>数据输入</a:t>
             </a:r>
           </a:p>
         </p:txBody>
@@ -18797,7 +18774,7 @@
           <p:cNvPr id="9" name="">
             <a:extLst xmlns:a="http://schemas.openxmlformats.org/drawingml/2006/main">
               <a:ext uri="{FF2B5EF4-FFF2-40B4-BE49-F238E27FC236}">
-                <a16:creationId xmlns:a16="http://schemas.microsoft.com/office/drawing/2014/main" id="{F8698919-8D6B-4B3D-80EF-6B99CFB30EAB}"/>
+                <a16:creationId xmlns:a16="http://schemas.microsoft.com/office/drawing/2014/main" id="{BC693D6D-DA44-4417-9F5A-A036066A6650}"/>
               </a:ext>
             </a:extLst>
           </p:cNvPr>
@@ -18851,7 +18828,7 @@
                 <a:ea typeface="Microsoft YaHei"/>
                 <a:cs typeface="Microsoft YaHei"/>
               </a:rPr>
-              <a:t>合成案例/上传文件</a:t>
+              <a:t>演示/CSV</a:t>
             </a:r>
           </a:p>
         </p:txBody>
@@ -18861,7 +18838,7 @@
           <p:cNvPr id="10" name="">
             <a:extLst xmlns:a="http://schemas.openxmlformats.org/drawingml/2006/main">
               <a:ext uri="{FF2B5EF4-FFF2-40B4-BE49-F238E27FC236}">
-                <a16:creationId xmlns:a16="http://schemas.microsoft.com/office/drawing/2014/main" id="{6A8F9E5B-F669-40A3-8C52-70120D8406CE}"/>
+                <a16:creationId xmlns:a16="http://schemas.microsoft.com/office/drawing/2014/main" id="{E8872A40-74F4-4CEA-893E-7AE2FEBD8ABE}"/>
               </a:ext>
             </a:extLst>
           </p:cNvPr>
@@ -18925,7 +18902,7 @@
           <p:cNvPr id="11" name="">
             <a:extLst xmlns:a="http://schemas.openxmlformats.org/drawingml/2006/main">
               <a:ext uri="{FF2B5EF4-FFF2-40B4-BE49-F238E27FC236}">
-                <a16:creationId xmlns:a16="http://schemas.microsoft.com/office/drawing/2014/main" id="{8F8759CA-E5BC-4FBE-87B2-28F8136903A6}"/>
+                <a16:creationId xmlns:a16="http://schemas.microsoft.com/office/drawing/2014/main" id="{D4C3C591-311B-48CA-B479-72C973B57786}"/>
               </a:ext>
             </a:extLst>
           </p:cNvPr>
@@ -18958,7 +18935,7 @@
           <p:cNvPr id="12" name="">
             <a:extLst xmlns:a="http://schemas.openxmlformats.org/drawingml/2006/main">
               <a:ext uri="{FF2B5EF4-FFF2-40B4-BE49-F238E27FC236}">
-                <a16:creationId xmlns:a16="http://schemas.microsoft.com/office/drawing/2014/main" id="{69FD6ADE-00C2-4742-988C-4D278D07F763}"/>
+                <a16:creationId xmlns:a16="http://schemas.microsoft.com/office/drawing/2014/main" id="{EEEFE872-C0B6-4321-9E9C-BBB337672D8F}"/>
               </a:ext>
             </a:extLst>
           </p:cNvPr>
@@ -19022,7 +18999,7 @@
           <p:cNvPr id="13" name="">
             <a:extLst xmlns:a="http://schemas.openxmlformats.org/drawingml/2006/main">
               <a:ext uri="{FF2B5EF4-FFF2-40B4-BE49-F238E27FC236}">
-                <a16:creationId xmlns:a16="http://schemas.microsoft.com/office/drawing/2014/main" id="{12633DAB-08E0-410A-AB1E-676FCD0FAD87}"/>
+                <a16:creationId xmlns:a16="http://schemas.microsoft.com/office/drawing/2014/main" id="{6CADAA0E-5680-4730-89DD-C9FD3C485D2C}"/>
               </a:ext>
             </a:extLst>
           </p:cNvPr>
@@ -19076,7 +19053,7 @@
                 <a:ea typeface="Microsoft YaHei"/>
                 <a:cs typeface="Microsoft YaHei"/>
               </a:rPr>
-              <a:t>规则扫描</a:t>
+              <a:t>清洗评分</a:t>
             </a:r>
           </a:p>
         </p:txBody>
@@ -19086,7 +19063,7 @@
           <p:cNvPr id="14" name="">
             <a:extLst xmlns:a="http://schemas.openxmlformats.org/drawingml/2006/main">
               <a:ext uri="{FF2B5EF4-FFF2-40B4-BE49-F238E27FC236}">
-                <a16:creationId xmlns:a16="http://schemas.microsoft.com/office/drawing/2014/main" id="{ED4563E7-3EFD-4168-AFE3-543AA27CCE1C}"/>
+                <a16:creationId xmlns:a16="http://schemas.microsoft.com/office/drawing/2014/main" id="{B7E169BF-7F24-483B-ACA0-81B7E555DBD0}"/>
               </a:ext>
             </a:extLst>
           </p:cNvPr>
@@ -19140,7 +19117,7 @@
                 <a:ea typeface="Microsoft YaHei"/>
                 <a:cs typeface="Microsoft YaHei"/>
               </a:rPr>
-              <a:t>8 类跨境风险</a:t>
+              <a:t>质量控制</a:t>
             </a:r>
           </a:p>
         </p:txBody>
@@ -19150,7 +19127,7 @@
           <p:cNvPr id="15" name="">
             <a:extLst xmlns:a="http://schemas.openxmlformats.org/drawingml/2006/main">
               <a:ext uri="{FF2B5EF4-FFF2-40B4-BE49-F238E27FC236}">
-                <a16:creationId xmlns:a16="http://schemas.microsoft.com/office/drawing/2014/main" id="{C79F9DD9-9D83-4A31-8EC4-3DC0AD1187AF}"/>
+                <a16:creationId xmlns:a16="http://schemas.microsoft.com/office/drawing/2014/main" id="{12B91EE1-439B-482A-ACDF-FE68E084E055}"/>
               </a:ext>
             </a:extLst>
           </p:cNvPr>
@@ -19214,7 +19191,7 @@
           <p:cNvPr id="16" name="">
             <a:extLst xmlns:a="http://schemas.openxmlformats.org/drawingml/2006/main">
               <a:ext uri="{FF2B5EF4-FFF2-40B4-BE49-F238E27FC236}">
-                <a16:creationId xmlns:a16="http://schemas.microsoft.com/office/drawing/2014/main" id="{B4E961A7-A3E2-4866-8E52-C39047E52469}"/>
+                <a16:creationId xmlns:a16="http://schemas.microsoft.com/office/drawing/2014/main" id="{CFD5D1E4-C24D-4DCB-8570-ACC4A6EA39E5}"/>
               </a:ext>
             </a:extLst>
           </p:cNvPr>
@@ -19247,7 +19224,7 @@
           <p:cNvPr id="17" name="">
             <a:extLst xmlns:a="http://schemas.openxmlformats.org/drawingml/2006/main">
               <a:ext uri="{FF2B5EF4-FFF2-40B4-BE49-F238E27FC236}">
-                <a16:creationId xmlns:a16="http://schemas.microsoft.com/office/drawing/2014/main" id="{5D83135B-3291-4F34-8CD3-0AFD60920453}"/>
+                <a16:creationId xmlns:a16="http://schemas.microsoft.com/office/drawing/2014/main" id="{33E0580D-FAB3-4845-B5A5-9C09CA948E05}"/>
               </a:ext>
             </a:extLst>
           </p:cNvPr>
@@ -19311,7 +19288,7 @@
           <p:cNvPr id="18" name="">
             <a:extLst xmlns:a="http://schemas.openxmlformats.org/drawingml/2006/main">
               <a:ext uri="{FF2B5EF4-FFF2-40B4-BE49-F238E27FC236}">
-                <a16:creationId xmlns:a16="http://schemas.microsoft.com/office/drawing/2014/main" id="{06206DA6-C786-4CD2-9530-32DD31D3D561}"/>
+                <a16:creationId xmlns:a16="http://schemas.microsoft.com/office/drawing/2014/main" id="{4CDD340F-FEA2-4D80-B908-BB6933737561}"/>
               </a:ext>
             </a:extLst>
           </p:cNvPr>
@@ -19365,7 +19342,7 @@
                 <a:ea typeface="Microsoft YaHei"/>
                 <a:cs typeface="Microsoft YaHei"/>
               </a:rPr>
-              <a:t>RAG 证据</a:t>
+              <a:t>规则扫描</a:t>
             </a:r>
           </a:p>
         </p:txBody>
@@ -19375,7 +19352,7 @@
           <p:cNvPr id="19" name="">
             <a:extLst xmlns:a="http://schemas.openxmlformats.org/drawingml/2006/main">
               <a:ext uri="{FF2B5EF4-FFF2-40B4-BE49-F238E27FC236}">
-                <a16:creationId xmlns:a16="http://schemas.microsoft.com/office/drawing/2014/main" id="{EE331853-2FA8-4EFA-91FE-8226A3EF4B1D}"/>
+                <a16:creationId xmlns:a16="http://schemas.microsoft.com/office/drawing/2014/main" id="{E8D7A963-A106-4B2B-BE98-184A10E50B47}"/>
               </a:ext>
             </a:extLst>
           </p:cNvPr>
@@ -19429,7 +19406,7 @@
                 <a:ea typeface="Microsoft YaHei"/>
                 <a:cs typeface="Microsoft YaHei"/>
               </a:rPr>
-              <a:t>准则片段/fallback</a:t>
+              <a:t>8 类风险</a:t>
             </a:r>
           </a:p>
         </p:txBody>
@@ -19439,7 +19416,7 @@
           <p:cNvPr id="20" name="">
             <a:extLst xmlns:a="http://schemas.openxmlformats.org/drawingml/2006/main">
               <a:ext uri="{FF2B5EF4-FFF2-40B4-BE49-F238E27FC236}">
-                <a16:creationId xmlns:a16="http://schemas.microsoft.com/office/drawing/2014/main" id="{C11EAC8B-B487-4635-9DC3-E1B5F36EBD3A}"/>
+                <a16:creationId xmlns:a16="http://schemas.microsoft.com/office/drawing/2014/main" id="{8EB8998A-B56E-400A-A3DE-85A7C786097D}"/>
               </a:ext>
             </a:extLst>
           </p:cNvPr>
@@ -19503,7 +19480,7 @@
           <p:cNvPr id="21" name="">
             <a:extLst xmlns:a="http://schemas.openxmlformats.org/drawingml/2006/main">
               <a:ext uri="{FF2B5EF4-FFF2-40B4-BE49-F238E27FC236}">
-                <a16:creationId xmlns:a16="http://schemas.microsoft.com/office/drawing/2014/main" id="{91BB0D8E-9202-4080-8783-951A6DC146BA}"/>
+                <a16:creationId xmlns:a16="http://schemas.microsoft.com/office/drawing/2014/main" id="{59560190-D47D-4E8D-A948-8ADB80272D29}"/>
               </a:ext>
             </a:extLst>
           </p:cNvPr>
@@ -19536,7 +19513,7 @@
           <p:cNvPr id="22" name="">
             <a:extLst xmlns:a="http://schemas.openxmlformats.org/drawingml/2006/main">
               <a:ext uri="{FF2B5EF4-FFF2-40B4-BE49-F238E27FC236}">
-                <a16:creationId xmlns:a16="http://schemas.microsoft.com/office/drawing/2014/main" id="{74C32E43-C087-43F0-833C-1E878CE2DF19}"/>
+                <a16:creationId xmlns:a16="http://schemas.microsoft.com/office/drawing/2014/main" id="{26667C95-F56E-41D2-97E8-670CD62E2B54}"/>
               </a:ext>
             </a:extLst>
           </p:cNvPr>
@@ -19600,7 +19577,7 @@
           <p:cNvPr id="23" name="">
             <a:extLst xmlns:a="http://schemas.openxmlformats.org/drawingml/2006/main">
               <a:ext uri="{FF2B5EF4-FFF2-40B4-BE49-F238E27FC236}">
-                <a16:creationId xmlns:a16="http://schemas.microsoft.com/office/drawing/2014/main" id="{B1BDD5FD-8C25-4251-A452-4E9D5ED9E197}"/>
+                <a16:creationId xmlns:a16="http://schemas.microsoft.com/office/drawing/2014/main" id="{63331DC0-B5EC-477F-A076-C5773C8EFEBC}"/>
               </a:ext>
             </a:extLst>
           </p:cNvPr>
@@ -19654,7 +19631,7 @@
                 <a:ea typeface="Microsoft YaHei"/>
                 <a:cs typeface="Microsoft YaHei"/>
               </a:rPr>
-              <a:t>三 Agent</a:t>
+              <a:t>AI 分析</a:t>
             </a:r>
           </a:p>
         </p:txBody>
@@ -19664,7 +19641,7 @@
           <p:cNvPr id="24" name="">
             <a:extLst xmlns:a="http://schemas.openxmlformats.org/drawingml/2006/main">
               <a:ext uri="{FF2B5EF4-FFF2-40B4-BE49-F238E27FC236}">
-                <a16:creationId xmlns:a16="http://schemas.microsoft.com/office/drawing/2014/main" id="{47162703-CA3B-475C-BE61-01F65E1A9CE2}"/>
+                <a16:creationId xmlns:a16="http://schemas.microsoft.com/office/drawing/2014/main" id="{7C028EFE-8A7E-482F-885B-99E94B778EDD}"/>
               </a:ext>
             </a:extLst>
           </p:cNvPr>
@@ -19718,7 +19695,7 @@
                 <a:ea typeface="Microsoft YaHei"/>
                 <a:cs typeface="Microsoft YaHei"/>
               </a:rPr>
-              <a:t>提取/合规/复核</a:t>
+              <a:t>DeepSeek/mock</a:t>
             </a:r>
           </a:p>
         </p:txBody>
@@ -19728,7 +19705,7 @@
           <p:cNvPr id="25" name="">
             <a:extLst xmlns:a="http://schemas.openxmlformats.org/drawingml/2006/main">
               <a:ext uri="{FF2B5EF4-FFF2-40B4-BE49-F238E27FC236}">
-                <a16:creationId xmlns:a16="http://schemas.microsoft.com/office/drawing/2014/main" id="{DE334D23-7C69-4DBB-92E6-D86BBECC7A6E}"/>
+                <a16:creationId xmlns:a16="http://schemas.microsoft.com/office/drawing/2014/main" id="{9D7598E6-9BF5-48CE-96C4-4649EEF4F8B0}"/>
               </a:ext>
             </a:extLst>
           </p:cNvPr>
@@ -19792,7 +19769,7 @@
           <p:cNvPr id="26" name="">
             <a:extLst xmlns:a="http://schemas.openxmlformats.org/drawingml/2006/main">
               <a:ext uri="{FF2B5EF4-FFF2-40B4-BE49-F238E27FC236}">
-                <a16:creationId xmlns:a16="http://schemas.microsoft.com/office/drawing/2014/main" id="{B1C746E5-23BE-4FCC-AAEF-51CB6EA0A740}"/>
+                <a16:creationId xmlns:a16="http://schemas.microsoft.com/office/drawing/2014/main" id="{D53CE1EA-9BFB-4945-BFE0-96E4B14CAE9C}"/>
               </a:ext>
             </a:extLst>
           </p:cNvPr>
@@ -19825,7 +19802,7 @@
           <p:cNvPr id="27" name="">
             <a:extLst xmlns:a="http://schemas.openxmlformats.org/drawingml/2006/main">
               <a:ext uri="{FF2B5EF4-FFF2-40B4-BE49-F238E27FC236}">
-                <a16:creationId xmlns:a16="http://schemas.microsoft.com/office/drawing/2014/main" id="{0FAD0503-DD5F-4443-B238-9502A874BD03}"/>
+                <a16:creationId xmlns:a16="http://schemas.microsoft.com/office/drawing/2014/main" id="{C3AF086F-9DE9-49F2-8282-BF066A322426}"/>
               </a:ext>
             </a:extLst>
           </p:cNvPr>
@@ -19889,7 +19866,7 @@
           <p:cNvPr id="28" name="">
             <a:extLst xmlns:a="http://schemas.openxmlformats.org/drawingml/2006/main">
               <a:ext uri="{FF2B5EF4-FFF2-40B4-BE49-F238E27FC236}">
-                <a16:creationId xmlns:a16="http://schemas.microsoft.com/office/drawing/2014/main" id="{751D4D44-4C88-454E-B159-D00944070397}"/>
+                <a16:creationId xmlns:a16="http://schemas.microsoft.com/office/drawing/2014/main" id="{B39CE6B3-1E96-4DDF-8FBF-6EFC5823E54A}"/>
               </a:ext>
             </a:extLst>
           </p:cNvPr>
@@ -19943,7 +19920,7 @@
                 <a:ea typeface="Microsoft YaHei"/>
                 <a:cs typeface="Microsoft YaHei"/>
               </a:rPr>
-              <a:t>底稿输出</a:t>
+              <a:t>报告输出</a:t>
             </a:r>
           </a:p>
         </p:txBody>
@@ -19953,7 +19930,7 @@
           <p:cNvPr id="29" name="">
             <a:extLst xmlns:a="http://schemas.openxmlformats.org/drawingml/2006/main">
               <a:ext uri="{FF2B5EF4-FFF2-40B4-BE49-F238E27FC236}">
-                <a16:creationId xmlns:a16="http://schemas.microsoft.com/office/drawing/2014/main" id="{0CC53062-1A86-4CC4-865C-07504BD51267}"/>
+                <a16:creationId xmlns:a16="http://schemas.microsoft.com/office/drawing/2014/main" id="{8B0A1251-FFE8-4768-AEB1-9868B53E9935}"/>
               </a:ext>
             </a:extLst>
           </p:cNvPr>
@@ -20007,7 +19984,7 @@
                 <a:ea typeface="Microsoft YaHei"/>
                 <a:cs typeface="Microsoft YaHei"/>
               </a:rPr>
-              <a:t>Excel/Markdown</a:t>
+              <a:t>Markdown/CSV</a:t>
             </a:r>
           </a:p>
         </p:txBody>
@@ -20017,7 +19994,7 @@
           <p:cNvPr id="30" name="">
             <a:extLst xmlns:a="http://schemas.openxmlformats.org/drawingml/2006/main">
               <a:ext uri="{FF2B5EF4-FFF2-40B4-BE49-F238E27FC236}">
-                <a16:creationId xmlns:a16="http://schemas.microsoft.com/office/drawing/2014/main" id="{A8D47117-3D57-4FA5-9DFF-C32BE976C8CB}"/>
+                <a16:creationId xmlns:a16="http://schemas.microsoft.com/office/drawing/2014/main" id="{06404D50-2871-4530-9358-D1E13FF85090}"/>
               </a:ext>
             </a:extLst>
           </p:cNvPr>
@@ -20081,7 +20058,7 @@
           <p:cNvPr id="31" name="">
             <a:extLst xmlns:a="http://schemas.openxmlformats.org/drawingml/2006/main">
               <a:ext uri="{FF2B5EF4-FFF2-40B4-BE49-F238E27FC236}">
-                <a16:creationId xmlns:a16="http://schemas.microsoft.com/office/drawing/2014/main" id="{3407F5F9-4A48-412B-924F-C703F23401E3}"/>
+                <a16:creationId xmlns:a16="http://schemas.microsoft.com/office/drawing/2014/main" id="{31D3A557-68DA-4177-91DF-DA6E31558724}"/>
               </a:ext>
             </a:extLst>
           </p:cNvPr>
@@ -20114,7 +20091,7 @@
           <p:cNvPr id="32" name="">
             <a:extLst xmlns:a="http://schemas.openxmlformats.org/drawingml/2006/main">
               <a:ext uri="{FF2B5EF4-FFF2-40B4-BE49-F238E27FC236}">
-                <a16:creationId xmlns:a16="http://schemas.microsoft.com/office/drawing/2014/main" id="{2EC3A15A-3B0F-4497-8AEB-E6369E0D60A6}"/>
+                <a16:creationId xmlns:a16="http://schemas.microsoft.com/office/drawing/2014/main" id="{D6BAC387-0801-4D66-970C-E2060D8CE544}"/>
               </a:ext>
             </a:extLst>
           </p:cNvPr>
@@ -20178,7 +20155,7 @@
           <p:cNvPr id="33" name="">
             <a:extLst xmlns:a="http://schemas.openxmlformats.org/drawingml/2006/main">
               <a:ext uri="{FF2B5EF4-FFF2-40B4-BE49-F238E27FC236}">
-                <a16:creationId xmlns:a16="http://schemas.microsoft.com/office/drawing/2014/main" id="{544180C4-5693-4329-824C-CAB92F11036F}"/>
+                <a16:creationId xmlns:a16="http://schemas.microsoft.com/office/drawing/2014/main" id="{4A2EB9BE-C71C-483D-A8A7-C70B630079BC}"/>
               </a:ext>
             </a:extLst>
           </p:cNvPr>
@@ -20242,7 +20219,7 @@
           <p:cNvPr id="34" name="">
             <a:extLst xmlns:a="http://schemas.openxmlformats.org/drawingml/2006/main">
               <a:ext uri="{FF2B5EF4-FFF2-40B4-BE49-F238E27FC236}">
-                <a16:creationId xmlns:a16="http://schemas.microsoft.com/office/drawing/2014/main" id="{02350E0E-83D0-4613-BBC3-1C9F4DBE2296}"/>
+                <a16:creationId xmlns:a16="http://schemas.microsoft.com/office/drawing/2014/main" id="{43C4B6CA-027F-4F23-B9D7-D1768934D6FC}"/>
               </a:ext>
             </a:extLst>
           </p:cNvPr>
@@ -20296,7 +20273,7 @@
                 <a:ea typeface="Microsoft YaHei"/>
                 <a:cs typeface="Microsoft YaHei"/>
               </a:rPr>
-              <a:t>证据缺口留痕</a:t>
+              <a:t>高风险留痕</a:t>
             </a:r>
           </a:p>
         </p:txBody>
@@ -20310,13 +20287,13 @@
           <p:nvPr/>
         </p:nvPicPr>
         <p:blipFill>
-          <a:blip xmlns:r="http://schemas.openxmlformats.org/officeDocument/2006/relationships" xmlns:a="http://schemas.openxmlformats.org/drawingml/2006/main" r:embed="Rf54f2a3f34b24693"/>
+          <a:blip xmlns:r="http://schemas.openxmlformats.org/officeDocument/2006/relationships" xmlns:a="http://schemas.openxmlformats.org/drawingml/2006/main" r:embed="R5f52f88055cb4981"/>
           <a:stretch xmlns:a="http://schemas.openxmlformats.org/drawingml/2006/main"/>
         </p:blipFill>
         <p:spPr>
           <a:xfrm xmlns:a="http://schemas.openxmlformats.org/drawingml/2006/main">
-            <a:off x="1857375" y="3676650"/>
-            <a:ext cx="2133600" cy="2000250"/>
+            <a:off x="1323975" y="3676650"/>
+            <a:ext cx="3200400" cy="2000250"/>
           </a:xfrm>
           <a:prstGeom xmlns:a="http://schemas.openxmlformats.org/drawingml/2006/main" prst="rect">
             <a:avLst/>
@@ -20328,7 +20305,7 @@
           <p:cNvPr id="36" name="">
             <a:extLst xmlns:a="http://schemas.openxmlformats.org/drawingml/2006/main">
               <a:ext uri="{FF2B5EF4-FFF2-40B4-BE49-F238E27FC236}">
-                <a16:creationId xmlns:a16="http://schemas.microsoft.com/office/drawing/2014/main" id="{54F6E244-359A-4C89-9F23-D3E98C32AF06}"/>
+                <a16:creationId xmlns:a16="http://schemas.microsoft.com/office/drawing/2014/main" id="{95E31B73-30EC-47B1-A60F-C2B61D521BD3}"/>
               </a:ext>
             </a:extLst>
           </p:cNvPr>
@@ -20361,7 +20338,7 @@
           <p:cNvPr id="37" name="">
             <a:extLst xmlns:a="http://schemas.openxmlformats.org/drawingml/2006/main">
               <a:ext uri="{FF2B5EF4-FFF2-40B4-BE49-F238E27FC236}">
-                <a16:creationId xmlns:a16="http://schemas.microsoft.com/office/drawing/2014/main" id="{8C002322-C8FA-4B98-A1E5-ECD221B97063}"/>
+                <a16:creationId xmlns:a16="http://schemas.microsoft.com/office/drawing/2014/main" id="{591E5927-B3F2-4719-AAFB-EE84FA70D8A0}"/>
               </a:ext>
             </a:extLst>
           </p:cNvPr>
@@ -20425,7 +20402,7 @@
           <p:cNvPr id="38" name="">
             <a:extLst xmlns:a="http://schemas.openxmlformats.org/drawingml/2006/main">
               <a:ext uri="{FF2B5EF4-FFF2-40B4-BE49-F238E27FC236}">
-                <a16:creationId xmlns:a16="http://schemas.microsoft.com/office/drawing/2014/main" id="{D24694C4-AB12-4AC0-BE4C-D7D5BCE66107}"/>
+                <a16:creationId xmlns:a16="http://schemas.microsoft.com/office/drawing/2014/main" id="{766EB3F3-4E89-444F-9CD7-4E81A226F350}"/>
               </a:ext>
             </a:extLst>
           </p:cNvPr>
@@ -20489,7 +20466,7 @@
           <p:cNvPr id="39" name="">
             <a:extLst xmlns:a="http://schemas.openxmlformats.org/drawingml/2006/main">
               <a:ext uri="{FF2B5EF4-FFF2-40B4-BE49-F238E27FC236}">
-                <a16:creationId xmlns:a16="http://schemas.microsoft.com/office/drawing/2014/main" id="{3D12B9E2-1E20-413A-A1E6-D1E2478CE5B6}"/>
+                <a16:creationId xmlns:a16="http://schemas.microsoft.com/office/drawing/2014/main" id="{0BF0C131-900B-4F60-8C9F-839FAE0A6391}"/>
               </a:ext>
             </a:extLst>
           </p:cNvPr>
@@ -20553,7 +20530,7 @@
           <p:cNvPr id="40" name="">
             <a:extLst xmlns:a="http://schemas.openxmlformats.org/drawingml/2006/main">
               <a:ext uri="{FF2B5EF4-FFF2-40B4-BE49-F238E27FC236}">
-                <a16:creationId xmlns:a16="http://schemas.microsoft.com/office/drawing/2014/main" id="{F14C60B8-45DF-49E1-B315-3F7AEFEFA396}"/>
+                <a16:creationId xmlns:a16="http://schemas.microsoft.com/office/drawing/2014/main" id="{C60F9761-A413-4E97-948F-39326ABD82DF}"/>
               </a:ext>
             </a:extLst>
           </p:cNvPr>
@@ -20586,7 +20563,7 @@
           <p:cNvPr id="41" name="">
             <a:extLst xmlns:a="http://schemas.openxmlformats.org/drawingml/2006/main">
               <a:ext uri="{FF2B5EF4-FFF2-40B4-BE49-F238E27FC236}">
-                <a16:creationId xmlns:a16="http://schemas.microsoft.com/office/drawing/2014/main" id="{5106AF80-ADC8-4D38-9DF8-D1D7FA6791CD}"/>
+                <a16:creationId xmlns:a16="http://schemas.microsoft.com/office/drawing/2014/main" id="{D14E32E6-A5DE-40BE-9493-EFF2EE656752}"/>
               </a:ext>
             </a:extLst>
           </p:cNvPr>
@@ -20650,7 +20627,7 @@
           <p:cNvPr id="42" name="">
             <a:extLst xmlns:a="http://schemas.openxmlformats.org/drawingml/2006/main">
               <a:ext uri="{FF2B5EF4-FFF2-40B4-BE49-F238E27FC236}">
-                <a16:creationId xmlns:a16="http://schemas.microsoft.com/office/drawing/2014/main" id="{91C17213-A947-4AE8-B454-CFE63BD29707}"/>
+                <a16:creationId xmlns:a16="http://schemas.microsoft.com/office/drawing/2014/main" id="{FF68580A-8F8A-4F30-B9F9-6648F1B348B4}"/>
               </a:ext>
             </a:extLst>
           </p:cNvPr>
@@ -20714,7 +20691,7 @@
           <p:cNvPr id="43" name="">
             <a:extLst xmlns:a="http://schemas.openxmlformats.org/drawingml/2006/main">
               <a:ext uri="{FF2B5EF4-FFF2-40B4-BE49-F238E27FC236}">
-                <a16:creationId xmlns:a16="http://schemas.microsoft.com/office/drawing/2014/main" id="{2B7E31DB-B1B9-4097-AE11-18F7C25511FC}"/>
+                <a16:creationId xmlns:a16="http://schemas.microsoft.com/office/drawing/2014/main" id="{9BED01AB-AC72-450A-9453-C6CBEA4A8DB4}"/>
               </a:ext>
             </a:extLst>
           </p:cNvPr>
@@ -20778,7 +20755,7 @@
           <p:cNvPr id="44" name="">
             <a:extLst xmlns:a="http://schemas.openxmlformats.org/drawingml/2006/main">
               <a:ext uri="{FF2B5EF4-FFF2-40B4-BE49-F238E27FC236}">
-                <a16:creationId xmlns:a16="http://schemas.microsoft.com/office/drawing/2014/main" id="{8B429CB9-5B07-423B-A78F-2401EF1F4F9B}"/>
+                <a16:creationId xmlns:a16="http://schemas.microsoft.com/office/drawing/2014/main" id="{5DDC6C28-212F-479F-AA23-0B9C4996E3C9}"/>
               </a:ext>
             </a:extLst>
           </p:cNvPr>
@@ -20811,7 +20788,7 @@
           <p:cNvPr id="45" name="">
             <a:extLst xmlns:a="http://schemas.openxmlformats.org/drawingml/2006/main">
               <a:ext uri="{FF2B5EF4-FFF2-40B4-BE49-F238E27FC236}">
-                <a16:creationId xmlns:a16="http://schemas.microsoft.com/office/drawing/2014/main" id="{C0BA5EDB-1CF3-4BF5-AEDE-35E16491D030}"/>
+                <a16:creationId xmlns:a16="http://schemas.microsoft.com/office/drawing/2014/main" id="{8B1F31B9-BD87-4F9C-9F23-81D1CC5680B7}"/>
               </a:ext>
             </a:extLst>
           </p:cNvPr>
@@ -20865,7 +20842,7 @@
                 <a:ea typeface="Microsoft YaHei"/>
                 <a:cs typeface="Microsoft YaHei"/>
               </a:rPr>
-              <a:t>Cell Map</a:t>
+              <a:t>Report</a:t>
             </a:r>
           </a:p>
         </p:txBody>
@@ -20875,7 +20852,7 @@
           <p:cNvPr id="46" name="">
             <a:extLst xmlns:a="http://schemas.openxmlformats.org/drawingml/2006/main">
               <a:ext uri="{FF2B5EF4-FFF2-40B4-BE49-F238E27FC236}">
-                <a16:creationId xmlns:a16="http://schemas.microsoft.com/office/drawing/2014/main" id="{4BE9D35B-7E9F-4002-B090-9F7F8C783BA9}"/>
+                <a16:creationId xmlns:a16="http://schemas.microsoft.com/office/drawing/2014/main" id="{187045E7-6DF2-4E56-A833-445338D9BC3F}"/>
               </a:ext>
             </a:extLst>
           </p:cNvPr>
@@ -20929,7 +20906,7 @@
                 <a:ea typeface="Microsoft YaHei"/>
                 <a:cs typeface="Microsoft YaHei"/>
               </a:rPr>
-              <a:t>公式区保护</a:t>
+              <a:t>审计报告</a:t>
             </a:r>
           </a:p>
         </p:txBody>
@@ -20939,7 +20916,7 @@
           <p:cNvPr id="47" name="">
             <a:extLst xmlns:a="http://schemas.openxmlformats.org/drawingml/2006/main">
               <a:ext uri="{FF2B5EF4-FFF2-40B4-BE49-F238E27FC236}">
-                <a16:creationId xmlns:a16="http://schemas.microsoft.com/office/drawing/2014/main" id="{C01A9EBF-BB10-44AD-9D3D-3FC5DFAEE958}"/>
+                <a16:creationId xmlns:a16="http://schemas.microsoft.com/office/drawing/2014/main" id="{A7492293-118C-459F-8302-F5E64F773C6B}"/>
               </a:ext>
             </a:extLst>
           </p:cNvPr>
@@ -20993,7 +20970,7 @@
                 <a:ea typeface="Microsoft YaHei"/>
                 <a:cs typeface="Microsoft YaHei"/>
               </a:rPr>
-              <a:t>只写入模板可填区域</a:t>
+              <a:t>风险清单 + 图表 + 叙述</a:t>
             </a:r>
           </a:p>
         </p:txBody>
@@ -21003,7 +20980,7 @@
           <p:cNvPr id="48" name="">
             <a:extLst xmlns:a="http://schemas.openxmlformats.org/drawingml/2006/main">
               <a:ext uri="{FF2B5EF4-FFF2-40B4-BE49-F238E27FC236}">
-                <a16:creationId xmlns:a16="http://schemas.microsoft.com/office/drawing/2014/main" id="{039F8535-7CE9-45E2-9AC0-C4BE4A7C66C8}"/>
+                <a16:creationId xmlns:a16="http://schemas.microsoft.com/office/drawing/2014/main" id="{CC4783CD-CD79-407A-A893-00C4FAD0A064}"/>
               </a:ext>
             </a:extLst>
           </p:cNvPr>
@@ -21067,7 +21044,7 @@
           <p:cNvPr id="49" name="">
             <a:extLst xmlns:a="http://schemas.openxmlformats.org/drawingml/2006/main">
               <a:ext uri="{FF2B5EF4-FFF2-40B4-BE49-F238E27FC236}">
-                <a16:creationId xmlns:a16="http://schemas.microsoft.com/office/drawing/2014/main" id="{47908121-2D4C-4C68-B14D-519A6EC2093D}"/>
+                <a16:creationId xmlns:a16="http://schemas.microsoft.com/office/drawing/2014/main" id="{E64AEEF7-6251-4354-8A47-A8EE7A7D6CA5}"/>
               </a:ext>
             </a:extLst>
           </p:cNvPr>
@@ -21129,7 +21106,7 @@
     </p:spTree>
     <p:extLst>
       <p:ext uri="{BB962C8B-B14F-4D97-AF65-F5344CB8AC3E}">
-        <p14:creationId xmlns:p14="http://schemas.microsoft.com/office/powerpoint/2010/main" val="1382969062"/>
+        <p14:creationId xmlns:p14="http://schemas.microsoft.com/office/powerpoint/2010/main" val="393992738"/>
       </p:ext>
     </p:extLst>
   </p:cSld>

</xml_diff>